<commit_message>
feat(ooad): add S03 static model session and revise S01/S02
- S03 정적 모델: domain model positioning, data modeling (ERD) linkage,
  attribute domains and attribute-level rules, static-modeling wrong practices
- S02: event-centric requirements, iterative approaches, AI-era requirements,
  knowledge/uncertainty cases, use case positioning and levels, wrong
  practices; order case restructured into "주문을 관리한다" (CRUD as one
  use case with alternative flows) and an independent delivery-status use case
- S01: common misconceptions topic, exact session-name references
- course-design: S02/S03 outlines and shared case terms aligned
- rendered decks refreshed; S01 baseline counts in tests updated (26 topics)

Co-Authored-By: Claude Opus 5.5 <noreply@anthropic.com>
</commit_message>
<xml_diff>
--- a/courses/ooad/sessions/s01.pptx
+++ b/courses/ooad/sessions/s01.pptx
@@ -34,6 +34,7 @@
     <p:sldId id="279" r:id="javaLecture24"/>
     <p:sldId id="280" r:id="javaLecture25"/>
     <p:sldId id="281" r:id="javaLecture26"/>
+    <p:sldId id="282" r:id="javaLecture27"/>
   </p:sldIdLst>
   <p:sldSz cx="9144000" cy="6858000" type="screen4x3"/>
   <p:notesSz cx="6858000" cy="9144000"/>
@@ -781,7 +782,7 @@
             <a:pPr lvl="0"/>
             <a:r>
               <a:rPr lang="ko-KR" sz="1200"/>
-              <a:t>S03·S04에서 의미를 분석하고 S06·S07에서 설계 판단으로 연결한다.</a:t>
+              <a:t>"03. 정적 모델 — 도메인 개념과 관계"·"04. 동적 모델 — 상호작용과 상태"에서 의미를 분석하고 "06. 분석 모델에서 설계 모델로"·"07. 책임·협력·계약"에서 설계 판단으로 연결한다.</a:t>
             </a:r>
           </a:p>
         </p:txBody>
@@ -1393,28 +1394,14 @@
             <a:pPr lvl="0"/>
             <a:r>
               <a:rPr lang="ko-KR" sz="1200"/>
-              <a:t>도메인 주도 설계를 객체지향 분석·설계의 대체재로 설명하지 않는다.</a:t>
+              <a:t>각 오해는 앞 topic과 연결된다: UML(13), 분석의 목적(10), 기계적 전환(17), 메시지와 협력(15·16), 기술과 본질(08·09), 적정성과 피드백(18·19).</a:t>
             </a:r>
           </a:p>
           <a:p>
             <a:pPr lvl="0"/>
             <a:r>
               <a:rPr lang="ko-KR" sz="1200"/>
-              <a:t>이 과정에서는 객체지향 설계를 기반으로 DDD와 연결한다. DDD 전체를 특정 프로그래밍 패러다임에 한정하는 정의는 아니다.</a:t>
-            </a:r>
-          </a:p>
-          <a:p>
-            <a:pPr lvl="0"/>
-            <a:r>
-              <a:rPr lang="ko-KR" sz="1200"/>
-              <a:t>전략적 설계와 전술적 설계의 차이는 개괄 수준에서만 소개한다.</a:t>
-            </a:r>
-          </a:p>
-          <a:p>
-            <a:pPr lvl="0"/>
-            <a:r>
-              <a:rPr lang="ko-KR" sz="1200"/>
-              <a:t>위 인용문은 Eric Evans, *Domain-Driven Design*(Final Manuscript, 2003-04-15), Part II 서두(p.48)에서 직접 확인했다.</a:t>
+              <a:t>요구 분석의 잘못된 관행은 "02. 요구 분석과 유스케이스", 정적 모델링의 잘못된 관행은 "03. 정적 모델 — 도메인 개념과 관계", 패턴의 선택적 적용은 "08. 변화 대응과 변이 설계"에서 다룬다.</a:t>
             </a:r>
           </a:p>
         </p:txBody>
@@ -1475,14 +1462,28 @@
             <a:pPr lvl="0"/>
             <a:r>
               <a:rPr lang="ko-KR" sz="1200"/>
-              <a:t>위 관계는 이 과정의 교육용 연결이다. Gruber가 OOAD→DDD→온톨로지 순서를 제안했다는 의미가 아니다.</a:t>
+              <a:t>도메인 주도 설계를 객체지향 분석·설계의 대체재로 설명하지 않는다.</a:t>
             </a:r>
           </a:p>
           <a:p>
             <a:pPr lvl="0"/>
             <a:r>
               <a:rPr lang="ko-KR" sz="1200"/>
-              <a:t>LLM에 모델을 제공하는 것만으로 동일한 해석이 보장되지는 않는다. 구체적인 사례와 검증으로 확인한다.</a:t>
+              <a:t>이 과정에서는 객체지향 설계를 기반으로 DDD와 연결한다. DDD 전체를 특정 프로그래밍 패러다임에 한정하는 정의는 아니다.</a:t>
+            </a:r>
+          </a:p>
+          <a:p>
+            <a:pPr lvl="0"/>
+            <a:r>
+              <a:rPr lang="ko-KR" sz="1200"/>
+              <a:t>전략적 설계와 전술적 설계의 차이는 개괄 수준에서만 소개한다.</a:t>
+            </a:r>
+          </a:p>
+          <a:p>
+            <a:pPr lvl="0"/>
+            <a:r>
+              <a:rPr lang="ko-KR" sz="1200"/>
+              <a:t>위 인용문은 Eric Evans, *Domain-Driven Design*(Final Manuscript, 2003-04-15), Part II 서두(p.48)에서 직접 확인했다.</a:t>
             </a:r>
           </a:p>
         </p:txBody>
@@ -1543,35 +1544,14 @@
             <a:pPr lvl="0"/>
             <a:r>
               <a:rPr lang="ko-KR" sz="1200"/>
-              <a:t>세 영역은 절대적인 기술 경계가 아니라 주도권과 책임의 구분이다.</a:t>
+              <a:t>위 관계는 이 과정의 교육용 연결이다. Gruber가 OOAD→DDD→온톨로지 순서를 제안했다는 의미가 아니다.</a:t>
             </a:r>
           </a:p>
           <a:p>
             <a:pPr lvl="0"/>
             <a:r>
               <a:rPr lang="ko-KR" sz="1200"/>
-              <a:t>인간이 최종 책임진다는 것은 모든 산출물을 직접 작성한다는 뜻이 아니다.</a:t>
-            </a:r>
-          </a:p>
-          <a:p>
-            <a:pPr lvl="0"/>
-            <a:r>
-              <a:rPr lang="ko-KR" sz="1200"/>
-              <a:t>AI 중심 실행은 충분한 맥락·제약·명세·검증을 전제로 한다.</a:t>
-            </a:r>
-          </a:p>
-          <a:p>
-            <a:pPr lvl="0"/>
-            <a:r>
-              <a:rPr lang="ko-KR" sz="1200"/>
-              <a:t>도메인 모델·온톨로지와 아키텍처·설계는 함께 진화한다.</a:t>
-            </a:r>
-          </a:p>
-          <a:p>
-            <a:pPr lvl="0"/>
-            <a:r>
-              <a:rPr lang="ko-KR" sz="1200"/>
-              <a:t>객체지향 분석·설계는 사라지지 않으며 인간과 AI의 협업 방식으로 수행된다.</a:t>
+              <a:t>LLM에 모델을 제공하는 것만으로 동일한 해석이 보장되지는 않는다. 구체적인 사례와 검증으로 확인한다.</a:t>
             </a:r>
           </a:p>
         </p:txBody>
@@ -1632,21 +1612,35 @@
             <a:pPr lvl="0"/>
             <a:r>
               <a:rPr lang="ko-KR" sz="1200"/>
-              <a:t>개인 판단 → 2~3인 근거 비교 → 전체 검토 순서로 진행한다. 시간은 전체 SA 완성 후 운영 계획에서 정한다.</a:t>
+              <a:t>세 영역은 절대적인 기술 경계가 아니라 주도권과 책임의 구분이다.</a:t>
             </a:r>
           </a:p>
           <a:p>
             <a:pPr lvl="0"/>
             <a:r>
               <a:rPr lang="ko-KR" sz="1200"/>
-              <a:t>객체 설계나 UML 작성까지 요구하지 않는다.</a:t>
+              <a:t>인간이 최종 책임진다는 것은 모든 산출물을 직접 작성한다는 뜻이 아니다.</a:t>
             </a:r>
           </a:p>
           <a:p>
             <a:pPr lvl="0"/>
             <a:r>
               <a:rPr lang="ko-KR" sz="1200"/>
-              <a:t>평가 기준: 네 항목의 수준 구분이 정확한지, 조건과 추정을 분리했는지, 취소 버튼 이외의 대안도 검토했는지, 확인 질문이 가설의 참·거짓을 가릴 수 있는지.</a:t>
+              <a:t>AI 중심 실행은 충분한 맥락·제약·명세·검증을 전제로 한다.</a:t>
+            </a:r>
+          </a:p>
+          <a:p>
+            <a:pPr lvl="0"/>
+            <a:r>
+              <a:rPr lang="ko-KR" sz="1200"/>
+              <a:t>도메인 모델·온톨로지와 아키텍처·설계는 함께 진화한다.</a:t>
+            </a:r>
+          </a:p>
+          <a:p>
+            <a:pPr lvl="0"/>
+            <a:r>
+              <a:rPr lang="ko-KR" sz="1200"/>
+              <a:t>객체지향 분석·설계는 사라지지 않으며 인간과 AI의 협업 방식으로 수행된다.</a:t>
             </a:r>
           </a:p>
         </p:txBody>
@@ -1707,14 +1701,21 @@
             <a:pPr lvl="0"/>
             <a:r>
               <a:rPr lang="ko-KR" sz="1200"/>
-              <a:t>특정 문장 하나보다 각 항목의 수준과 사실·가정을 구분했는지가 중요하다.</a:t>
+              <a:t>개인 판단 → 2~3인 근거 비교 → 전체 검토 순서로 진행한다. 시간은 전체 SA 완성 후 운영 계획에서 정한다.</a:t>
             </a:r>
           </a:p>
           <a:p>
             <a:pPr lvl="0"/>
             <a:r>
               <a:rPr lang="ko-KR" sz="1200"/>
-              <a:t>같은 요구사항을 만족시키는 해결책은 여러 개일 수 있다.</a:t>
+              <a:t>객체 설계나 UML 작성까지 요구하지 않는다.</a:t>
+            </a:r>
+          </a:p>
+          <a:p>
+            <a:pPr lvl="0"/>
+            <a:r>
+              <a:rPr lang="ko-KR" sz="1200"/>
+              <a:t>평가 기준: 네 항목의 수준 구분이 정확한지, 조건과 추정을 분리했는지, 취소 버튼 이외의 대안도 검토했는지, 확인 질문이 가설의 참·거짓을 가릴 수 있는지.</a:t>
             </a:r>
           </a:p>
         </p:txBody>
@@ -1728,6 +1729,74 @@
 </file>
 
 <file path=ppt/notesSlides/notesSlide26.xml><?xml version="1.0" encoding="utf-8"?>
+<p:notes xmlns:a="http://schemas.openxmlformats.org/drawingml/2006/main" xmlns:r="http://schemas.openxmlformats.org/officeDocument/2006/relationships" xmlns:p="http://schemas.openxmlformats.org/presentationml/2006/main">
+  <p:cSld>
+    <p:spTree>
+      <p:nvGrpSpPr>
+        <p:cNvPr id="1" name=""/>
+        <p:cNvGrpSpPr/>
+        <p:nvPr/>
+      </p:nvGrpSpPr>
+      <p:grpSpPr>
+        <a:xfrm>
+          <a:off x="0" y="0"/>
+          <a:ext cx="0" cy="0"/>
+          <a:chOff x="0" y="0"/>
+          <a:chExt cx="0" cy="0"/>
+        </a:xfrm>
+      </p:grpSpPr>
+      <p:sp>
+        <p:nvSpPr>
+          <p:cNvPr id="2" name="슬라이드 이미지 개체 틀"/>
+          <p:cNvSpPr/>
+          <p:nvPr>
+            <p:ph type="sldImg" idx="2"/>
+          </p:nvPr>
+        </p:nvSpPr>
+        <p:spPr/>
+        <p:txBody>
+          <a:bodyPr/>
+          <a:lstStyle/>
+          <a:p/>
+        </p:txBody>
+      </p:sp>
+      <p:sp>
+        <p:nvSpPr>
+          <p:cNvPr id="3" name="슬라이드 노트 개체 틀"/>
+          <p:cNvSpPr/>
+          <p:nvPr>
+            <p:ph type="body" idx="3"/>
+          </p:nvPr>
+        </p:nvSpPr>
+        <p:spPr/>
+        <p:txBody>
+          <a:bodyPr/>
+          <a:lstStyle/>
+          <a:p>
+            <a:pPr lvl="0"/>
+            <a:r>
+              <a:rPr lang="ko-KR" sz="1200"/>
+              <a:t>특정 문장 하나보다 각 항목의 수준과 사실·가정을 구분했는지가 중요하다.</a:t>
+            </a:r>
+          </a:p>
+          <a:p>
+            <a:pPr lvl="0"/>
+            <a:r>
+              <a:rPr lang="ko-KR" sz="1200"/>
+              <a:t>같은 요구사항을 만족시키는 해결책은 여러 개일 수 있다.</a:t>
+            </a:r>
+          </a:p>
+        </p:txBody>
+      </p:sp>
+    </p:spTree>
+  </p:cSld>
+  <p:clrMapOvr>
+    <a:masterClrMapping/>
+  </p:clrMapOvr>
+</p:notes>
+</file>
+
+<file path=ppt/notesSlides/notesSlide27.xml><?xml version="1.0" encoding="utf-8"?>
 <p:notes xmlns:a="http://schemas.openxmlformats.org/drawingml/2006/main" xmlns:r="http://schemas.openxmlformats.org/officeDocument/2006/relationships" xmlns:p="http://schemas.openxmlformats.org/presentationml/2006/main">
   <p:cSld>
     <p:spTree>
@@ -4030,7 +4099,7 @@
                 <a:latin typeface="맑은 고딕"/>
                 <a:ea typeface="맑은 고딕"/>
               </a:rPr>
-              <a:t>20. 도메인 주도 설계</a:t>
+              <a:t>20. 흔한 오해</a:t>
             </a:r>
           </a:p>
           <a:p>
@@ -4051,7 +4120,7 @@
                 <a:latin typeface="맑은 고딕"/>
                 <a:ea typeface="맑은 고딕"/>
               </a:rPr>
-              <a:t>21. 온톨로지</a:t>
+              <a:t>21. 도메인 주도 설계</a:t>
             </a:r>
           </a:p>
           <a:p>
@@ -4072,7 +4141,7 @@
                 <a:latin typeface="맑은 고딕"/>
                 <a:ea typeface="맑은 고딕"/>
               </a:rPr>
-              <a:t>22. AI 기반 소프트웨어공학</a:t>
+              <a:t>22. 온톨로지</a:t>
             </a:r>
           </a:p>
           <a:p>
@@ -4093,17 +4162,7 @@
                 <a:latin typeface="맑은 고딕"/>
                 <a:ea typeface="맑은 고딕"/>
               </a:rPr>
-              <a:t>23. 실습 —</a:t>
-            </a:r>
-            <a:r>
-              <a:rPr sz="1400" b="0">
-                <a:solidFill>
-                  <a:srgbClr val="000000"/>
-                </a:solidFill>
-                <a:latin typeface="맑은 고딕"/>
-                <a:ea typeface="맑은 고딕"/>
-              </a:rPr>
-              <a:t> 문제·요구사항·해결책</a:t>
+              <a:t>23. AI 기반 소프트웨어공학</a:t>
             </a:r>
           </a:p>
           <a:p>
@@ -4134,17 +4193,7 @@
                 <a:latin typeface="맑은 고딕"/>
                 <a:ea typeface="맑은 고딕"/>
               </a:rPr>
-              <a:t> 검토 예시</a:t>
-            </a:r>
-            <a:r>
-              <a:rPr sz="1000" b="0">
-                <a:solidFill>
-                  <a:srgbClr val="000000"/>
-                </a:solidFill>
-                <a:latin typeface="맑은 고딕"/>
-                <a:ea typeface="맑은 고딕"/>
-              </a:rPr>
-              <a:t>(모범답안)</a:t>
+              <a:t> 문제·요구사항·해결책</a:t>
             </a:r>
           </a:p>
           <a:p>
@@ -4165,7 +4214,48 @@
                 <a:latin typeface="맑은 고딕"/>
                 <a:ea typeface="맑은 고딕"/>
               </a:rPr>
-              <a:t>25. 요약</a:t>
+              <a:t>25. 실습 —</a:t>
+            </a:r>
+            <a:r>
+              <a:rPr sz="1400" b="0">
+                <a:solidFill>
+                  <a:srgbClr val="000000"/>
+                </a:solidFill>
+                <a:latin typeface="맑은 고딕"/>
+                <a:ea typeface="맑은 고딕"/>
+              </a:rPr>
+              <a:t> 검토 예시</a:t>
+            </a:r>
+            <a:r>
+              <a:rPr sz="1000" b="0">
+                <a:solidFill>
+                  <a:srgbClr val="000000"/>
+                </a:solidFill>
+                <a:latin typeface="맑은 고딕"/>
+                <a:ea typeface="맑은 고딕"/>
+              </a:rPr>
+              <a:t>(모범답안)</a:t>
+            </a:r>
+          </a:p>
+          <a:p>
+            <a:pPr lvl="1" marL="355600" indent="0">
+              <a:spcBef>
+                <a:spcPts val="300"/>
+              </a:spcBef>
+              <a:spcAft>
+                <a:spcPts val="300"/>
+              </a:spcAft>
+              <a:buNone/>
+            </a:pPr>
+            <a:r>
+              <a:rPr sz="1600" b="0">
+                <a:solidFill>
+                  <a:srgbClr val="000000"/>
+                </a:solidFill>
+                <a:latin typeface="맑은 고딕"/>
+                <a:ea typeface="맑은 고딕"/>
+              </a:rPr>
+              <a:t>26. 요약</a:t>
             </a:r>
           </a:p>
         </p:txBody>
@@ -5103,8 +5193,8 @@
         </p:blipFill>
         <p:spPr>
           <a:xfrm>
-            <a:off x="1153716" y="4040228"/>
-            <a:ext cx="6836569" cy="1222375"/>
+            <a:off x="1149350" y="4114443"/>
+            <a:ext cx="6845300" cy="1073944"/>
           </a:xfrm>
           <a:prstGeom prst="rect">
             <a:avLst/>
@@ -7134,8 +7224,8 @@
         </p:blipFill>
         <p:spPr>
           <a:xfrm>
-            <a:off x="3113881" y="3692649"/>
-            <a:ext cx="2916238" cy="2427288"/>
+            <a:off x="2747169" y="3692649"/>
+            <a:ext cx="3649663" cy="2427288"/>
           </a:xfrm>
           <a:prstGeom prst="rect">
             <a:avLst/>
@@ -8632,8 +8722,8 @@
         </p:blipFill>
         <p:spPr>
           <a:xfrm>
-            <a:off x="2688468" y="3389876"/>
-            <a:ext cx="3767064" cy="2865193"/>
+            <a:off x="703382" y="3332480"/>
+            <a:ext cx="7737236" cy="2979985"/>
           </a:xfrm>
           <a:prstGeom prst="rect">
             <a:avLst/>
@@ -10645,7 +10735,7 @@
         <p:spPr>
           <a:xfrm>
             <a:off x="365760" y="960120"/>
-            <a:ext cx="8412480" cy="2514600"/>
+            <a:ext cx="8412480" cy="2788920"/>
           </a:xfrm>
         </p:spPr>
         <p:txBody>
@@ -10884,8 +10974,8 @@
         </p:blipFill>
         <p:spPr>
           <a:xfrm>
-            <a:off x="1149350" y="3949348"/>
-            <a:ext cx="6845300" cy="1885950"/>
+            <a:off x="1149350" y="3641784"/>
+            <a:ext cx="6845300" cy="1562894"/>
           </a:xfrm>
           <a:prstGeom prst="rect">
             <a:avLst/>
@@ -10913,7 +11003,7 @@
         <p:cNvPr id="1" name="">
           <a:extLst>
             <a:ext uri="{FF2B5EF4-FFF2-40B4-BE49-F238E27FC236}">
-              <a16:creationId xmlns:a16="http://schemas.microsoft.com/office/drawing/2014/main" id="{8E4F1F13-426B-086B-7D8C-9A58A0F879DB}"/>
+              <a16:creationId xmlns:a16="http://schemas.microsoft.com/office/drawing/2014/main" id="{60B87152-D004-1569-E429-90A42420A65C}"/>
             </a:ext>
           </a:extLst>
         </p:cNvPr>
@@ -10933,7 +11023,7 @@
           <p:cNvPr id="2" name="제목 1">
             <a:extLst>
               <a:ext uri="{FF2B5EF4-FFF2-40B4-BE49-F238E27FC236}">
-                <a16:creationId xmlns:a16="http://schemas.microsoft.com/office/drawing/2014/main" id="{AA26A92D-924E-0575-9551-F8FD7BFD3FAD}"/>
+                <a16:creationId xmlns:a16="http://schemas.microsoft.com/office/drawing/2014/main" id="{F2E2AB02-3ADE-69B8-887E-7981AD15EF24}"/>
               </a:ext>
             </a:extLst>
           </p:cNvPr>
@@ -10957,17 +11047,17 @@
                 <a:latin typeface="맑은 고딕"/>
                 <a:ea typeface="맑은 고딕"/>
               </a:rPr>
-              <a:t>20. 도메인 주도 설계</a:t>
-            </a:r>
-          </a:p>
-        </p:txBody>
-      </p:sp>
-      <p:sp>
-        <p:nvSpPr>
-          <p:cNvPr id="3" name="슬라이드 번호 개체 틀 2">
+              <a:t>20. 흔한 오해</a:t>
+            </a:r>
+          </a:p>
+        </p:txBody>
+      </p:sp>
+      <p:sp>
+        <p:nvSpPr>
+          <p:cNvPr id="5" name="텍스트 개체 틀 4">
             <a:extLst>
               <a:ext uri="{FF2B5EF4-FFF2-40B4-BE49-F238E27FC236}">
-                <a16:creationId xmlns:a16="http://schemas.microsoft.com/office/drawing/2014/main" id="{12CF30EE-4DFD-8063-56B8-B8689E76DFCA}"/>
+                <a16:creationId xmlns:a16="http://schemas.microsoft.com/office/drawing/2014/main" id="{F0895985-68EF-30BA-2165-4B3D90ECD41C}"/>
               </a:ext>
             </a:extLst>
           </p:cNvPr>
@@ -10975,7 +11065,7 @@
             <a:spLocks noGrp="1"/>
           </p:cNvSpPr>
           <p:nvPr>
-            <p:ph type="sldNum" sz="quarter" idx="10"/>
+            <p:ph type="body" sz="quarter" idx="11"/>
           </p:nvPr>
         </p:nvSpPr>
         <p:spPr/>
@@ -10983,26 +11073,19 @@
           <a:bodyPr/>
           <a:lstStyle/>
           <a:p>
-            <a:pPr>
-              <a:defRPr/>
-            </a:pPr>
-            <a:r>
-              <a:rPr lang="en-US" altLang="ko-KR">
-                <a:solidFill>
-                  <a:prstClr val="black"/>
-                </a:solidFill>
-              </a:rPr>
-              <a:t>- 21 -</a:t>
-            </a:r>
-          </a:p>
-        </p:txBody>
-      </p:sp>
-      <p:sp>
-        <p:nvSpPr>
-          <p:cNvPr id="5" name="텍스트 개체 틀 4">
+            <a:r>
+              <a:rPr kumimoji="1" lang="en-US" altLang="ko-KR" sz="1400" dirty="0" err="1"/>
+              <a:t>01. OOAD 개요</a:t>
+            </a:r>
+          </a:p>
+        </p:txBody>
+      </p:sp>
+      <p:sp>
+        <p:nvSpPr>
+          <p:cNvPr id="6" name="텍스트 개체 틀 5">
             <a:extLst>
               <a:ext uri="{FF2B5EF4-FFF2-40B4-BE49-F238E27FC236}">
-                <a16:creationId xmlns:a16="http://schemas.microsoft.com/office/drawing/2014/main" id="{D66274C8-E16F-5AEB-614B-D8D32DA3E8C6}"/>
+                <a16:creationId xmlns:a16="http://schemas.microsoft.com/office/drawing/2014/main" id="{D985C1FD-84C4-10F9-372D-6A84E1680E07}"/>
               </a:ext>
             </a:extLst>
           </p:cNvPr>
@@ -11010,7 +11093,7 @@
             <a:spLocks noGrp="1"/>
           </p:cNvSpPr>
           <p:nvPr>
-            <p:ph type="body" sz="quarter" idx="11"/>
+            <p:ph type="body" sz="quarter" idx="12"/>
           </p:nvPr>
         </p:nvSpPr>
         <p:spPr/>
@@ -11018,19 +11101,16 @@
           <a:bodyPr/>
           <a:lstStyle/>
           <a:p>
-            <a:r>
-              <a:rPr kumimoji="1" lang="en-US" altLang="ko-KR" sz="1400" dirty="0" err="1"/>
-              <a:t>01. OOAD 개요</a:t>
-            </a:r>
-          </a:p>
-        </p:txBody>
-      </p:sp>
-      <p:sp>
-        <p:nvSpPr>
-          <p:cNvPr id="6" name="텍스트 개체 틀 5">
+            <a:endParaRPr kumimoji="1" lang="ko-KR" altLang="en-US" dirty="0"/>
+          </a:p>
+        </p:txBody>
+      </p:sp>
+      <p:sp>
+        <p:nvSpPr>
+          <p:cNvPr id="7" name="텍스트 개체 틀 6">
             <a:extLst>
               <a:ext uri="{FF2B5EF4-FFF2-40B4-BE49-F238E27FC236}">
-                <a16:creationId xmlns:a16="http://schemas.microsoft.com/office/drawing/2014/main" id="{A24E58E1-194B-A320-AEEE-24D08685BB67}"/>
+                <a16:creationId xmlns:a16="http://schemas.microsoft.com/office/drawing/2014/main" id="{E26A8878-48FF-5E3A-5D05-0F900C22011B}"/>
               </a:ext>
             </a:extLst>
           </p:cNvPr>
@@ -11038,7 +11118,7 @@
             <a:spLocks noGrp="1"/>
           </p:cNvSpPr>
           <p:nvPr>
-            <p:ph type="body" sz="quarter" idx="12"/>
+            <p:ph type="body" sz="quarter" idx="13"/>
           </p:nvPr>
         </p:nvSpPr>
         <p:spPr/>
@@ -11046,16 +11126,1040 @@
           <a:bodyPr/>
           <a:lstStyle/>
           <a:p>
-            <a:endParaRPr kumimoji="1" lang="ko-KR" altLang="en-US" dirty="0"/>
-          </a:p>
-        </p:txBody>
-      </p:sp>
-      <p:sp>
-        <p:nvSpPr>
-          <p:cNvPr id="7" name="텍스트 개체 틀 6">
+            <a:endParaRPr lang="en-US" altLang="ko-KR" dirty="0"/>
+          </a:p>
+        </p:txBody>
+      </p:sp>
+      <p:graphicFrame>
+        <p:nvGraphicFramePr>
+          <p:cNvPr id="11" name="표 10">
             <a:extLst>
               <a:ext uri="{FF2B5EF4-FFF2-40B4-BE49-F238E27FC236}">
-                <a16:creationId xmlns:a16="http://schemas.microsoft.com/office/drawing/2014/main" id="{A219F420-613B-6234-45F6-0955A9A4505F}"/>
+                <a16:creationId xmlns:a16="http://schemas.microsoft.com/office/drawing/2014/main" id="{93753AB9-526C-CE2D-446D-7615D9B6D6D2}"/>
+              </a:ext>
+            </a:extLst>
+          </p:cNvPr>
+          <p:cNvGraphicFramePr>
+            <a:graphicFrameLocks noGrp="1"/>
+          </p:cNvGraphicFramePr>
+          <p:nvPr>
+            <p:extLst>
+              <p:ext uri="{D42A27DB-BD31-4B8C-83A1-F6EECF244321}">
+                <p14:modId xmlns:p14="http://schemas.microsoft.com/office/powerpoint/2010/main" val="1761827855"/>
+              </p:ext>
+            </p:extLst>
+          </p:nvPr>
+        </p:nvGraphicFramePr>
+        <p:xfrm>
+          <a:off x="488506" y="1842998"/>
+          <a:ext cx="8153400" cy="3873500"/>
+        </p:xfrm>
+        <a:graphic>
+          <a:graphicData uri="http://schemas.openxmlformats.org/drawingml/2006/table">
+            <a:tbl>
+              <a:tblPr/>
+              <a:tblGrid>
+                <a:gridCol w="3154680"/>
+                <a:gridCol w="4998720"/>
+              </a:tblGrid>
+              <a:tr h="317500">
+                <a:tc>
+                  <a:txBody>
+                    <a:bodyPr/>
+                    <a:lstStyle/>
+                    <a:p>
+                      <a:pPr algn="ctr" fontAlgn="ctr">
+                        <a:buNone/>
+                      </a:pPr>
+                      <a:r>
+                        <a:rPr lang="ko-KR" altLang="en-US" sz="1000" b="1" i="0" u="none" strike="noStrike" dirty="0">
+                          <a:solidFill>
+                            <a:schemeClr val="bg1"/>
+                          </a:solidFill>
+                          <a:effectLst/>
+                          <a:latin typeface="맑은 고딕" panose="020B0503020000020004" pitchFamily="34" charset="-127"/>
+                          <a:ea typeface="맑은 고딕" panose="020B0503020000020004" pitchFamily="34" charset="-127"/>
+                          <a:cs typeface="맑은 고딕"/>
+                        </a:rPr>
+                        <a:t>오해</a:t>
+                      </a:r>
+                    </a:p>
+                  </a:txBody>
+                  <a:tcPr marL="6750" marR="6750" marT="6750" marB="0" anchor="ctr">
+                    <a:lnL>
+                      <a:noFill/>
+                    </a:lnL>
+                    <a:lnR w="9525" cap="flat" cmpd="sng" algn="ctr">
+                      <a:solidFill>
+                        <a:schemeClr val="bg1">
+                          <a:lumMod val="50000"/>
+                        </a:schemeClr>
+                      </a:solidFill>
+                      <a:prstDash val="solid"/>
+                      <a:round/>
+                      <a:headEnd type="none" w="med" len="med"/>
+                      <a:tailEnd type="none" w="med" len="med"/>
+                    </a:lnR>
+                    <a:lnT w="9525" cap="flat" cmpd="sng" algn="ctr">
+                      <a:solidFill>
+                        <a:schemeClr val="tx1"/>
+                      </a:solidFill>
+                      <a:prstDash val="solid"/>
+                      <a:round/>
+                      <a:headEnd type="none" w="med" len="med"/>
+                      <a:tailEnd type="none" w="med" len="med"/>
+                    </a:lnT>
+                    <a:lnB w="9525" cap="flat" cmpd="sng" algn="ctr">
+                      <a:solidFill>
+                        <a:schemeClr val="bg1">
+                          <a:lumMod val="50000"/>
+                        </a:schemeClr>
+                      </a:solidFill>
+                      <a:prstDash val="solid"/>
+                      <a:round/>
+                      <a:headEnd type="none" w="med" len="med"/>
+                      <a:tailEnd type="none" w="med" len="med"/>
+                    </a:lnB>
+                    <a:solidFill>
+                      <a:srgbClr val="002060"/>
+                    </a:solidFill>
+                  </a:tcPr>
+                </a:tc>
+                <a:tc>
+                  <a:txBody>
+                    <a:bodyPr/>
+                    <a:lstStyle/>
+                    <a:p>
+                      <a:pPr algn="ctr" fontAlgn="ctr">
+                        <a:buNone/>
+                      </a:pPr>
+                      <a:r>
+                        <a:rPr lang="ko-KR" altLang="en-US" sz="1000" b="1" i="0" u="none" strike="noStrike" dirty="0">
+                          <a:solidFill>
+                            <a:schemeClr val="bg1"/>
+                          </a:solidFill>
+                          <a:effectLst/>
+                          <a:latin typeface="맑은 고딕" panose="020B0503020000020004" pitchFamily="34" charset="-127"/>
+                          <a:ea typeface="맑은 고딕" panose="020B0503020000020004" pitchFamily="34" charset="-127"/>
+                          <a:cs typeface="맑은 고딕"/>
+                        </a:rPr>
+                        <a:t>바른 판단</a:t>
+                      </a:r>
+                    </a:p>
+                  </a:txBody>
+                  <a:tcPr marL="6750" marR="6750" marT="6750" marB="0" anchor="ctr">
+                    <a:lnL w="9525" cap="flat" cmpd="sng" algn="ctr">
+                      <a:solidFill>
+                        <a:schemeClr val="bg1">
+                          <a:lumMod val="50000"/>
+                        </a:schemeClr>
+                      </a:solidFill>
+                      <a:prstDash val="solid"/>
+                      <a:round/>
+                      <a:headEnd type="none" w="med" len="med"/>
+                      <a:tailEnd type="none" w="med" len="med"/>
+                    </a:lnL>
+                    <a:lnR w="9525" cap="flat" cmpd="sng" algn="ctr">
+                      <a:solidFill>
+                        <a:schemeClr val="bg1">
+                          <a:lumMod val="50000"/>
+                        </a:schemeClr>
+                      </a:solidFill>
+                      <a:prstDash val="solid"/>
+                      <a:round/>
+                      <a:headEnd type="none" w="med" len="med"/>
+                      <a:tailEnd type="none" w="med" len="med"/>
+                    </a:lnR>
+                    <a:lnT w="9525" cap="flat" cmpd="sng" algn="ctr">
+                      <a:solidFill>
+                        <a:schemeClr val="tx1"/>
+                      </a:solidFill>
+                      <a:prstDash val="solid"/>
+                      <a:round/>
+                      <a:headEnd type="none" w="med" len="med"/>
+                      <a:tailEnd type="none" w="med" len="med"/>
+                    </a:lnT>
+                    <a:lnB w="9525" cap="flat" cmpd="sng" algn="ctr">
+                      <a:solidFill>
+                        <a:schemeClr val="bg1">
+                          <a:lumMod val="50000"/>
+                        </a:schemeClr>
+                      </a:solidFill>
+                      <a:prstDash val="solid"/>
+                      <a:round/>
+                      <a:headEnd type="none" w="med" len="med"/>
+                      <a:tailEnd type="none" w="med" len="med"/>
+                    </a:lnB>
+                    <a:solidFill>
+                      <a:srgbClr val="002060"/>
+                    </a:solidFill>
+                  </a:tcPr>
+                </a:tc>
+              </a:tr>
+              <a:tr h="317500">
+                <a:tc>
+                  <a:txBody>
+                    <a:bodyPr/>
+                    <a:lstStyle/>
+                    <a:p>
+                      <a:pPr algn="l" fontAlgn="ctr">
+                        <a:buNone/>
+                      </a:pPr>
+                      <a:r>
+                        <a:rPr lang="en" sz="1000" b="1" i="0" u="none" strike="noStrike" dirty="0">
+                          <a:solidFill>
+                            <a:schemeClr val="tx1"/>
+                          </a:solidFill>
+                          <a:effectLst/>
+                          <a:latin typeface="맑은 고딕" panose="020B0503020000020004" pitchFamily="34" charset="-127"/>
+                          <a:ea typeface="맑은 고딕" panose="020B0503020000020004" pitchFamily="34" charset="-127"/>
+                          <a:cs typeface="맑은 고딕"/>
+                        </a:rPr>
+                        <a:t>UML을 그리면 OOAD다</a:t>
+                      </a:r>
+                    </a:p>
+                  </a:txBody>
+                  <a:tcPr marL="81005" marR="6750" marT="6750" marB="0" anchor="ctr">
+                    <a:lnL>
+                      <a:noFill/>
+                    </a:lnL>
+                    <a:lnR>
+                      <a:noFill/>
+                    </a:lnR>
+                    <a:lnT w="9525" cap="flat" cmpd="sng" algn="ctr">
+                      <a:solidFill>
+                        <a:schemeClr val="bg1">
+                          <a:lumMod val="50000"/>
+                        </a:schemeClr>
+                      </a:solidFill>
+                      <a:prstDash val="solid"/>
+                      <a:round/>
+                      <a:headEnd type="none" w="med" len="med"/>
+                      <a:tailEnd type="none" w="med" len="med"/>
+                    </a:lnT>
+                    <a:lnB w="9525" cap="flat" cmpd="sng" algn="ctr">
+                      <a:solidFill>
+                        <a:schemeClr val="bg1">
+                          <a:lumMod val="50000"/>
+                        </a:schemeClr>
+                      </a:solidFill>
+                      <a:prstDash val="solid"/>
+                      <a:round/>
+                      <a:headEnd type="none" w="med" len="med"/>
+                      <a:tailEnd type="none" w="med" len="med"/>
+                    </a:lnB>
+                    <a:noFill/>
+                  </a:tcPr>
+                </a:tc>
+                <a:tc>
+                  <a:txBody>
+                    <a:bodyPr/>
+                    <a:lstStyle/>
+                    <a:p>
+                      <a:pPr algn="l" fontAlgn="ctr">
+                        <a:buNone/>
+                      </a:pPr>
+                      <a:r>
+                        <a:rPr lang="ko-KR" altLang="en-US" sz="1000" b="0" i="0" u="none" strike="noStrike" dirty="0">
+                          <a:solidFill>
+                            <a:srgbClr val="000000"/>
+                          </a:solidFill>
+                          <a:effectLst/>
+                          <a:latin typeface="맑은 고딕" panose="020B0503020000020004" pitchFamily="34" charset="-127"/>
+                          <a:ea typeface="맑은 고딕" panose="020B0503020000020004" pitchFamily="34" charset="-127"/>
+                          <a:cs typeface="맑은 고딕"/>
+                        </a:rPr>
+                        <a:t>UML은 표현 언어다. 핵심은 문제 이해와 책임·경계 판단이다</a:t>
+                      </a:r>
+                    </a:p>
+                  </a:txBody>
+                  <a:tcPr marL="81005" marR="6750" marT="6750" marB="0" anchor="ctr">
+                    <a:lnL>
+                      <a:noFill/>
+                    </a:lnL>
+                    <a:lnR>
+                      <a:noFill/>
+                    </a:lnR>
+                    <a:lnT w="9525" cap="flat" cmpd="sng" algn="ctr">
+                      <a:solidFill>
+                        <a:schemeClr val="bg1">
+                          <a:lumMod val="50000"/>
+                        </a:schemeClr>
+                      </a:solidFill>
+                      <a:prstDash val="solid"/>
+                      <a:round/>
+                      <a:headEnd type="none" w="med" len="med"/>
+                      <a:tailEnd type="none" w="med" len="med"/>
+                    </a:lnT>
+                    <a:lnB w="9525" cap="flat" cmpd="sng" algn="ctr">
+                      <a:solidFill>
+                        <a:schemeClr val="bg1">
+                          <a:lumMod val="50000"/>
+                        </a:schemeClr>
+                      </a:solidFill>
+                      <a:prstDash val="solid"/>
+                      <a:round/>
+                      <a:headEnd type="none" w="med" len="med"/>
+                      <a:tailEnd type="none" w="med" len="med"/>
+                    </a:lnB>
+                    <a:solidFill>
+                      <a:srgbClr val="FFFFFF"/>
+                    </a:solidFill>
+                  </a:tcPr>
+                </a:tc>
+              </a:tr>
+              <a:tr h="317500">
+                <a:tc>
+                  <a:txBody>
+                    <a:bodyPr/>
+                    <a:lstStyle/>
+                    <a:p>
+                      <a:pPr algn="l" fontAlgn="ctr">
+                        <a:buNone/>
+                      </a:pPr>
+                      <a:r>
+                        <a:rPr lang="en" sz="1000" b="1" i="0" u="none" strike="noStrike" dirty="0">
+                          <a:solidFill>
+                            <a:schemeClr val="tx1"/>
+                          </a:solidFill>
+                          <a:effectLst/>
+                          <a:latin typeface="맑은 고딕" panose="020B0503020000020004" pitchFamily="34" charset="-127"/>
+                          <a:ea typeface="맑은 고딕" panose="020B0503020000020004" pitchFamily="34" charset="-127"/>
+                          <a:cs typeface="맑은 고딕"/>
+                        </a:rPr>
+                        <a:t>분석은 문서를 많이 만드는 일이다</a:t>
+                      </a:r>
+                    </a:p>
+                  </a:txBody>
+                  <a:tcPr marL="81005" marR="6750" marT="6750" marB="0" anchor="ctr">
+                    <a:lnL>
+                      <a:noFill/>
+                    </a:lnL>
+                    <a:lnR>
+                      <a:noFill/>
+                    </a:lnR>
+                    <a:lnT w="9525" cap="flat" cmpd="sng" algn="ctr">
+                      <a:solidFill>
+                        <a:schemeClr val="bg1">
+                          <a:lumMod val="50000"/>
+                        </a:schemeClr>
+                      </a:solidFill>
+                      <a:prstDash val="solid"/>
+                      <a:round/>
+                      <a:headEnd type="none" w="med" len="med"/>
+                      <a:tailEnd type="none" w="med" len="med"/>
+                    </a:lnT>
+                    <a:lnB w="9525" cap="flat" cmpd="sng" algn="ctr">
+                      <a:solidFill>
+                        <a:schemeClr val="bg1">
+                          <a:lumMod val="50000"/>
+                        </a:schemeClr>
+                      </a:solidFill>
+                      <a:prstDash val="solid"/>
+                      <a:round/>
+                      <a:headEnd type="none" w="med" len="med"/>
+                      <a:tailEnd type="none" w="med" len="med"/>
+                    </a:lnB>
+                    <a:noFill/>
+                  </a:tcPr>
+                </a:tc>
+                <a:tc>
+                  <a:txBody>
+                    <a:bodyPr/>
+                    <a:lstStyle/>
+                    <a:p>
+                      <a:pPr algn="l" fontAlgn="ctr">
+                        <a:buNone/>
+                      </a:pPr>
+                      <a:r>
+                        <a:rPr lang="ko-KR" altLang="en-US" sz="1000" b="0" i="0" u="none" strike="noStrike" dirty="0">
+                          <a:solidFill>
+                            <a:srgbClr val="000000"/>
+                          </a:solidFill>
+                          <a:effectLst/>
+                          <a:latin typeface="맑은 고딕" panose="020B0503020000020004" pitchFamily="34" charset="-127"/>
+                          <a:ea typeface="맑은 고딕" panose="020B0503020000020004" pitchFamily="34" charset="-127"/>
+                          <a:cs typeface="맑은 고딕"/>
+                        </a:rPr>
+                        <a:t>분석의 목적은 산출물이 아니라 판단이다</a:t>
+                      </a:r>
+                    </a:p>
+                  </a:txBody>
+                  <a:tcPr marL="81005" marR="6750" marT="6750" marB="0" anchor="ctr">
+                    <a:lnL>
+                      <a:noFill/>
+                    </a:lnL>
+                    <a:lnR>
+                      <a:noFill/>
+                    </a:lnR>
+                    <a:lnT w="9525" cap="flat" cmpd="sng" algn="ctr">
+                      <a:solidFill>
+                        <a:schemeClr val="bg1">
+                          <a:lumMod val="50000"/>
+                        </a:schemeClr>
+                      </a:solidFill>
+                      <a:prstDash val="solid"/>
+                      <a:round/>
+                      <a:headEnd type="none" w="med" len="med"/>
+                      <a:tailEnd type="none" w="med" len="med"/>
+                    </a:lnT>
+                    <a:lnB w="9525" cap="flat" cmpd="sng" algn="ctr">
+                      <a:solidFill>
+                        <a:schemeClr val="bg1">
+                          <a:lumMod val="50000"/>
+                        </a:schemeClr>
+                      </a:solidFill>
+                      <a:prstDash val="solid"/>
+                      <a:round/>
+                      <a:headEnd type="none" w="med" len="med"/>
+                      <a:tailEnd type="none" w="med" len="med"/>
+                    </a:lnB>
+                    <a:solidFill>
+                      <a:srgbClr val="FFFFFF"/>
+                    </a:solidFill>
+                  </a:tcPr>
+                </a:tc>
+              </a:tr>
+              <a:tr h="317500">
+                <a:tc>
+                  <a:txBody>
+                    <a:bodyPr/>
+                    <a:lstStyle/>
+                    <a:p>
+                      <a:pPr algn="l" fontAlgn="ctr">
+                        <a:buNone/>
+                      </a:pPr>
+                      <a:r>
+                        <a:rPr lang="en" sz="1000" b="1" i="0" u="none" strike="noStrike" dirty="0">
+                          <a:solidFill>
+                            <a:schemeClr val="tx1"/>
+                          </a:solidFill>
+                          <a:effectLst/>
+                          <a:latin typeface="맑은 고딕" panose="020B0503020000020004" pitchFamily="34" charset="-127"/>
+                          <a:ea typeface="맑은 고딕" panose="020B0503020000020004" pitchFamily="34" charset="-127"/>
+                          <a:cs typeface="맑은 고딕"/>
+                        </a:rPr>
+                        <a:t>명사는 클래스, 테이블은 객체다</a:t>
+                      </a:r>
+                    </a:p>
+                  </a:txBody>
+                  <a:tcPr marL="81005" marR="6750" marT="6750" marB="0" anchor="ctr">
+                    <a:lnL>
+                      <a:noFill/>
+                    </a:lnL>
+                    <a:lnR>
+                      <a:noFill/>
+                    </a:lnR>
+                    <a:lnT w="9525" cap="flat" cmpd="sng" algn="ctr">
+                      <a:solidFill>
+                        <a:schemeClr val="bg1">
+                          <a:lumMod val="50000"/>
+                        </a:schemeClr>
+                      </a:solidFill>
+                      <a:prstDash val="solid"/>
+                      <a:round/>
+                      <a:headEnd type="none" w="med" len="med"/>
+                      <a:tailEnd type="none" w="med" len="med"/>
+                    </a:lnT>
+                    <a:lnB w="9525" cap="flat" cmpd="sng" algn="ctr">
+                      <a:solidFill>
+                        <a:schemeClr val="bg1">
+                          <a:lumMod val="50000"/>
+                        </a:schemeClr>
+                      </a:solidFill>
+                      <a:prstDash val="solid"/>
+                      <a:round/>
+                      <a:headEnd type="none" w="med" len="med"/>
+                      <a:tailEnd type="none" w="med" len="med"/>
+                    </a:lnB>
+                    <a:noFill/>
+                  </a:tcPr>
+                </a:tc>
+                <a:tc>
+                  <a:txBody>
+                    <a:bodyPr/>
+                    <a:lstStyle/>
+                    <a:p>
+                      <a:pPr algn="l" fontAlgn="ctr">
+                        <a:buNone/>
+                      </a:pPr>
+                      <a:r>
+                        <a:rPr lang="ko-KR" altLang="en-US" sz="1000" b="0" i="0" u="none" strike="noStrike" dirty="0">
+                          <a:solidFill>
+                            <a:srgbClr val="000000"/>
+                          </a:solidFill>
+                          <a:effectLst/>
+                          <a:latin typeface="맑은 고딕" panose="020B0503020000020004" pitchFamily="34" charset="-127"/>
+                          <a:ea typeface="맑은 고딕" panose="020B0503020000020004" pitchFamily="34" charset="-127"/>
+                          <a:cs typeface="맑은 고딕"/>
+                        </a:rPr>
+                        <a:t>분석 개념을 설계·코드로 기계적으로 옮기지 않는다</a:t>
+                      </a:r>
+                    </a:p>
+                  </a:txBody>
+                  <a:tcPr marL="81005" marR="6750" marT="6750" marB="0" anchor="ctr">
+                    <a:lnL>
+                      <a:noFill/>
+                    </a:lnL>
+                    <a:lnR>
+                      <a:noFill/>
+                    </a:lnR>
+                    <a:lnT w="9525" cap="flat" cmpd="sng" algn="ctr">
+                      <a:solidFill>
+                        <a:schemeClr val="bg1">
+                          <a:lumMod val="50000"/>
+                        </a:schemeClr>
+                      </a:solidFill>
+                      <a:prstDash val="solid"/>
+                      <a:round/>
+                      <a:headEnd type="none" w="med" len="med"/>
+                      <a:tailEnd type="none" w="med" len="med"/>
+                    </a:lnT>
+                    <a:lnB w="9525" cap="flat" cmpd="sng" algn="ctr">
+                      <a:solidFill>
+                        <a:schemeClr val="bg1">
+                          <a:lumMod val="50000"/>
+                        </a:schemeClr>
+                      </a:solidFill>
+                      <a:prstDash val="solid"/>
+                      <a:round/>
+                      <a:headEnd type="none" w="med" len="med"/>
+                      <a:tailEnd type="none" w="med" len="med"/>
+                    </a:lnB>
+                    <a:solidFill>
+                      <a:srgbClr val="FFFFFF"/>
+                    </a:solidFill>
+                  </a:tcPr>
+                </a:tc>
+              </a:tr>
+              <a:tr h="317500">
+                <a:tc>
+                  <a:txBody>
+                    <a:bodyPr/>
+                    <a:lstStyle/>
+                    <a:p>
+                      <a:pPr algn="l" fontAlgn="ctr">
+                        <a:buNone/>
+                      </a:pPr>
+                      <a:r>
+                        <a:rPr lang="en" sz="1000" b="1" i="0" u="none" strike="noStrike" dirty="0">
+                          <a:solidFill>
+                            <a:schemeClr val="tx1"/>
+                          </a:solidFill>
+                          <a:effectLst/>
+                          <a:latin typeface="맑은 고딕" panose="020B0503020000020004" pitchFamily="34" charset="-127"/>
+                          <a:ea typeface="맑은 고딕" panose="020B0503020000020004" pitchFamily="34" charset="-127"/>
+                          <a:cs typeface="맑은 고딕"/>
+                        </a:rPr>
+                        <a:t>객체는 데이터와 접근 메서드의 묶음이다</a:t>
+                      </a:r>
+                    </a:p>
+                  </a:txBody>
+                  <a:tcPr marL="81005" marR="6750" marT="6750" marB="0" anchor="ctr">
+                    <a:lnL>
+                      <a:noFill/>
+                    </a:lnL>
+                    <a:lnR>
+                      <a:noFill/>
+                    </a:lnR>
+                    <a:lnT w="9525" cap="flat" cmpd="sng" algn="ctr">
+                      <a:solidFill>
+                        <a:schemeClr val="bg1">
+                          <a:lumMod val="50000"/>
+                        </a:schemeClr>
+                      </a:solidFill>
+                      <a:prstDash val="solid"/>
+                      <a:round/>
+                      <a:headEnd type="none" w="med" len="med"/>
+                      <a:tailEnd type="none" w="med" len="med"/>
+                    </a:lnT>
+                    <a:lnB w="9525" cap="flat" cmpd="sng" algn="ctr">
+                      <a:solidFill>
+                        <a:schemeClr val="bg1">
+                          <a:lumMod val="50000"/>
+                        </a:schemeClr>
+                      </a:solidFill>
+                      <a:prstDash val="solid"/>
+                      <a:round/>
+                      <a:headEnd type="none" w="med" len="med"/>
+                      <a:tailEnd type="none" w="med" len="med"/>
+                    </a:lnB>
+                    <a:noFill/>
+                  </a:tcPr>
+                </a:tc>
+                <a:tc>
+                  <a:txBody>
+                    <a:bodyPr/>
+                    <a:lstStyle/>
+                    <a:p>
+                      <a:pPr algn="l" fontAlgn="ctr">
+                        <a:buNone/>
+                      </a:pPr>
+                      <a:r>
+                        <a:rPr lang="ko-KR" altLang="en-US" sz="1000" b="0" i="0" u="none" strike="noStrike" dirty="0">
+                          <a:solidFill>
+                            <a:srgbClr val="000000"/>
+                          </a:solidFill>
+                          <a:effectLst/>
+                          <a:latin typeface="맑은 고딕" panose="020B0503020000020004" pitchFamily="34" charset="-127"/>
+                          <a:ea typeface="맑은 고딕" panose="020B0503020000020004" pitchFamily="34" charset="-127"/>
+                          <a:cs typeface="맑은 고딕"/>
+                        </a:rPr>
+                        <a:t>객체는 책임을 지고 메시지로 협력한다</a:t>
+                      </a:r>
+                    </a:p>
+                  </a:txBody>
+                  <a:tcPr marL="81005" marR="6750" marT="6750" marB="0" anchor="ctr">
+                    <a:lnL>
+                      <a:noFill/>
+                    </a:lnL>
+                    <a:lnR>
+                      <a:noFill/>
+                    </a:lnR>
+                    <a:lnT w="9525" cap="flat" cmpd="sng" algn="ctr">
+                      <a:solidFill>
+                        <a:schemeClr val="bg1">
+                          <a:lumMod val="50000"/>
+                        </a:schemeClr>
+                      </a:solidFill>
+                      <a:prstDash val="solid"/>
+                      <a:round/>
+                      <a:headEnd type="none" w="med" len="med"/>
+                      <a:tailEnd type="none" w="med" len="med"/>
+                    </a:lnT>
+                    <a:lnB w="9525" cap="flat" cmpd="sng" algn="ctr">
+                      <a:solidFill>
+                        <a:schemeClr val="bg1">
+                          <a:lumMod val="50000"/>
+                        </a:schemeClr>
+                      </a:solidFill>
+                      <a:prstDash val="solid"/>
+                      <a:round/>
+                      <a:headEnd type="none" w="med" len="med"/>
+                      <a:tailEnd type="none" w="med" len="med"/>
+                    </a:lnB>
+                    <a:solidFill>
+                      <a:srgbClr val="FFFFFF"/>
+                    </a:solidFill>
+                  </a:tcPr>
+                </a:tc>
+              </a:tr>
+              <a:tr h="317500">
+                <a:tc>
+                  <a:txBody>
+                    <a:bodyPr/>
+                    <a:lstStyle/>
+                    <a:p>
+                      <a:pPr algn="l" fontAlgn="ctr">
+                        <a:buNone/>
+                      </a:pPr>
+                      <a:r>
+                        <a:rPr lang="en" sz="1000" b="1" i="0" u="none" strike="noStrike" dirty="0">
+                          <a:solidFill>
+                            <a:schemeClr val="tx1"/>
+                          </a:solidFill>
+                          <a:effectLst/>
+                          <a:latin typeface="맑은 고딕" panose="020B0503020000020004" pitchFamily="34" charset="-127"/>
+                          <a:ea typeface="맑은 고딕" panose="020B0503020000020004" pitchFamily="34" charset="-127"/>
+                          <a:cs typeface="맑은 고딕"/>
+                        </a:rPr>
+                        <a:t>상속과 디자인 패턴이 객체지향의 핵심이다</a:t>
+                      </a:r>
+                    </a:p>
+                  </a:txBody>
+                  <a:tcPr marL="81005" marR="6750" marT="6750" marB="0" anchor="ctr">
+                    <a:lnL>
+                      <a:noFill/>
+                    </a:lnL>
+                    <a:lnR>
+                      <a:noFill/>
+                    </a:lnR>
+                    <a:lnT w="9525" cap="flat" cmpd="sng" algn="ctr">
+                      <a:solidFill>
+                        <a:schemeClr val="bg1">
+                          <a:lumMod val="50000"/>
+                        </a:schemeClr>
+                      </a:solidFill>
+                      <a:prstDash val="solid"/>
+                      <a:round/>
+                      <a:headEnd type="none" w="med" len="med"/>
+                      <a:tailEnd type="none" w="med" len="med"/>
+                    </a:lnT>
+                    <a:lnB w="9525" cap="flat" cmpd="sng" algn="ctr">
+                      <a:solidFill>
+                        <a:schemeClr val="bg1">
+                          <a:lumMod val="50000"/>
+                        </a:schemeClr>
+                      </a:solidFill>
+                      <a:prstDash val="solid"/>
+                      <a:round/>
+                      <a:headEnd type="none" w="med" len="med"/>
+                      <a:tailEnd type="none" w="med" len="med"/>
+                    </a:lnB>
+                    <a:noFill/>
+                  </a:tcPr>
+                </a:tc>
+                <a:tc>
+                  <a:txBody>
+                    <a:bodyPr/>
+                    <a:lstStyle/>
+                    <a:p>
+                      <a:pPr algn="l" fontAlgn="ctr">
+                        <a:buNone/>
+                      </a:pPr>
+                      <a:r>
+                        <a:rPr lang="ko-KR" altLang="en-US" sz="1000" b="0" i="0" u="none" strike="noStrike" dirty="0">
+                          <a:solidFill>
+                            <a:srgbClr val="000000"/>
+                          </a:solidFill>
+                          <a:effectLst/>
+                          <a:latin typeface="맑은 고딕" panose="020B0503020000020004" pitchFamily="34" charset="-127"/>
+                          <a:ea typeface="맑은 고딕" panose="020B0503020000020004" pitchFamily="34" charset="-127"/>
+                          <a:cs typeface="맑은 고딕"/>
+                        </a:rPr>
+                        <a:t>핵심은 메시지·책임·협력이며, 패턴은 실제 변경 압력이 있을 때 쓴다</a:t>
+                      </a:r>
+                    </a:p>
+                  </a:txBody>
+                  <a:tcPr marL="81005" marR="6750" marT="6750" marB="0" anchor="ctr">
+                    <a:lnL>
+                      <a:noFill/>
+                    </a:lnL>
+                    <a:lnR>
+                      <a:noFill/>
+                    </a:lnR>
+                    <a:lnT w="9525" cap="flat" cmpd="sng" algn="ctr">
+                      <a:solidFill>
+                        <a:schemeClr val="bg1">
+                          <a:lumMod val="50000"/>
+                        </a:schemeClr>
+                      </a:solidFill>
+                      <a:prstDash val="solid"/>
+                      <a:round/>
+                      <a:headEnd type="none" w="med" len="med"/>
+                      <a:tailEnd type="none" w="med" len="med"/>
+                    </a:lnT>
+                    <a:lnB w="9525" cap="flat" cmpd="sng" algn="ctr">
+                      <a:solidFill>
+                        <a:schemeClr val="bg1">
+                          <a:lumMod val="50000"/>
+                        </a:schemeClr>
+                      </a:solidFill>
+                      <a:prstDash val="solid"/>
+                      <a:round/>
+                      <a:headEnd type="none" w="med" len="med"/>
+                      <a:tailEnd type="none" w="med" len="med"/>
+                    </a:lnB>
+                    <a:solidFill>
+                      <a:srgbClr val="FFFFFF"/>
+                    </a:solidFill>
+                  </a:tcPr>
+                </a:tc>
+              </a:tr>
+              <a:tr h="317500">
+                <a:tc>
+                  <a:txBody>
+                    <a:bodyPr/>
+                    <a:lstStyle/>
+                    <a:p>
+                      <a:pPr algn="l" fontAlgn="ctr">
+                        <a:buNone/>
+                      </a:pPr>
+                      <a:r>
+                        <a:rPr lang="en" sz="1000" b="1" i="0" u="none" strike="noStrike" dirty="0">
+                          <a:solidFill>
+                            <a:schemeClr val="tx1"/>
+                          </a:solidFill>
+                          <a:effectLst/>
+                          <a:latin typeface="맑은 고딕" panose="020B0503020000020004" pitchFamily="34" charset="-127"/>
+                          <a:ea typeface="맑은 고딕" panose="020B0503020000020004" pitchFamily="34" charset="-127"/>
+                          <a:cs typeface="맑은 고딕"/>
+                        </a:rPr>
+                        <a:t>기술을 먼저 정하고 요구를 맞춘다</a:t>
+                      </a:r>
+                    </a:p>
+                  </a:txBody>
+                  <a:tcPr marL="81005" marR="6750" marT="6750" marB="0" anchor="ctr">
+                    <a:lnL>
+                      <a:noFill/>
+                    </a:lnL>
+                    <a:lnR>
+                      <a:noFill/>
+                    </a:lnR>
+                    <a:lnT w="9525" cap="flat" cmpd="sng" algn="ctr">
+                      <a:solidFill>
+                        <a:schemeClr val="bg1">
+                          <a:lumMod val="50000"/>
+                        </a:schemeClr>
+                      </a:solidFill>
+                      <a:prstDash val="solid"/>
+                      <a:round/>
+                      <a:headEnd type="none" w="med" len="med"/>
+                      <a:tailEnd type="none" w="med" len="med"/>
+                    </a:lnT>
+                    <a:lnB w="9525" cap="flat" cmpd="sng" algn="ctr">
+                      <a:solidFill>
+                        <a:schemeClr val="bg1">
+                          <a:lumMod val="50000"/>
+                        </a:schemeClr>
+                      </a:solidFill>
+                      <a:prstDash val="solid"/>
+                      <a:round/>
+                      <a:headEnd type="none" w="med" len="med"/>
+                      <a:tailEnd type="none" w="med" len="med"/>
+                    </a:lnB>
+                    <a:noFill/>
+                  </a:tcPr>
+                </a:tc>
+                <a:tc>
+                  <a:txBody>
+                    <a:bodyPr/>
+                    <a:lstStyle/>
+                    <a:p>
+                      <a:pPr algn="l" fontAlgn="ctr">
+                        <a:buNone/>
+                      </a:pPr>
+                      <a:r>
+                        <a:rPr lang="ko-KR" altLang="en-US" sz="1000" b="0" i="0" u="none" strike="noStrike" dirty="0">
+                          <a:solidFill>
+                            <a:srgbClr val="000000"/>
+                          </a:solidFill>
+                          <a:effectLst/>
+                          <a:latin typeface="맑은 고딕" panose="020B0503020000020004" pitchFamily="34" charset="-127"/>
+                          <a:ea typeface="맑은 고딕" panose="020B0503020000020004" pitchFamily="34" charset="-127"/>
+                          <a:cs typeface="맑은 고딕"/>
+                        </a:rPr>
+                        <a:t>문제와 요구를 먼저 정하고 기술은 해결책으로 고른다</a:t>
+                      </a:r>
+                    </a:p>
+                  </a:txBody>
+                  <a:tcPr marL="81005" marR="6750" marT="6750" marB="0" anchor="ctr">
+                    <a:lnL>
+                      <a:noFill/>
+                    </a:lnL>
+                    <a:lnR>
+                      <a:noFill/>
+                    </a:lnR>
+                    <a:lnT w="9525" cap="flat" cmpd="sng" algn="ctr">
+                      <a:solidFill>
+                        <a:schemeClr val="bg1">
+                          <a:lumMod val="50000"/>
+                        </a:schemeClr>
+                      </a:solidFill>
+                      <a:prstDash val="solid"/>
+                      <a:round/>
+                      <a:headEnd type="none" w="med" len="med"/>
+                      <a:tailEnd type="none" w="med" len="med"/>
+                    </a:lnT>
+                    <a:lnB w="9525" cap="flat" cmpd="sng" algn="ctr">
+                      <a:solidFill>
+                        <a:schemeClr val="bg1">
+                          <a:lumMod val="50000"/>
+                        </a:schemeClr>
+                      </a:solidFill>
+                      <a:prstDash val="solid"/>
+                      <a:round/>
+                      <a:headEnd type="none" w="med" len="med"/>
+                      <a:tailEnd type="none" w="med" len="med"/>
+                    </a:lnB>
+                    <a:solidFill>
+                      <a:srgbClr val="FFFFFF"/>
+                    </a:solidFill>
+                  </a:tcPr>
+                </a:tc>
+              </a:tr>
+              <a:tr h="317500">
+                <a:tc>
+                  <a:txBody>
+                    <a:bodyPr/>
+                    <a:lstStyle/>
+                    <a:p>
+                      <a:pPr algn="l" fontAlgn="ctr">
+                        <a:buNone/>
+                      </a:pPr>
+                      <a:r>
+                        <a:rPr lang="en" sz="1000" b="1" i="0" u="none" strike="noStrike" dirty="0">
+                          <a:solidFill>
+                            <a:schemeClr val="tx1"/>
+                          </a:solidFill>
+                          <a:effectLst/>
+                          <a:latin typeface="맑은 고딕" panose="020B0503020000020004" pitchFamily="34" charset="-127"/>
+                          <a:ea typeface="맑은 고딕" panose="020B0503020000020004" pitchFamily="34" charset="-127"/>
+                          <a:cs typeface="맑은 고딕"/>
+                        </a:rPr>
+                        <a:t>한 번에 완벽하게 분석·설계한다</a:t>
+                      </a:r>
+                    </a:p>
+                  </a:txBody>
+                  <a:tcPr marL="81005" marR="6750" marT="6750" marB="0" anchor="ctr">
+                    <a:lnL>
+                      <a:noFill/>
+                    </a:lnL>
+                    <a:lnR>
+                      <a:noFill/>
+                    </a:lnR>
+                    <a:lnT w="9525" cap="flat" cmpd="sng" algn="ctr">
+                      <a:solidFill>
+                        <a:schemeClr val="bg1">
+                          <a:lumMod val="50000"/>
+                        </a:schemeClr>
+                      </a:solidFill>
+                      <a:prstDash val="solid"/>
+                      <a:round/>
+                      <a:headEnd type="none" w="med" len="med"/>
+                      <a:tailEnd type="none" w="med" len="med"/>
+                    </a:lnT>
+                    <a:lnB w="9525" cap="flat" cmpd="sng" algn="ctr">
+                      <a:solidFill>
+                        <a:schemeClr val="bg1">
+                          <a:lumMod val="50000"/>
+                        </a:schemeClr>
+                      </a:solidFill>
+                      <a:prstDash val="solid"/>
+                      <a:round/>
+                      <a:headEnd type="none" w="med" len="med"/>
+                      <a:tailEnd type="none" w="med" len="med"/>
+                    </a:lnB>
+                    <a:noFill/>
+                  </a:tcPr>
+                </a:tc>
+                <a:tc>
+                  <a:txBody>
+                    <a:bodyPr/>
+                    <a:lstStyle/>
+                    <a:p>
+                      <a:pPr algn="l" fontAlgn="ctr">
+                        <a:buNone/>
+                      </a:pPr>
+                      <a:r>
+                        <a:rPr lang="ko-KR" altLang="en-US" sz="1000" b="0" i="0" u="none" strike="noStrike" dirty="0">
+                          <a:solidFill>
+                            <a:srgbClr val="000000"/>
+                          </a:solidFill>
+                          <a:effectLst/>
+                          <a:latin typeface="맑은 고딕" panose="020B0503020000020004" pitchFamily="34" charset="-127"/>
+                          <a:ea typeface="맑은 고딕" panose="020B0503020000020004" pitchFamily="34" charset="-127"/>
+                          <a:cs typeface="맑은 고딕"/>
+                        </a:rPr>
+                        <a:t>적정하게 분석·설계하고 피드백으로 고친다</a:t>
+                      </a:r>
+                    </a:p>
+                  </a:txBody>
+                  <a:tcPr marL="81005" marR="6750" marT="6750" marB="0" anchor="ctr">
+                    <a:lnL>
+                      <a:noFill/>
+                    </a:lnL>
+                    <a:lnR>
+                      <a:noFill/>
+                    </a:lnR>
+                    <a:lnT w="9525" cap="flat" cmpd="sng" algn="ctr">
+                      <a:solidFill>
+                        <a:schemeClr val="bg1">
+                          <a:lumMod val="50000"/>
+                        </a:schemeClr>
+                      </a:solidFill>
+                      <a:prstDash val="solid"/>
+                      <a:round/>
+                      <a:headEnd type="none" w="med" len="med"/>
+                      <a:tailEnd type="none" w="med" len="med"/>
+                    </a:lnT>
+                    <a:lnB w="9525" cap="flat" cmpd="sng" algn="ctr">
+                      <a:solidFill>
+                        <a:schemeClr val="bg1">
+                          <a:lumMod val="50000"/>
+                        </a:schemeClr>
+                      </a:solidFill>
+                      <a:prstDash val="solid"/>
+                      <a:round/>
+                      <a:headEnd type="none" w="med" len="med"/>
+                      <a:tailEnd type="none" w="med" len="med"/>
+                    </a:lnB>
+                    <a:solidFill>
+                      <a:srgbClr val="FFFFFF"/>
+                    </a:solidFill>
+                  </a:tcPr>
+                </a:tc>
+              </a:tr>
+            </a:tbl>
+          </a:graphicData>
+        </a:graphic>
+      </p:graphicFrame>
+      <p:sp>
+        <p:nvSpPr>
+          <p:cNvPr id="13" name="TextBox 12">
+            <a:extLst>
+              <a:ext uri="{FF2B5EF4-FFF2-40B4-BE49-F238E27FC236}">
+                <a16:creationId xmlns:a16="http://schemas.microsoft.com/office/drawing/2014/main" id="{654EDDB4-901F-3D48-A715-17D163E8A7AC}"/>
+              </a:ext>
+            </a:extLst>
+          </p:cNvPr>
+          <p:cNvSpPr txBox="1"/>
+          <p:nvPr/>
+        </p:nvSpPr>
+        <p:spPr>
+          <a:xfrm>
+            <a:off x="365760" y="960120"/>
+            <a:ext cx="8412480" cy="781278"/>
+          </a:xfrm>
+          <a:prstGeom prst="rect">
+            <a:avLst/>
+          </a:prstGeom>
+          <a:noFill/>
+        </p:spPr>
+        <p:txBody>
+          <a:bodyPr wrap="square">
+            <a:spAutoFit/>
+          </a:bodyPr>
+          <a:lstStyle/>
+          <a:p>
+            <a:pPr marL="0" indent="0">
+              <a:spcBef>
+                <a:spcPts val="600"/>
+              </a:spcBef>
+              <a:spcAft>
+                <a:spcPts val="600"/>
+              </a:spcAft>
+              <a:buNone/>
+            </a:pPr>
+            <a:r>
+              <a:rPr sz="1800" b="0">
+                <a:solidFill>
+                  <a:srgbClr val="000000"/>
+                </a:solidFill>
+                <a:latin typeface="맑은 고딕"/>
+                <a:ea typeface="맑은 고딕"/>
+              </a:rPr>
+              <a:t>객체지향 분석·설계에 대한 흔한 오해는 </a:t>
+            </a:r>
+            <a:r>
+              <a:rPr sz="1800" b="1">
+                <a:solidFill>
+                  <a:srgbClr val="000000"/>
+                </a:solidFill>
+                <a:latin typeface="맑은 고딕"/>
+                <a:ea typeface="맑은 고딕"/>
+              </a:rPr>
+              <a:t>표기·산출물·기술</a:t>
+            </a:r>
+            <a:r>
+              <a:rPr sz="1800" b="0">
+                <a:solidFill>
+                  <a:srgbClr val="000000"/>
+                </a:solidFill>
+                <a:latin typeface="맑은 고딕"/>
+                <a:ea typeface="맑은 고딕"/>
+              </a:rPr>
+              <a:t>을 판단보다 앞세우는 데서 생긴다.</a:t>
+            </a:r>
+          </a:p>
+        </p:txBody>
+      </p:sp>
+      <p:sp>
+        <p:nvSpPr>
+          <p:cNvPr id="8" name="슬라이드 번호 개체 틀 2">
+            <a:extLst>
+              <a:ext uri="{FF2B5EF4-FFF2-40B4-BE49-F238E27FC236}">
+                <a16:creationId xmlns:a16="http://schemas.microsoft.com/office/drawing/2014/main" id="{741B75C6-7ED3-AA4C-41B6-F69C599EA447}"/>
               </a:ext>
             </a:extLst>
           </p:cNvPr>
@@ -11063,311 +12167,54 @@
             <a:spLocks noGrp="1"/>
           </p:cNvSpPr>
           <p:nvPr>
-            <p:ph type="body" sz="quarter" idx="13"/>
-          </p:nvPr>
-        </p:nvSpPr>
-        <p:spPr/>
-        <p:txBody>
-          <a:bodyPr/>
-          <a:lstStyle/>
-          <a:p>
-            <a:endParaRPr kumimoji="1" lang="en-US" altLang="ko-KR" dirty="0"/>
-          </a:p>
-        </p:txBody>
-      </p:sp>
-      <p:sp>
-        <p:nvSpPr>
-          <p:cNvPr id="8" name="내용 개체 틀 7">
-            <a:extLst>
-              <a:ext uri="{FF2B5EF4-FFF2-40B4-BE49-F238E27FC236}">
-                <a16:creationId xmlns:a16="http://schemas.microsoft.com/office/drawing/2014/main" id="{BEBA2C4A-B0BF-F2E4-EA6E-614C99CBA184}"/>
-              </a:ext>
-            </a:extLst>
-          </p:cNvPr>
-          <p:cNvSpPr>
-            <a:spLocks noGrp="1"/>
-          </p:cNvSpPr>
-          <p:nvPr>
-            <p:ph idx="1"/>
-          </p:nvPr>
-        </p:nvSpPr>
-        <p:spPr/>
+            <p:ph type="sldNum" sz="quarter" idx="10"/>
+          </p:nvPr>
+        </p:nvSpPr>
+        <p:spPr>
+          <a:xfrm>
+            <a:off x="3508472" y="6449625"/>
+            <a:ext cx="2133600" cy="238277"/>
+          </a:xfrm>
+        </p:spPr>
         <p:txBody>
           <a:bodyPr>
             <a:normAutofit/>
           </a:bodyPr>
           <a:lstStyle/>
           <a:p>
-            <a:pPr marL="0" indent="0">
+            <a:pPr marL="0" marR="0" lvl="0" indent="0" algn="ctr" defTabSz="457200" rtl="0" eaLnBrk="1" fontAlgn="auto" latinLnBrk="0" hangingPunct="1">
+              <a:lnSpc>
+                <a:spcPct val="100000"/>
+              </a:lnSpc>
               <a:spcBef>
-                <a:spcPts val="600"/>
+                <a:spcPts val="0"/>
               </a:spcBef>
               <a:spcAft>
                 <a:spcPts val="600"/>
               </a:spcAft>
+              <a:buClrTx/>
+              <a:buSzTx/>
+              <a:buFontTx/>
               <a:buNone/>
+              <a:tabLst/>
+              <a:defRPr/>
             </a:pPr>
             <a:r>
-              <a:rPr sz="1800" b="1">
-                <a:solidFill>
-                  <a:srgbClr val="000000"/>
-                </a:solidFill>
-                <a:latin typeface="맑은 고딕"/>
-                <a:ea typeface="맑은 고딕"/>
-              </a:rPr>
-              <a:t>기존 객체지향 설계의 대체물이 아니라, 도메인 모델과 설계·구현의 정합성을 깊이 있게 다룬다.</a:t>
-            </a:r>
-          </a:p>
-          <a:p>
-            <a:pPr lvl="2" marL="723900" indent="-368300">
-              <a:spcBef>
-                <a:spcPts val="600"/>
-              </a:spcBef>
-              <a:spcAft>
-                <a:spcPts val="600"/>
-              </a:spcAft>
-              <a:buSzPct val="90000"/>
-              <a:buFont typeface="Wingdings" pitchFamily="2" charset="2"/>
-              <a:buChar char=""/>
-            </a:pPr>
-            <a:r>
-              <a:rPr sz="1800" b="1">
-                <a:solidFill>
-                  <a:srgbClr val="000000"/>
-                </a:solidFill>
-                <a:latin typeface="맑은 고딕"/>
-                <a:ea typeface="맑은 고딕"/>
-              </a:rPr>
-              <a:t>전략적 설계</a:t>
-            </a:r>
-            <a:r>
-              <a:rPr sz="1800" b="0">
-                <a:solidFill>
-                  <a:srgbClr val="000000"/>
-                </a:solidFill>
-                <a:latin typeface="맑은 고딕"/>
-                <a:ea typeface="맑은 고딕"/>
-              </a:rPr>
-              <a:t> —</a:t>
-            </a:r>
-            <a:r>
-              <a:rPr sz="1600" b="0">
-                <a:solidFill>
-                  <a:srgbClr val="000000"/>
-                </a:solidFill>
-                <a:latin typeface="맑은 고딕"/>
-                <a:ea typeface="맑은 고딕"/>
-              </a:rPr>
-              <a:t> 핵심 도메인, 경계가 명확한 문맥, 문맥 간 관계</a:t>
-            </a:r>
-          </a:p>
-          <a:p>
-            <a:pPr lvl="2" marL="723900" indent="-368300">
-              <a:spcBef>
-                <a:spcPts val="600"/>
-              </a:spcBef>
-              <a:spcAft>
-                <a:spcPts val="600"/>
-              </a:spcAft>
-              <a:buSzPct val="90000"/>
-              <a:buFont typeface="Wingdings" pitchFamily="2" charset="2"/>
-              <a:buChar char=""/>
-            </a:pPr>
-            <a:r>
-              <a:rPr sz="1800" b="1">
-                <a:solidFill>
-                  <a:srgbClr val="000000"/>
-                </a:solidFill>
-                <a:latin typeface="맑은 고딕"/>
-                <a:ea typeface="맑은 고딕"/>
-              </a:rPr>
-              <a:t>전술적 설계</a:t>
-            </a:r>
-            <a:r>
-              <a:rPr sz="1800" b="0">
-                <a:solidFill>
-                  <a:srgbClr val="000000"/>
-                </a:solidFill>
-                <a:latin typeface="맑은 고딕"/>
-                <a:ea typeface="맑은 고딕"/>
-              </a:rPr>
-              <a:t> —</a:t>
-            </a:r>
-            <a:r>
-              <a:rPr sz="1600" b="0">
-                <a:solidFill>
-                  <a:srgbClr val="000000"/>
-                </a:solidFill>
-                <a:latin typeface="맑은 고딕"/>
-                <a:ea typeface="맑은 고딕"/>
-              </a:rPr>
-              <a:t> 엔티티, 값 객체, 애그리거트, 저장소, 도메인 서비스</a:t>
-            </a:r>
-          </a:p>
-          <a:p>
-            <a:pPr lvl="2" marL="723900" indent="-368300">
-              <a:spcBef>
-                <a:spcPts val="600"/>
-              </a:spcBef>
-              <a:spcAft>
-                <a:spcPts val="600"/>
-              </a:spcAft>
-              <a:buSzPct val="90000"/>
-              <a:buFont typeface="Wingdings" pitchFamily="2" charset="2"/>
-              <a:buChar char=""/>
-            </a:pPr>
-            <a:r>
-              <a:rPr sz="1800" b="0">
-                <a:solidFill>
-                  <a:srgbClr val="000000"/>
-                </a:solidFill>
-                <a:latin typeface="맑은 고딕"/>
-                <a:ea typeface="맑은 고딕"/>
-              </a:rPr>
-              <a:t>"이 책의 설계 방식은 대체로 </a:t>
-            </a:r>
-            <a:r>
-              <a:rPr sz="1800" b="1">
-                <a:solidFill>
-                  <a:srgbClr val="000000"/>
-                </a:solidFill>
-                <a:latin typeface="맑은 고딕"/>
-                <a:ea typeface="맑은 고딕"/>
-              </a:rPr>
-              <a:t>책임 중심 설계</a:t>
-            </a:r>
-            <a:r>
-              <a:rPr sz="1400" b="0">
-                <a:solidFill>
-                  <a:srgbClr val="000000"/>
-                </a:solidFill>
-                <a:latin typeface="맑은 고딕"/>
-                <a:ea typeface="맑은 고딕"/>
-              </a:rPr>
-              <a:t>(Responsibility-Driven Design)</a:t>
-            </a:r>
-            <a:r>
-              <a:rPr sz="1800" b="0">
-                <a:solidFill>
-                  <a:srgbClr val="000000"/>
-                </a:solidFill>
-                <a:latin typeface="맑은 고딕"/>
-                <a:ea typeface="맑은 고딕"/>
-              </a:rPr>
-              <a:t> 원칙을 따르며, 10장에서는 특히 </a:t>
-            </a:r>
-            <a:r>
-              <a:rPr sz="1800" b="1">
-                <a:solidFill>
-                  <a:srgbClr val="000000"/>
-                </a:solidFill>
-                <a:latin typeface="맑은 고딕"/>
-                <a:ea typeface="맑은 고딕"/>
-              </a:rPr>
-              <a:t>계약에 의한 설계</a:t>
-            </a:r>
-            <a:r>
-              <a:rPr sz="1400" b="0">
-                <a:solidFill>
-                  <a:srgbClr val="000000"/>
-                </a:solidFill>
-                <a:latin typeface="맑은 고딕"/>
-                <a:ea typeface="맑은 고딕"/>
-              </a:rPr>
-              <a:t>(Design by Contract)</a:t>
-            </a:r>
-            <a:r>
-              <a:rPr sz="1800" b="0">
-                <a:solidFill>
-                  <a:srgbClr val="000000"/>
-                </a:solidFill>
-                <a:latin typeface="맑은 고딕"/>
-                <a:ea typeface="맑은 고딕"/>
-              </a:rPr>
-              <a:t>의 개념에 크게 의존한다. 또한 라만</a:t>
-            </a:r>
-            <a:r>
-              <a:rPr sz="1400" b="0">
-                <a:solidFill>
-                  <a:srgbClr val="000000"/>
-                </a:solidFill>
-                <a:latin typeface="맑은 고딕"/>
-                <a:ea typeface="맑은 고딕"/>
-              </a:rPr>
-              <a:t>(Craig Larman)</a:t>
-            </a:r>
-            <a:r>
-              <a:rPr sz="1800" b="0">
-                <a:solidFill>
-                  <a:srgbClr val="000000"/>
-                </a:solidFill>
-                <a:latin typeface="맑은 고딕"/>
-                <a:ea typeface="맑은 고딕"/>
-              </a:rPr>
-              <a:t>의 책과 같이 널리 받아들여지는 다른 객체지향 설계 모범 사례의 일반적인 배경 위에 있다."</a:t>
-            </a:r>
-            <a:r>
-              <a:rPr sz="1000" b="0">
-                <a:solidFill>
-                  <a:srgbClr val="000000"/>
-                </a:solidFill>
-                <a:latin typeface="맑은 고딕"/>
-                <a:ea typeface="맑은 고딕"/>
-              </a:rPr>
-              <a:t>, </a:t>
-            </a:r>
-            <a:r>
-              <a:rPr sz="1000" b="0">
-                <a:solidFill>
-                  <a:srgbClr val="000000"/>
-                </a:solidFill>
-                <a:latin typeface="맑은 고딕"/>
-                <a:ea typeface="맑은 고딕"/>
-              </a:rPr>
-              <a:t>"The design style largely follows the principle of “responsibility-driven design”... It also relies heavily (especially in Chapter 10) on the ideas of “design by contract”... It draws on the general background of other widely held best practices of object-oriented design, which are described in such books as [Larman 1998]."</a:t>
-            </a:r>
-            <a:r>
-              <a:rPr sz="1000" b="0">
-                <a:solidFill>
-                  <a:srgbClr val="000000"/>
-                </a:solidFill>
-                <a:latin typeface="맑은 고딕"/>
-                <a:ea typeface="맑은 고딕"/>
-              </a:rPr>
-              <a:t>, </a:t>
-            </a:r>
-            <a:r>
-              <a:rPr sz="1000" b="0">
-                <a:solidFill>
-                  <a:srgbClr val="000000"/>
-                </a:solidFill>
-                <a:latin typeface="맑은 고딕"/>
-                <a:ea typeface="맑은 고딕"/>
-              </a:rPr>
-              <a:t>Eric Evans, 2003</a:t>
-            </a:r>
-          </a:p>
-          <a:p>
-            <a:pPr lvl="2" marL="723900" indent="-368300">
-              <a:spcBef>
-                <a:spcPts val="600"/>
-              </a:spcBef>
-              <a:spcAft>
-                <a:spcPts val="600"/>
-              </a:spcAft>
-              <a:buSzPct val="90000"/>
-              <a:buFont typeface="Wingdings" pitchFamily="2" charset="2"/>
-              <a:buChar char=""/>
-            </a:pPr>
-            <a:r>
-              <a:rPr sz="1800" b="0">
-                <a:solidFill>
-                  <a:srgbClr val="000000"/>
-                </a:solidFill>
-                <a:latin typeface="맑은 고딕"/>
-                <a:ea typeface="맑은 고딕"/>
-              </a:rPr>
-              <a:t>에반스는 도메인 주도 설계를 이 배경 위에 세운다. 이 세션은 그 위에서 도메인 주도 설계 고유의 전략적·전술적 설계를 다룬다.</a:t>
+              <a:rPr kumimoji="0" lang="en-US" altLang="ko-KR" sz="800" b="0" i="0" u="none" strike="noStrike" kern="1200" cap="none" spc="0" normalizeH="0" baseline="0" noProof="0">
+                <a:ln>
+                  <a:noFill/>
+                </a:ln>
+                <a:solidFill>
+                  <a:prstClr val="black"/>
+                </a:solidFill>
+                <a:effectLst/>
+                <a:uLnTx/>
+                <a:uFillTx/>
+                <a:latin typeface="맑은 고딕" panose="020B0503020000020004" pitchFamily="34" charset="-127"/>
+                <a:ea typeface="맑은 고딕" panose="020B0503020000020004" pitchFamily="34" charset="-127"/>
+                <a:cs typeface="+mn-cs"/>
+              </a:rPr>
+              <a:t>- 21 -</a:t>
             </a:r>
           </a:p>
         </p:txBody>
@@ -11375,7 +12222,7 @@
     </p:spTree>
     <p:extLst>
       <p:ext uri="{BB962C8B-B14F-4D97-AF65-F5344CB8AC3E}">
-        <p14:creationId xmlns:p14="http://schemas.microsoft.com/office/powerpoint/2010/main" val="3555436673"/>
+        <p14:creationId xmlns:p14="http://schemas.microsoft.com/office/powerpoint/2010/main" val="2789569477"/>
       </p:ext>
     </p:extLst>
   </p:cSld>
@@ -11437,7 +12284,7 @@
                 <a:latin typeface="맑은 고딕"/>
                 <a:ea typeface="맑은 고딕"/>
               </a:rPr>
-              <a:t>21. 온톨로지</a:t>
+              <a:t>21. 도메인 주도 설계</a:t>
             </a:r>
           </a:p>
         </p:txBody>
@@ -11571,12 +12418,7 @@
             <p:ph idx="1"/>
           </p:nvPr>
         </p:nvSpPr>
-        <p:spPr>
-          <a:xfrm>
-            <a:off x="365760" y="960120"/>
-            <a:ext cx="8412480" cy="2514600"/>
-          </a:xfrm>
-        </p:spPr>
+        <p:spPr/>
         <p:txBody>
           <a:bodyPr>
             <a:normAutofit/>
@@ -11600,47 +12442,7 @@
                 <a:latin typeface="맑은 고딕"/>
                 <a:ea typeface="맑은 고딕"/>
               </a:rPr>
-              <a:t>온톨로지</a:t>
-            </a:r>
-            <a:r>
-              <a:rPr sz="1400" b="1">
-                <a:solidFill>
-                  <a:srgbClr val="000000"/>
-                </a:solidFill>
-                <a:latin typeface="맑은 고딕"/>
-                <a:ea typeface="맑은 고딕"/>
-              </a:rPr>
-              <a:t>(Ontology)</a:t>
-            </a:r>
-            <a:r>
-              <a:rPr sz="1800" b="0">
-                <a:solidFill>
-                  <a:srgbClr val="000000"/>
-                </a:solidFill>
-                <a:latin typeface="맑은 고딕"/>
-                <a:ea typeface="맑은 고딕"/>
-              </a:rPr>
-              <a:t>는 공유하려는 개념과 관계의 의미를 명시하는 데 사용한다. 도메인 모델과 관심을 공유하지만 </a:t>
-            </a:r>
-            <a:r>
-              <a:rPr sz="1800" b="1">
-                <a:solidFill>
-                  <a:srgbClr val="000000"/>
-                </a:solidFill>
-                <a:latin typeface="맑은 고딕"/>
-                <a:ea typeface="맑은 고딕"/>
-              </a:rPr>
-              <a:t>모든 도메인 모델을 자동으로 온톨로지라고 부르지는 않는다</a:t>
-            </a:r>
-            <a:r>
-              <a:rPr sz="1800" b="0">
-                <a:solidFill>
-                  <a:srgbClr val="000000"/>
-                </a:solidFill>
-                <a:latin typeface="맑은 고딕"/>
-                <a:ea typeface="맑은 고딕"/>
-              </a:rPr>
-              <a:t>.</a:t>
+              <a:t>기존 객체지향 설계의 대체물이 아니라, 도메인 모델과 설계·구현의 정합성을 깊이 있게 다룬다.</a:t>
             </a:r>
           </a:p>
           <a:p>
@@ -11656,6 +12458,16 @@
               <a:buChar char=""/>
             </a:pPr>
             <a:r>
+              <a:rPr sz="1800" b="1">
+                <a:solidFill>
+                  <a:srgbClr val="000000"/>
+                </a:solidFill>
+                <a:latin typeface="맑은 고딕"/>
+                <a:ea typeface="맑은 고딕"/>
+              </a:rPr>
+              <a:t>전략적 설계</a:t>
+            </a:r>
+            <a:r>
               <a:rPr sz="1800" b="0">
                 <a:solidFill>
                   <a:srgbClr val="000000"/>
@@ -11663,67 +12475,17 @@
                 <a:latin typeface="맑은 고딕"/>
                 <a:ea typeface="맑은 고딕"/>
               </a:rPr>
-              <a:t>"온톨로지는 </a:t>
-            </a:r>
-            <a:r>
-              <a:rPr sz="1800" b="1">
-                <a:solidFill>
-                  <a:srgbClr val="000000"/>
-                </a:solidFill>
-                <a:latin typeface="맑은 고딕"/>
-                <a:ea typeface="맑은 고딕"/>
-              </a:rPr>
-              <a:t>개념화의 명시적 명세</a:t>
-            </a:r>
-            <a:r>
-              <a:rPr sz="1800" b="0">
-                <a:solidFill>
-                  <a:srgbClr val="000000"/>
-                </a:solidFill>
-                <a:latin typeface="맑은 고딕"/>
-                <a:ea typeface="맑은 고딕"/>
-              </a:rPr>
-              <a:t>다"</a:t>
-            </a:r>
-            <a:r>
-              <a:rPr sz="1000" b="0">
-                <a:solidFill>
-                  <a:srgbClr val="000000"/>
-                </a:solidFill>
-                <a:latin typeface="맑은 고딕"/>
-                <a:ea typeface="맑은 고딕"/>
-              </a:rPr>
-              <a:t>, </a:t>
-            </a:r>
-            <a:r>
-              <a:rPr sz="1000" b="0">
-                <a:solidFill>
-                  <a:srgbClr val="000000"/>
-                </a:solidFill>
-                <a:latin typeface="맑은 고딕"/>
-                <a:ea typeface="맑은 고딕"/>
-              </a:rPr>
-              <a:t>"An ontology is an explicit specification of a conceptualization."</a:t>
-            </a:r>
-            <a:r>
-              <a:rPr sz="1000" b="0">
-                <a:solidFill>
-                  <a:srgbClr val="000000"/>
-                </a:solidFill>
-                <a:latin typeface="맑은 고딕"/>
-                <a:ea typeface="맑은 고딕"/>
-              </a:rPr>
-              <a:t>, </a:t>
-            </a:r>
-            <a:r>
-              <a:rPr sz="1000" b="0">
-                <a:solidFill>
-                  <a:srgbClr val="000000"/>
-                </a:solidFill>
-                <a:latin typeface="맑은 고딕"/>
-                <a:ea typeface="맑은 고딕"/>
-              </a:rPr>
-              <a:t>Thomas R. Gruber, 1993</a:t>
+              <a:t> —</a:t>
+            </a:r>
+            <a:r>
+              <a:rPr sz="1600" b="0">
+                <a:solidFill>
+                  <a:srgbClr val="000000"/>
+                </a:solidFill>
+                <a:latin typeface="맑은 고딕"/>
+                <a:ea typeface="맑은 고딕"/>
+              </a:rPr>
+              <a:t> 핵심 도메인, 경계가 명확한 문맥, 문맥 간 관계</a:t>
             </a:r>
           </a:p>
           <a:p>
@@ -11739,6 +12501,16 @@
               <a:buChar char=""/>
             </a:pPr>
             <a:r>
+              <a:rPr sz="1800" b="1">
+                <a:solidFill>
+                  <a:srgbClr val="000000"/>
+                </a:solidFill>
+                <a:latin typeface="맑은 고딕"/>
+                <a:ea typeface="맑은 고딕"/>
+              </a:rPr>
+              <a:t>전술적 설계</a:t>
+            </a:r>
+            <a:r>
               <a:rPr sz="1800" b="0">
                 <a:solidFill>
                   <a:srgbClr val="000000"/>
@@ -11746,7 +12518,40 @@
                 <a:latin typeface="맑은 고딕"/>
                 <a:ea typeface="맑은 고딕"/>
               </a:rPr>
-              <a:t>이는 필수 개발 순서가 아니라 </a:t>
+              <a:t> —</a:t>
+            </a:r>
+            <a:r>
+              <a:rPr sz="1600" b="0">
+                <a:solidFill>
+                  <a:srgbClr val="000000"/>
+                </a:solidFill>
+                <a:latin typeface="맑은 고딕"/>
+                <a:ea typeface="맑은 고딕"/>
+              </a:rPr>
+              <a:t> 엔티티, 값 객체, 애그리거트, 저장소, 도메인 서비스</a:t>
+            </a:r>
+          </a:p>
+          <a:p>
+            <a:pPr lvl="2" marL="723900" indent="-368300">
+              <a:spcBef>
+                <a:spcPts val="600"/>
+              </a:spcBef>
+              <a:spcAft>
+                <a:spcPts val="600"/>
+              </a:spcAft>
+              <a:buSzPct val="90000"/>
+              <a:buFont typeface="Wingdings" pitchFamily="2" charset="2"/>
+              <a:buChar char=""/>
+            </a:pPr>
+            <a:r>
+              <a:rPr sz="1800" b="0">
+                <a:solidFill>
+                  <a:srgbClr val="000000"/>
+                </a:solidFill>
+                <a:latin typeface="맑은 고딕"/>
+                <a:ea typeface="맑은 고딕"/>
+              </a:rPr>
+              <a:t>"이 책의 설계 방식은 대체로 </a:t>
             </a:r>
             <a:r>
               <a:rPr sz="1800" b="1">
@@ -11756,7 +12561,17 @@
                 <a:latin typeface="맑은 고딕"/>
                 <a:ea typeface="맑은 고딕"/>
               </a:rPr>
-              <a:t>관심과 활용 관계</a:t>
+              <a:t>책임 중심 설계</a:t>
+            </a:r>
+            <a:r>
+              <a:rPr sz="1400" b="0">
+                <a:solidFill>
+                  <a:srgbClr val="000000"/>
+                </a:solidFill>
+                <a:latin typeface="맑은 고딕"/>
+                <a:ea typeface="맑은 고딕"/>
+              </a:rPr>
+              <a:t>(Responsibility-Driven Design)</a:t>
             </a:r>
             <a:r>
               <a:rPr sz="1800" b="0">
@@ -11766,35 +12581,124 @@
                 <a:latin typeface="맑은 고딕"/>
                 <a:ea typeface="맑은 고딕"/>
               </a:rPr>
-              <a:t>다.</a:t>
-            </a:r>
-          </a:p>
-        </p:txBody>
-      </p:sp>
-      <p:pic>
-        <p:nvPicPr>
-          <p:cNvPr id="9" name="mermaid Diagram 8"/>
-          <p:cNvPicPr>
-            <a:picLocks noChangeAspect="1"/>
-          </p:cNvPicPr>
-          <p:nvPr/>
-        </p:nvPicPr>
-        <p:blipFill>
-          <a:blip r:embed="mermaidImage8"/>
-          <a:stretch>
-            <a:fillRect/>
-          </a:stretch>
-        </p:blipFill>
-        <p:spPr>
-          <a:xfrm>
-            <a:off x="1149350" y="3418488"/>
-            <a:ext cx="6845300" cy="2794000"/>
-          </a:xfrm>
-          <a:prstGeom prst="rect">
-            <a:avLst/>
-          </a:prstGeom>
-        </p:spPr>
-      </p:pic>
+              <a:t> 원칙을 따르며, 10장에서는 특히 </a:t>
+            </a:r>
+            <a:r>
+              <a:rPr sz="1800" b="1">
+                <a:solidFill>
+                  <a:srgbClr val="000000"/>
+                </a:solidFill>
+                <a:latin typeface="맑은 고딕"/>
+                <a:ea typeface="맑은 고딕"/>
+              </a:rPr>
+              <a:t>계약에 의한 설계</a:t>
+            </a:r>
+            <a:r>
+              <a:rPr sz="1400" b="0">
+                <a:solidFill>
+                  <a:srgbClr val="000000"/>
+                </a:solidFill>
+                <a:latin typeface="맑은 고딕"/>
+                <a:ea typeface="맑은 고딕"/>
+              </a:rPr>
+              <a:t>(Design by Contract)</a:t>
+            </a:r>
+            <a:r>
+              <a:rPr sz="1800" b="0">
+                <a:solidFill>
+                  <a:srgbClr val="000000"/>
+                </a:solidFill>
+                <a:latin typeface="맑은 고딕"/>
+                <a:ea typeface="맑은 고딕"/>
+              </a:rPr>
+              <a:t>의 개념에 크게 의존한다. 또한 라만</a:t>
+            </a:r>
+            <a:r>
+              <a:rPr sz="1400" b="0">
+                <a:solidFill>
+                  <a:srgbClr val="000000"/>
+                </a:solidFill>
+                <a:latin typeface="맑은 고딕"/>
+                <a:ea typeface="맑은 고딕"/>
+              </a:rPr>
+              <a:t>(Craig Larman)</a:t>
+            </a:r>
+            <a:r>
+              <a:rPr sz="1800" b="0">
+                <a:solidFill>
+                  <a:srgbClr val="000000"/>
+                </a:solidFill>
+                <a:latin typeface="맑은 고딕"/>
+                <a:ea typeface="맑은 고딕"/>
+              </a:rPr>
+              <a:t>의 책과 같이 널리 받아들여지는 다른 객체지향 설계 모범 사례의 일반적인 배경 위에 있다."</a:t>
+            </a:r>
+            <a:r>
+              <a:rPr sz="1000" b="0">
+                <a:solidFill>
+                  <a:srgbClr val="000000"/>
+                </a:solidFill>
+                <a:latin typeface="맑은 고딕"/>
+                <a:ea typeface="맑은 고딕"/>
+              </a:rPr>
+              <a:t>, </a:t>
+            </a:r>
+            <a:r>
+              <a:rPr sz="1000" b="0">
+                <a:solidFill>
+                  <a:srgbClr val="000000"/>
+                </a:solidFill>
+                <a:latin typeface="맑은 고딕"/>
+                <a:ea typeface="맑은 고딕"/>
+              </a:rPr>
+              <a:t>"The design style largely follows the principle of “responsibility-driven design”... It also relies heavily (especially in Chapter 10) on the ideas of “design by contract”... It draws on the general background of other widely held best practices of object-oriented design, which are described in such books as [Larman 1998]."</a:t>
+            </a:r>
+            <a:r>
+              <a:rPr sz="1000" b="0">
+                <a:solidFill>
+                  <a:srgbClr val="000000"/>
+                </a:solidFill>
+                <a:latin typeface="맑은 고딕"/>
+                <a:ea typeface="맑은 고딕"/>
+              </a:rPr>
+              <a:t>, </a:t>
+            </a:r>
+            <a:r>
+              <a:rPr sz="1000" b="0">
+                <a:solidFill>
+                  <a:srgbClr val="000000"/>
+                </a:solidFill>
+                <a:latin typeface="맑은 고딕"/>
+                <a:ea typeface="맑은 고딕"/>
+              </a:rPr>
+              <a:t>Eric Evans, 2003</a:t>
+            </a:r>
+          </a:p>
+          <a:p>
+            <a:pPr lvl="2" marL="723900" indent="-368300">
+              <a:spcBef>
+                <a:spcPts val="600"/>
+              </a:spcBef>
+              <a:spcAft>
+                <a:spcPts val="600"/>
+              </a:spcAft>
+              <a:buSzPct val="90000"/>
+              <a:buFont typeface="Wingdings" pitchFamily="2" charset="2"/>
+              <a:buChar char=""/>
+            </a:pPr>
+            <a:r>
+              <a:rPr sz="1800" b="0">
+                <a:solidFill>
+                  <a:srgbClr val="000000"/>
+                </a:solidFill>
+                <a:latin typeface="맑은 고딕"/>
+                <a:ea typeface="맑은 고딕"/>
+              </a:rPr>
+              <a:t>에반스는 도메인 주도 설계를 이 배경 위에 세운다. 이 세션은 그 위에서 도메인 주도 설계 고유의 전략적·전술적 설계를 다룬다.</a:t>
+            </a:r>
+          </a:p>
+        </p:txBody>
+      </p:sp>
     </p:spTree>
     <p:extLst>
       <p:ext uri="{BB962C8B-B14F-4D97-AF65-F5344CB8AC3E}">
@@ -11860,7 +12764,7 @@
                 <a:latin typeface="맑은 고딕"/>
                 <a:ea typeface="맑은 고딕"/>
               </a:rPr>
-              <a:t>22. AI 기반 소프트웨어공학</a:t>
+              <a:t>22. 온톨로지</a:t>
             </a:r>
           </a:p>
         </p:txBody>
@@ -11994,7 +12898,12 @@
             <p:ph idx="1"/>
           </p:nvPr>
         </p:nvSpPr>
-        <p:spPr/>
+        <p:spPr>
+          <a:xfrm>
+            <a:off x="365760" y="960120"/>
+            <a:ext cx="8412480" cy="2514600"/>
+          </a:xfrm>
+        </p:spPr>
         <p:txBody>
           <a:bodyPr>
             <a:normAutofit/>
@@ -12011,6 +12920,26 @@
               <a:buNone/>
             </a:pPr>
             <a:r>
+              <a:rPr sz="1800" b="1">
+                <a:solidFill>
+                  <a:srgbClr val="000000"/>
+                </a:solidFill>
+                <a:latin typeface="맑은 고딕"/>
+                <a:ea typeface="맑은 고딕"/>
+              </a:rPr>
+              <a:t>온톨로지</a:t>
+            </a:r>
+            <a:r>
+              <a:rPr sz="1400" b="1">
+                <a:solidFill>
+                  <a:srgbClr val="000000"/>
+                </a:solidFill>
+                <a:latin typeface="맑은 고딕"/>
+                <a:ea typeface="맑은 고딕"/>
+              </a:rPr>
+              <a:t>(Ontology)</a:t>
+            </a:r>
+            <a:r>
               <a:rPr sz="1800" b="0">
                 <a:solidFill>
                   <a:srgbClr val="000000"/>
@@ -12018,7 +12947,7 @@
                 <a:latin typeface="맑은 고딕"/>
                 <a:ea typeface="맑은 고딕"/>
               </a:rPr>
-              <a:t>이 과정에서는 AI 기반 개발을 </a:t>
+              <a:t>는 공유하려는 개념과 관계의 의미를 명시하는 데 사용한다. 도메인 모델과 관심을 공유하지만 </a:t>
             </a:r>
             <a:r>
               <a:rPr sz="1800" b="1">
@@ -12028,7 +12957,7 @@
                 <a:latin typeface="맑은 고딕"/>
                 <a:ea typeface="맑은 고딕"/>
               </a:rPr>
-              <a:t>인간의 판단 책임과 AI의 실행·지원 역할을 배치하는 관점</a:t>
+              <a:t>모든 도메인 모델을 자동으로 온톨로지라고 부르지는 않는다</a:t>
             </a:r>
             <a:r>
               <a:rPr sz="1800" b="0">
@@ -12038,7 +12967,7 @@
                 <a:latin typeface="맑은 고딕"/>
                 <a:ea typeface="맑은 고딕"/>
               </a:rPr>
-              <a:t>으로 다룬다. 아래 구분은 보편적으로 확정된 역할 표준이 아니라 검증과 책임 소재를 명확히 하기 위한 운영 원칙이다.</a:t>
+              <a:t>.</a:t>
             </a:r>
           </a:p>
           <a:p>
@@ -12054,6 +12983,16 @@
               <a:buChar char=""/>
             </a:pPr>
             <a:r>
+              <a:rPr sz="1800" b="0">
+                <a:solidFill>
+                  <a:srgbClr val="000000"/>
+                </a:solidFill>
+                <a:latin typeface="맑은 고딕"/>
+                <a:ea typeface="맑은 고딕"/>
+              </a:rPr>
+              <a:t>"온톨로지는 </a:t>
+            </a:r>
+            <a:r>
               <a:rPr sz="1800" b="1">
                 <a:solidFill>
                   <a:srgbClr val="000000"/>
@@ -12061,7 +13000,7 @@
                 <a:latin typeface="맑은 고딕"/>
                 <a:ea typeface="맑은 고딕"/>
               </a:rPr>
-              <a:t>인간이 최종 책임지는 판단</a:t>
+              <a:t>개념화의 명시적 명세</a:t>
             </a:r>
             <a:r>
               <a:rPr sz="1800" b="0">
@@ -12071,17 +13010,47 @@
                 <a:latin typeface="맑은 고딕"/>
                 <a:ea typeface="맑은 고딕"/>
               </a:rPr>
-              <a:t> —</a:t>
-            </a:r>
-            <a:r>
-              <a:rPr sz="1600" b="0">
-                <a:solidFill>
-                  <a:srgbClr val="000000"/>
-                </a:solidFill>
-                <a:latin typeface="맑은 고딕"/>
-                <a:ea typeface="맑은 고딕"/>
-              </a:rPr>
-              <a:t> 비전과 가치, 위험 수용, 최종 의사결정과 책임</a:t>
+              <a:t>다"</a:t>
+            </a:r>
+            <a:r>
+              <a:rPr sz="1000" b="0">
+                <a:solidFill>
+                  <a:srgbClr val="000000"/>
+                </a:solidFill>
+                <a:latin typeface="맑은 고딕"/>
+                <a:ea typeface="맑은 고딕"/>
+              </a:rPr>
+              <a:t>, </a:t>
+            </a:r>
+            <a:r>
+              <a:rPr sz="1000" b="0">
+                <a:solidFill>
+                  <a:srgbClr val="000000"/>
+                </a:solidFill>
+                <a:latin typeface="맑은 고딕"/>
+                <a:ea typeface="맑은 고딕"/>
+              </a:rPr>
+              <a:t>"An ontology is an explicit specification of a conceptualization."</a:t>
+            </a:r>
+            <a:r>
+              <a:rPr sz="1000" b="0">
+                <a:solidFill>
+                  <a:srgbClr val="000000"/>
+                </a:solidFill>
+                <a:latin typeface="맑은 고딕"/>
+                <a:ea typeface="맑은 고딕"/>
+              </a:rPr>
+              <a:t>, </a:t>
+            </a:r>
+            <a:r>
+              <a:rPr sz="1000" b="0">
+                <a:solidFill>
+                  <a:srgbClr val="000000"/>
+                </a:solidFill>
+                <a:latin typeface="맑은 고딕"/>
+                <a:ea typeface="맑은 고딕"/>
+              </a:rPr>
+              <a:t>Thomas R. Gruber, 1993</a:t>
             </a:r>
           </a:p>
           <a:p>
@@ -12097,6 +13066,16 @@
               <a:buChar char=""/>
             </a:pPr>
             <a:r>
+              <a:rPr sz="1800" b="0">
+                <a:solidFill>
+                  <a:srgbClr val="000000"/>
+                </a:solidFill>
+                <a:latin typeface="맑은 고딕"/>
+                <a:ea typeface="맑은 고딕"/>
+              </a:rPr>
+              <a:t>이는 필수 개발 순서가 아니라 </a:t>
+            </a:r>
+            <a:r>
               <a:rPr sz="1800" b="1">
                 <a:solidFill>
                   <a:srgbClr val="000000"/>
@@ -12104,7 +13083,7 @@
                 <a:latin typeface="맑은 고딕"/>
                 <a:ea typeface="맑은 고딕"/>
               </a:rPr>
-              <a:t>인간과 AI의 협업</a:t>
+              <a:t>관심과 활용 관계</a:t>
             </a:r>
             <a:r>
               <a:rPr sz="1800" b="0">
@@ -12114,197 +13093,35 @@
                 <a:latin typeface="맑은 고딕"/>
                 <a:ea typeface="맑은 고딕"/>
               </a:rPr>
-              <a:t> —</a:t>
-            </a:r>
-            <a:r>
-              <a:rPr sz="1600" b="0">
-                <a:solidFill>
-                  <a:srgbClr val="000000"/>
-                </a:solidFill>
-                <a:latin typeface="맑은 고딕"/>
-                <a:ea typeface="맑은 고딕"/>
-              </a:rPr>
-              <a:t> 요구사항, 도메인 모델·온톨로지, 아키텍처·설계, 테스트·검토</a:t>
-            </a:r>
-          </a:p>
-          <a:p>
-            <a:pPr lvl="2" marL="723900" indent="-368300">
-              <a:spcBef>
-                <a:spcPts val="600"/>
-              </a:spcBef>
-              <a:spcAft>
-                <a:spcPts val="600"/>
-              </a:spcAft>
-              <a:buSzPct val="90000"/>
-              <a:buFont typeface="Wingdings" pitchFamily="2" charset="2"/>
-              <a:buChar char=""/>
-            </a:pPr>
-            <a:r>
-              <a:rPr sz="1800" b="1">
-                <a:solidFill>
-                  <a:srgbClr val="000000"/>
-                </a:solidFill>
-                <a:latin typeface="맑은 고딕"/>
-                <a:ea typeface="맑은 고딕"/>
-              </a:rPr>
-              <a:t>AI가 주도할 수 있는 실행</a:t>
-            </a:r>
-            <a:r>
-              <a:rPr sz="1800" b="0">
-                <a:solidFill>
-                  <a:srgbClr val="000000"/>
-                </a:solidFill>
-                <a:latin typeface="맑은 고딕"/>
-                <a:ea typeface="맑은 고딕"/>
-              </a:rPr>
-              <a:t> —</a:t>
-            </a:r>
-            <a:r>
-              <a:rPr sz="1600" b="0">
-                <a:solidFill>
-                  <a:srgbClr val="000000"/>
-                </a:solidFill>
-                <a:latin typeface="맑은 고딕"/>
-                <a:ea typeface="맑은 고딕"/>
-              </a:rPr>
-              <a:t> 코드 생성·변환, 정적 검사, 테스트 실행, 자동화</a:t>
-            </a:r>
-          </a:p>
-          <a:p>
-            <a:pPr lvl="2" marL="723900" indent="-368300">
-              <a:spcBef>
-                <a:spcPts val="600"/>
-              </a:spcBef>
-              <a:spcAft>
-                <a:spcPts val="600"/>
-              </a:spcAft>
-              <a:buSzPct val="90000"/>
-              <a:buFont typeface="Wingdings" pitchFamily="2" charset="2"/>
-              <a:buChar char=""/>
-            </a:pPr>
-            <a:r>
-              <a:rPr sz="1800" b="0">
-                <a:solidFill>
-                  <a:srgbClr val="000000"/>
-                </a:solidFill>
-                <a:latin typeface="맑은 고딕"/>
-                <a:ea typeface="맑은 고딕"/>
-              </a:rPr>
-              <a:t>핵심은 </a:t>
-            </a:r>
-            <a:r>
-              <a:rPr sz="1800" b="1">
-                <a:solidFill>
-                  <a:srgbClr val="000000"/>
-                </a:solidFill>
-                <a:latin typeface="맑은 고딕"/>
-                <a:ea typeface="맑은 고딕"/>
-              </a:rPr>
-              <a:t>누가 코드를 작성하느냐보다 누가 의미·경계·위험을 판단하고 결과를 검증하느냐</a:t>
-            </a:r>
-            <a:r>
-              <a:rPr sz="1800" b="0">
-                <a:solidFill>
-                  <a:srgbClr val="000000"/>
-                </a:solidFill>
-                <a:latin typeface="맑은 고딕"/>
-                <a:ea typeface="맑은 고딕"/>
-              </a:rPr>
-              <a:t>에 있다. 실행할 때는 필요한 맥락·제약을 </a:t>
-            </a:r>
-            <a:r>
-              <a:rPr sz="1800" b="1">
-                <a:solidFill>
-                  <a:srgbClr val="000000"/>
-                </a:solidFill>
-                <a:latin typeface="맑은 고딕"/>
-                <a:ea typeface="맑은 고딕"/>
-              </a:rPr>
-              <a:t>가드레일</a:t>
-            </a:r>
-            <a:r>
-              <a:rPr sz="1400" b="1">
-                <a:solidFill>
-                  <a:srgbClr val="000000"/>
-                </a:solidFill>
-                <a:latin typeface="맑은 고딕"/>
-                <a:ea typeface="맑은 고딕"/>
-              </a:rPr>
-              <a:t>(Guardrail)</a:t>
-            </a:r>
-            <a:r>
-              <a:rPr sz="1800" b="0">
-                <a:solidFill>
-                  <a:srgbClr val="000000"/>
-                </a:solidFill>
-                <a:latin typeface="맑은 고딕"/>
-                <a:ea typeface="맑은 고딕"/>
-              </a:rPr>
-              <a:t>에 담고, </a:t>
-            </a:r>
-            <a:r>
-              <a:rPr sz="1800" b="1">
-                <a:solidFill>
-                  <a:srgbClr val="000000"/>
-                </a:solidFill>
-                <a:latin typeface="맑은 고딕"/>
-                <a:ea typeface="맑은 고딕"/>
-              </a:rPr>
-              <a:t>에이전트</a:t>
-            </a:r>
-            <a:r>
-              <a:rPr sz="1400" b="1">
-                <a:solidFill>
-                  <a:srgbClr val="000000"/>
-                </a:solidFill>
-                <a:latin typeface="맑은 고딕"/>
-                <a:ea typeface="맑은 고딕"/>
-              </a:rPr>
-              <a:t>(Agent)</a:t>
-            </a:r>
-            <a:r>
-              <a:rPr sz="1800" b="0">
-                <a:solidFill>
-                  <a:srgbClr val="000000"/>
-                </a:solidFill>
-                <a:latin typeface="맑은 고딕"/>
-                <a:ea typeface="맑은 고딕"/>
-              </a:rPr>
-              <a:t>의 작업을 </a:t>
-            </a:r>
-            <a:r>
-              <a:rPr sz="1800" b="1">
-                <a:solidFill>
-                  <a:srgbClr val="000000"/>
-                </a:solidFill>
-                <a:latin typeface="맑은 고딕"/>
-                <a:ea typeface="맑은 고딕"/>
-              </a:rPr>
-              <a:t>실행·검증 환경</a:t>
-            </a:r>
-            <a:r>
-              <a:rPr sz="1400" b="1">
-                <a:solidFill>
-                  <a:srgbClr val="000000"/>
-                </a:solidFill>
-                <a:latin typeface="맑은 고딕"/>
-                <a:ea typeface="맑은 고딕"/>
-              </a:rPr>
-              <a:t>(Harness)</a:t>
-            </a:r>
-            <a:r>
-              <a:rPr sz="1800" b="0">
-                <a:solidFill>
-                  <a:srgbClr val="000000"/>
-                </a:solidFill>
-                <a:latin typeface="맑은 고딕"/>
-                <a:ea typeface="맑은 고딕"/>
-              </a:rPr>
-              <a:t>에서 확인한다.</a:t>
-            </a:r>
-          </a:p>
-        </p:txBody>
-      </p:sp>
+              <a:t>다.</a:t>
+            </a:r>
+          </a:p>
+        </p:txBody>
+      </p:sp>
+      <p:pic>
+        <p:nvPicPr>
+          <p:cNvPr id="9" name="mermaid Diagram 8"/>
+          <p:cNvPicPr>
+            <a:picLocks noChangeAspect="1"/>
+          </p:cNvPicPr>
+          <p:nvPr/>
+        </p:nvPicPr>
+        <p:blipFill>
+          <a:blip r:embed="mermaidImage8"/>
+          <a:stretch>
+            <a:fillRect/>
+          </a:stretch>
+        </p:blipFill>
+        <p:spPr>
+          <a:xfrm>
+            <a:off x="1149350" y="3545091"/>
+            <a:ext cx="6845300" cy="2540794"/>
+          </a:xfrm>
+          <a:prstGeom prst="rect">
+            <a:avLst/>
+          </a:prstGeom>
+        </p:spPr>
+      </p:pic>
     </p:spTree>
     <p:extLst>
       <p:ext uri="{BB962C8B-B14F-4D97-AF65-F5344CB8AC3E}">
@@ -12370,7 +13187,7 @@
                 <a:latin typeface="맑은 고딕"/>
                 <a:ea typeface="맑은 고딕"/>
               </a:rPr>
-              <a:t>23. 실습 — 문제·요구사항·해결책</a:t>
+              <a:t>23. AI 기반 소프트웨어공학</a:t>
             </a:r>
           </a:p>
         </p:txBody>
@@ -12528,7 +13345,7 @@
                 <a:latin typeface="맑은 고딕"/>
                 <a:ea typeface="맑은 고딕"/>
               </a:rPr>
-              <a:t>요청에 포함된 해결책과 그 배경의 문제·요구사항·제약을 구분하고, </a:t>
+              <a:t>이 과정에서는 AI 기반 개발을 </a:t>
             </a:r>
             <a:r>
               <a:rPr sz="1800" b="1">
@@ -12538,7 +13355,7 @@
                 <a:latin typeface="맑은 고딕"/>
                 <a:ea typeface="맑은 고딕"/>
               </a:rPr>
-              <a:t>확인이 필요한 가정</a:t>
+              <a:t>인간의 판단 책임과 AI의 실행·지원 역할을 배치하는 관점</a:t>
             </a:r>
             <a:r>
               <a:rPr sz="1800" b="0">
@@ -12548,7 +13365,7 @@
                 <a:latin typeface="맑은 고딕"/>
                 <a:ea typeface="맑은 고딕"/>
               </a:rPr>
-              <a:t>을 식별한다.</a:t>
+              <a:t>으로 다룬다. 아래 구분은 보편적으로 확정된 역할 표준이 아니라 검증과 책임 소재를 명확히 하기 위한 운영 원칙이다.</a:t>
             </a:r>
           </a:p>
           <a:p>
@@ -12564,6 +13381,16 @@
               <a:buChar char=""/>
             </a:pPr>
             <a:r>
+              <a:rPr sz="1800" b="1">
+                <a:solidFill>
+                  <a:srgbClr val="000000"/>
+                </a:solidFill>
+                <a:latin typeface="맑은 고딕"/>
+                <a:ea typeface="맑은 고딕"/>
+              </a:rPr>
+              <a:t>인간이 최종 책임지는 판단</a:t>
+            </a:r>
+            <a:r>
               <a:rPr sz="1800" b="0">
                 <a:solidFill>
                   <a:srgbClr val="000000"/>
@@ -12571,7 +13398,17 @@
                 <a:latin typeface="맑은 고딕"/>
                 <a:ea typeface="맑은 고딕"/>
               </a:rPr>
-              <a:t>온라인 쇼핑몰에 다음 요청이 들어왔다.</a:t>
+              <a:t> —</a:t>
+            </a:r>
+            <a:r>
+              <a:rPr sz="1600" b="0">
+                <a:solidFill>
+                  <a:srgbClr val="000000"/>
+                </a:solidFill>
+                <a:latin typeface="맑은 고딕"/>
+                <a:ea typeface="맑은 고딕"/>
+              </a:rPr>
+              <a:t> 비전과 가치, 위험 수용, 최종 의사결정과 책임</a:t>
             </a:r>
           </a:p>
           <a:p>
@@ -12587,6 +13424,16 @@
               <a:buChar char=""/>
             </a:pPr>
             <a:r>
+              <a:rPr sz="1800" b="1">
+                <a:solidFill>
+                  <a:srgbClr val="000000"/>
+                </a:solidFill>
+                <a:latin typeface="맑은 고딕"/>
+                <a:ea typeface="맑은 고딕"/>
+              </a:rPr>
+              <a:t>인간과 AI의 협업</a:t>
+            </a:r>
+            <a:r>
               <a:rPr sz="1800" b="0">
                 <a:solidFill>
                   <a:srgbClr val="000000"/>
@@ -12594,17 +13441,17 @@
                 <a:latin typeface="맑은 고딕"/>
                 <a:ea typeface="맑은 고딕"/>
               </a:rPr>
-              <a:t>“주문 목록에 취소 버튼을 추가해 주세요.” </a:t>
-            </a:r>
-            <a:r>
-              <a:rPr sz="1400" b="0">
-                <a:solidFill>
-                  <a:srgbClr val="000000"/>
-                </a:solidFill>
-                <a:latin typeface="맑은 고딕"/>
-                <a:ea typeface="맑은 고딕"/>
-              </a:rPr>
-              <a:t>(조건: 배송 시작 전 주문만 취소 가능, 취소 시 결제 금액 환불)</a:t>
+              <a:t> —</a:t>
+            </a:r>
+            <a:r>
+              <a:rPr sz="1600" b="0">
+                <a:solidFill>
+                  <a:srgbClr val="000000"/>
+                </a:solidFill>
+                <a:latin typeface="맑은 고딕"/>
+                <a:ea typeface="맑은 고딕"/>
+              </a:rPr>
+              <a:t> 요구사항, 도메인 모델·온톨로지, 아키텍처·설계, 테스트·검토</a:t>
             </a:r>
           </a:p>
           <a:p>
@@ -12627,7 +13474,7 @@
                 <a:latin typeface="맑은 고딕"/>
                 <a:ea typeface="맑은 고딕"/>
               </a:rPr>
-              <a:t>과제</a:t>
+              <a:t>AI가 주도할 수 있는 실행</a:t>
             </a:r>
             <a:r>
               <a:rPr sz="1800" b="0">
@@ -12647,107 +13494,140 @@
                 <a:latin typeface="맑은 고딕"/>
                 <a:ea typeface="맑은 고딕"/>
               </a:rPr>
-              <a:t> 구현 전에 </a:t>
-            </a:r>
-            <a:r>
-              <a:rPr sz="1200" b="0">
-                <a:solidFill>
-                  <a:srgbClr val="000000"/>
-                </a:solidFill>
-                <a:latin typeface="맑은 고딕"/>
-                <a:ea typeface="맑은 고딕"/>
-              </a:rPr>
-              <a:t>(1)</a:t>
-            </a:r>
-            <a:r>
-              <a:rPr sz="1600" b="0">
-                <a:solidFill>
-                  <a:srgbClr val="000000"/>
-                </a:solidFill>
-                <a:latin typeface="맑은 고딕"/>
-                <a:ea typeface="맑은 고딕"/>
-              </a:rPr>
-              <a:t> 문제 </a:t>
-            </a:r>
-            <a:r>
-              <a:rPr sz="1200" b="0">
-                <a:solidFill>
-                  <a:srgbClr val="000000"/>
-                </a:solidFill>
-                <a:latin typeface="맑은 고딕"/>
-                <a:ea typeface="맑은 고딕"/>
-              </a:rPr>
-              <a:t>(2)</a:t>
-            </a:r>
-            <a:r>
-              <a:rPr sz="1600" b="0">
-                <a:solidFill>
-                  <a:srgbClr val="000000"/>
-                </a:solidFill>
-                <a:latin typeface="맑은 고딕"/>
-                <a:ea typeface="맑은 고딕"/>
-              </a:rPr>
-              <a:t> 요구사항 </a:t>
-            </a:r>
-            <a:r>
-              <a:rPr sz="1200" b="0">
-                <a:solidFill>
-                  <a:srgbClr val="000000"/>
-                </a:solidFill>
-                <a:latin typeface="맑은 고딕"/>
-                <a:ea typeface="맑은 고딕"/>
-              </a:rPr>
-              <a:t>(3)</a:t>
-            </a:r>
-            <a:r>
-              <a:rPr sz="1600" b="0">
-                <a:solidFill>
-                  <a:srgbClr val="000000"/>
-                </a:solidFill>
-                <a:latin typeface="맑은 고딕"/>
-                <a:ea typeface="맑은 고딕"/>
-              </a:rPr>
-              <a:t> 제약 </a:t>
-            </a:r>
-            <a:r>
-              <a:rPr sz="1200" b="0">
-                <a:solidFill>
-                  <a:srgbClr val="000000"/>
-                </a:solidFill>
-                <a:latin typeface="맑은 고딕"/>
-                <a:ea typeface="맑은 고딕"/>
-              </a:rPr>
-              <a:t>(4)</a:t>
-            </a:r>
-            <a:r>
-              <a:rPr sz="1600" b="0">
-                <a:solidFill>
-                  <a:srgbClr val="000000"/>
-                </a:solidFill>
-                <a:latin typeface="맑은 고딕"/>
-                <a:ea typeface="맑은 고딕"/>
-              </a:rPr>
-              <a:t> 해결책을 구분하고, </a:t>
-            </a:r>
-            <a:r>
-              <a:rPr sz="1600" b="0">
-                <a:solidFill>
-                  <a:srgbClr val="000000"/>
-                </a:solidFill>
-                <a:latin typeface="맑은 고딕"/>
-                <a:ea typeface="맑은 고딕"/>
-              </a:rPr>
-              <a:t>취소 버튼</a:t>
-            </a:r>
-            <a:r>
-              <a:rPr sz="1600" b="0">
-                <a:solidFill>
-                  <a:srgbClr val="000000"/>
-                </a:solidFill>
-                <a:latin typeface="맑은 고딕"/>
-                <a:ea typeface="맑은 고딕"/>
-              </a:rPr>
-              <a:t>이 어느 항목에 해당하는지 판단한다. 주어진 사실과 추정을 구분해 추정을 확인할 질문을 하나 작성한다.</a:t>
+              <a:t> 코드 생성·변환, 정적 검사, 테스트 실행, 자동화</a:t>
+            </a:r>
+          </a:p>
+          <a:p>
+            <a:pPr lvl="2" marL="723900" indent="-368300">
+              <a:spcBef>
+                <a:spcPts val="600"/>
+              </a:spcBef>
+              <a:spcAft>
+                <a:spcPts val="600"/>
+              </a:spcAft>
+              <a:buSzPct val="90000"/>
+              <a:buFont typeface="Wingdings" pitchFamily="2" charset="2"/>
+              <a:buChar char=""/>
+            </a:pPr>
+            <a:r>
+              <a:rPr sz="1800" b="0">
+                <a:solidFill>
+                  <a:srgbClr val="000000"/>
+                </a:solidFill>
+                <a:latin typeface="맑은 고딕"/>
+                <a:ea typeface="맑은 고딕"/>
+              </a:rPr>
+              <a:t>핵심은 </a:t>
+            </a:r>
+            <a:r>
+              <a:rPr sz="1800" b="1">
+                <a:solidFill>
+                  <a:srgbClr val="000000"/>
+                </a:solidFill>
+                <a:latin typeface="맑은 고딕"/>
+                <a:ea typeface="맑은 고딕"/>
+              </a:rPr>
+              <a:t>누가 코드를 작성하느냐보다 누가 의미·경계·위험을 판단하고 결과를 검증하느냐</a:t>
+            </a:r>
+            <a:r>
+              <a:rPr sz="1800" b="0">
+                <a:solidFill>
+                  <a:srgbClr val="000000"/>
+                </a:solidFill>
+                <a:latin typeface="맑은 고딕"/>
+                <a:ea typeface="맑은 고딕"/>
+              </a:rPr>
+              <a:t>에 있다. 실행할 때는 필요한 맥락·제약을 </a:t>
+            </a:r>
+            <a:r>
+              <a:rPr sz="1800" b="1">
+                <a:solidFill>
+                  <a:srgbClr val="000000"/>
+                </a:solidFill>
+                <a:latin typeface="맑은 고딕"/>
+                <a:ea typeface="맑은 고딕"/>
+              </a:rPr>
+              <a:t>가드레일</a:t>
+            </a:r>
+            <a:r>
+              <a:rPr sz="1400" b="1">
+                <a:solidFill>
+                  <a:srgbClr val="000000"/>
+                </a:solidFill>
+                <a:latin typeface="맑은 고딕"/>
+                <a:ea typeface="맑은 고딕"/>
+              </a:rPr>
+              <a:t>(Guardrail)</a:t>
+            </a:r>
+            <a:r>
+              <a:rPr sz="1800" b="0">
+                <a:solidFill>
+                  <a:srgbClr val="000000"/>
+                </a:solidFill>
+                <a:latin typeface="맑은 고딕"/>
+                <a:ea typeface="맑은 고딕"/>
+              </a:rPr>
+              <a:t>에 담고, </a:t>
+            </a:r>
+            <a:r>
+              <a:rPr sz="1800" b="1">
+                <a:solidFill>
+                  <a:srgbClr val="000000"/>
+                </a:solidFill>
+                <a:latin typeface="맑은 고딕"/>
+                <a:ea typeface="맑은 고딕"/>
+              </a:rPr>
+              <a:t>에이전트</a:t>
+            </a:r>
+            <a:r>
+              <a:rPr sz="1400" b="1">
+                <a:solidFill>
+                  <a:srgbClr val="000000"/>
+                </a:solidFill>
+                <a:latin typeface="맑은 고딕"/>
+                <a:ea typeface="맑은 고딕"/>
+              </a:rPr>
+              <a:t>(Agent)</a:t>
+            </a:r>
+            <a:r>
+              <a:rPr sz="1800" b="0">
+                <a:solidFill>
+                  <a:srgbClr val="000000"/>
+                </a:solidFill>
+                <a:latin typeface="맑은 고딕"/>
+                <a:ea typeface="맑은 고딕"/>
+              </a:rPr>
+              <a:t>의 작업을 </a:t>
+            </a:r>
+            <a:r>
+              <a:rPr sz="1800" b="1">
+                <a:solidFill>
+                  <a:srgbClr val="000000"/>
+                </a:solidFill>
+                <a:latin typeface="맑은 고딕"/>
+                <a:ea typeface="맑은 고딕"/>
+              </a:rPr>
+              <a:t>실행·검증 환경</a:t>
+            </a:r>
+            <a:r>
+              <a:rPr sz="1400" b="1">
+                <a:solidFill>
+                  <a:srgbClr val="000000"/>
+                </a:solidFill>
+                <a:latin typeface="맑은 고딕"/>
+                <a:ea typeface="맑은 고딕"/>
+              </a:rPr>
+              <a:t>(Harness)</a:t>
+            </a:r>
+            <a:r>
+              <a:rPr sz="1800" b="0">
+                <a:solidFill>
+                  <a:srgbClr val="000000"/>
+                </a:solidFill>
+                <a:latin typeface="맑은 고딕"/>
+                <a:ea typeface="맑은 고딕"/>
+              </a:rPr>
+              <a:t>에서 확인한다.</a:t>
             </a:r>
           </a:p>
         </p:txBody>
@@ -12817,17 +13697,7 @@
                 <a:latin typeface="맑은 고딕"/>
                 <a:ea typeface="맑은 고딕"/>
               </a:rPr>
-              <a:t>24. 실습 — 검토 예시</a:t>
-            </a:r>
-            <a:r>
-              <a:rPr sz="2000" b="1">
-                <a:solidFill>
-                  <a:srgbClr val="000000"/>
-                </a:solidFill>
-                <a:latin typeface="맑은 고딕"/>
-                <a:ea typeface="맑은 고딕"/>
-              </a:rPr>
-              <a:t>(모범답안)</a:t>
+              <a:t>24. 실습 — 문제·요구사항·해결책</a:t>
             </a:r>
           </a:p>
         </p:txBody>
@@ -12985,7 +13855,7 @@
                 <a:latin typeface="맑은 고딕"/>
                 <a:ea typeface="맑은 고딕"/>
               </a:rPr>
-              <a:t>23번 실습의 </a:t>
+              <a:t>요청에 포함된 해결책과 그 배경의 문제·요구사항·제약을 구분하고, </a:t>
             </a:r>
             <a:r>
               <a:rPr sz="1800" b="1">
@@ -12995,7 +13865,7 @@
                 <a:latin typeface="맑은 고딕"/>
                 <a:ea typeface="맑은 고딕"/>
               </a:rPr>
-              <a:t>하나의 모범 예</a:t>
+              <a:t>확인이 필요한 가정</a:t>
             </a:r>
             <a:r>
               <a:rPr sz="1800" b="0">
@@ -13005,37 +13875,7 @@
                 <a:latin typeface="맑은 고딕"/>
                 <a:ea typeface="맑은 고딕"/>
               </a:rPr>
-              <a:t>다 —</a:t>
-            </a:r>
-            <a:r>
-              <a:rPr sz="1600" b="0">
-                <a:solidFill>
-                  <a:srgbClr val="000000"/>
-                </a:solidFill>
-                <a:latin typeface="맑은 고딕"/>
-                <a:ea typeface="맑은 고딕"/>
-              </a:rPr>
-              <a:t> 유일한 정답이 아니라, "수준을 구분했는가"를 보여주는 예시다. 아래는 </a:t>
-            </a:r>
-            <a:r>
-              <a:rPr sz="1600" b="1">
-                <a:solidFill>
-                  <a:srgbClr val="000000"/>
-                </a:solidFill>
-                <a:latin typeface="맑은 고딕"/>
-                <a:ea typeface="맑은 고딕"/>
-              </a:rPr>
-              <a:t>고객이 현재 직접 취소할 수 없다는 가정</a:t>
-            </a:r>
-            <a:r>
-              <a:rPr sz="1600" b="0">
-                <a:solidFill>
-                  <a:srgbClr val="000000"/>
-                </a:solidFill>
-                <a:latin typeface="맑은 고딕"/>
-                <a:ea typeface="맑은 고딕"/>
-              </a:rPr>
-              <a:t>에 따른 검토이며, 실제 원인은 요청자에게 확인해야 한다.</a:t>
+              <a:t>을 식별한다.</a:t>
             </a:r>
           </a:p>
           <a:p>
@@ -13051,16 +13891,6 @@
               <a:buChar char=""/>
             </a:pPr>
             <a:r>
-              <a:rPr sz="1800" b="1">
-                <a:solidFill>
-                  <a:srgbClr val="000000"/>
-                </a:solidFill>
-                <a:latin typeface="맑은 고딕"/>
-                <a:ea typeface="맑은 고딕"/>
-              </a:rPr>
-              <a:t>문제</a:t>
-            </a:r>
-            <a:r>
               <a:rPr sz="1800" b="0">
                 <a:solidFill>
                   <a:srgbClr val="000000"/>
@@ -13068,17 +13898,7 @@
                 <a:latin typeface="맑은 고딕"/>
                 <a:ea typeface="맑은 고딕"/>
               </a:rPr>
-              <a:t> —</a:t>
-            </a:r>
-            <a:r>
-              <a:rPr sz="1600" b="0">
-                <a:solidFill>
-                  <a:srgbClr val="000000"/>
-                </a:solidFill>
-                <a:latin typeface="맑은 고딕"/>
-                <a:ea typeface="맑은 고딕"/>
-              </a:rPr>
-              <a:t> 고객이 취소 가능한 주문을 직접 취소할 수 없음</a:t>
+              <a:t>온라인 쇼핑몰에 다음 요청이 들어왔다.</a:t>
             </a:r>
           </a:p>
           <a:p>
@@ -13094,16 +13914,6 @@
               <a:buChar char=""/>
             </a:pPr>
             <a:r>
-              <a:rPr sz="1800" b="1">
-                <a:solidFill>
-                  <a:srgbClr val="000000"/>
-                </a:solidFill>
-                <a:latin typeface="맑은 고딕"/>
-                <a:ea typeface="맑은 고딕"/>
-              </a:rPr>
-              <a:t>요구사항</a:t>
-            </a:r>
-            <a:r>
               <a:rPr sz="1800" b="0">
                 <a:solidFill>
                   <a:srgbClr val="000000"/>
@@ -13111,17 +13921,17 @@
                 <a:latin typeface="맑은 고딕"/>
                 <a:ea typeface="맑은 고딕"/>
               </a:rPr>
-              <a:t> —</a:t>
-            </a:r>
-            <a:r>
-              <a:rPr sz="1600" b="0">
-                <a:solidFill>
-                  <a:srgbClr val="000000"/>
-                </a:solidFill>
-                <a:latin typeface="맑은 고딕"/>
-                <a:ea typeface="맑은 고딕"/>
-              </a:rPr>
-              <a:t> 배송 시작 전 주문을 고객이 직접 취소하고 결제 금액을 환불받을 수 있어야 함</a:t>
+              <a:t>“주문 목록에 취소 버튼을 추가해 주세요.” </a:t>
+            </a:r>
+            <a:r>
+              <a:rPr sz="1400" b="0">
+                <a:solidFill>
+                  <a:srgbClr val="000000"/>
+                </a:solidFill>
+                <a:latin typeface="맑은 고딕"/>
+                <a:ea typeface="맑은 고딕"/>
+              </a:rPr>
+              <a:t>(조건: 배송 시작 전 주문만 취소 가능, 취소 시 결제 금액 환불)</a:t>
             </a:r>
           </a:p>
           <a:p>
@@ -13144,7 +13954,7 @@
                 <a:latin typeface="맑은 고딕"/>
                 <a:ea typeface="맑은 고딕"/>
               </a:rPr>
-              <a:t>제약</a:t>
+              <a:t>과제</a:t>
             </a:r>
             <a:r>
               <a:rPr sz="1800" b="0">
@@ -13164,40 +13974,17 @@
                 <a:latin typeface="맑은 고딕"/>
                 <a:ea typeface="맑은 고딕"/>
               </a:rPr>
-              <a:t> 배송 시작 후 일반 취소 불가</a:t>
-            </a:r>
-          </a:p>
-          <a:p>
-            <a:pPr lvl="2" marL="723900" indent="-368300">
-              <a:spcBef>
-                <a:spcPts val="600"/>
-              </a:spcBef>
-              <a:spcAft>
-                <a:spcPts val="600"/>
-              </a:spcAft>
-              <a:buSzPct val="90000"/>
-              <a:buFont typeface="Wingdings" pitchFamily="2" charset="2"/>
-              <a:buChar char=""/>
-            </a:pPr>
-            <a:r>
-              <a:rPr sz="1800" b="1">
-                <a:solidFill>
-                  <a:srgbClr val="000000"/>
-                </a:solidFill>
-                <a:latin typeface="맑은 고딕"/>
-                <a:ea typeface="맑은 고딕"/>
-              </a:rPr>
-              <a:t>해결책</a:t>
-            </a:r>
-            <a:r>
-              <a:rPr sz="1800" b="0">
-                <a:solidFill>
-                  <a:srgbClr val="000000"/>
-                </a:solidFill>
-                <a:latin typeface="맑은 고딕"/>
-                <a:ea typeface="맑은 고딕"/>
-              </a:rPr>
-              <a:t> —</a:t>
+              <a:t> 구현 전에 </a:t>
+            </a:r>
+            <a:r>
+              <a:rPr sz="1200" b="0">
+                <a:solidFill>
+                  <a:srgbClr val="000000"/>
+                </a:solidFill>
+                <a:latin typeface="맑은 고딕"/>
+                <a:ea typeface="맑은 고딕"/>
+              </a:rPr>
+              <a:t>(1)</a:t>
             </a:r>
             <a:r>
               <a:rPr sz="1600" b="0">
@@ -13207,7 +13994,7 @@
                 <a:latin typeface="맑은 고딕"/>
                 <a:ea typeface="맑은 고딕"/>
               </a:rPr>
-              <a:t> 취소 버튼</a:t>
+              <a:t> 문제 </a:t>
             </a:r>
             <a:r>
               <a:rPr sz="1200" b="0">
@@ -13217,40 +14004,7 @@
                 <a:latin typeface="맑은 고딕"/>
                 <a:ea typeface="맑은 고딕"/>
               </a:rPr>
-              <a:t>(다른 해결책도 가능. 예: 고객센터 취소 요청)</a:t>
-            </a:r>
-          </a:p>
-          <a:p>
-            <a:pPr lvl="2" marL="723900" indent="-368300">
-              <a:spcBef>
-                <a:spcPts val="600"/>
-              </a:spcBef>
-              <a:spcAft>
-                <a:spcPts val="600"/>
-              </a:spcAft>
-              <a:buSzPct val="90000"/>
-              <a:buFont typeface="Wingdings" pitchFamily="2" charset="2"/>
-              <a:buChar char=""/>
-            </a:pPr>
-            <a:r>
-              <a:rPr sz="1800" b="1">
-                <a:solidFill>
-                  <a:srgbClr val="000000"/>
-                </a:solidFill>
-                <a:latin typeface="맑은 고딕"/>
-                <a:ea typeface="맑은 고딕"/>
-              </a:rPr>
-              <a:t>확인 질문</a:t>
-            </a:r>
-            <a:r>
-              <a:rPr sz="1800" b="0">
-                <a:solidFill>
-                  <a:srgbClr val="000000"/>
-                </a:solidFill>
-                <a:latin typeface="맑은 고딕"/>
-                <a:ea typeface="맑은 고딕"/>
-              </a:rPr>
-              <a:t> —</a:t>
+              <a:t>(2)</a:t>
             </a:r>
             <a:r>
               <a:rPr sz="1600" b="0">
@@ -13260,7 +14014,67 @@
                 <a:latin typeface="맑은 고딕"/>
                 <a:ea typeface="맑은 고딕"/>
               </a:rPr>
-              <a:t> 현재 취소 경로가 없는가, 아니면 찾기 어려운가?</a:t>
+              <a:t> 요구사항 </a:t>
+            </a:r>
+            <a:r>
+              <a:rPr sz="1200" b="0">
+                <a:solidFill>
+                  <a:srgbClr val="000000"/>
+                </a:solidFill>
+                <a:latin typeface="맑은 고딕"/>
+                <a:ea typeface="맑은 고딕"/>
+              </a:rPr>
+              <a:t>(3)</a:t>
+            </a:r>
+            <a:r>
+              <a:rPr sz="1600" b="0">
+                <a:solidFill>
+                  <a:srgbClr val="000000"/>
+                </a:solidFill>
+                <a:latin typeface="맑은 고딕"/>
+                <a:ea typeface="맑은 고딕"/>
+              </a:rPr>
+              <a:t> 제약 </a:t>
+            </a:r>
+            <a:r>
+              <a:rPr sz="1200" b="0">
+                <a:solidFill>
+                  <a:srgbClr val="000000"/>
+                </a:solidFill>
+                <a:latin typeface="맑은 고딕"/>
+                <a:ea typeface="맑은 고딕"/>
+              </a:rPr>
+              <a:t>(4)</a:t>
+            </a:r>
+            <a:r>
+              <a:rPr sz="1600" b="0">
+                <a:solidFill>
+                  <a:srgbClr val="000000"/>
+                </a:solidFill>
+                <a:latin typeface="맑은 고딕"/>
+                <a:ea typeface="맑은 고딕"/>
+              </a:rPr>
+              <a:t> 해결책을 구분하고, </a:t>
+            </a:r>
+            <a:r>
+              <a:rPr sz="1600" b="0">
+                <a:solidFill>
+                  <a:srgbClr val="000000"/>
+                </a:solidFill>
+                <a:latin typeface="맑은 고딕"/>
+                <a:ea typeface="맑은 고딕"/>
+              </a:rPr>
+              <a:t>취소 버튼</a:t>
+            </a:r>
+            <a:r>
+              <a:rPr sz="1600" b="0">
+                <a:solidFill>
+                  <a:srgbClr val="000000"/>
+                </a:solidFill>
+                <a:latin typeface="맑은 고딕"/>
+                <a:ea typeface="맑은 고딕"/>
+              </a:rPr>
+              <a:t>이 어느 항목에 해당하는지 판단한다. 주어진 사실과 추정을 구분해 추정을 확인할 질문을 하나 작성한다.</a:t>
             </a:r>
           </a:p>
         </p:txBody>
@@ -13330,7 +14144,17 @@
                 <a:latin typeface="맑은 고딕"/>
                 <a:ea typeface="맑은 고딕"/>
               </a:rPr>
-              <a:t>25. 요약</a:t>
+              <a:t>25. 실습 — 검토 예시</a:t>
+            </a:r>
+            <a:r>
+              <a:rPr sz="2000" b="1">
+                <a:solidFill>
+                  <a:srgbClr val="000000"/>
+                </a:solidFill>
+                <a:latin typeface="맑은 고딕"/>
+                <a:ea typeface="맑은 고딕"/>
+              </a:rPr>
+              <a:t>(모범답안)</a:t>
             </a:r>
           </a:p>
         </p:txBody>
@@ -13366,6 +14190,509 @@
                 </a:solidFill>
               </a:rPr>
               <a:t>- 26 -</a:t>
+            </a:r>
+          </a:p>
+        </p:txBody>
+      </p:sp>
+      <p:sp>
+        <p:nvSpPr>
+          <p:cNvPr id="5" name="텍스트 개체 틀 4">
+            <a:extLst>
+              <a:ext uri="{FF2B5EF4-FFF2-40B4-BE49-F238E27FC236}">
+                <a16:creationId xmlns:a16="http://schemas.microsoft.com/office/drawing/2014/main" id="{D66274C8-E16F-5AEB-614B-D8D32DA3E8C6}"/>
+              </a:ext>
+            </a:extLst>
+          </p:cNvPr>
+          <p:cNvSpPr>
+            <a:spLocks noGrp="1"/>
+          </p:cNvSpPr>
+          <p:nvPr>
+            <p:ph type="body" sz="quarter" idx="11"/>
+          </p:nvPr>
+        </p:nvSpPr>
+        <p:spPr/>
+        <p:txBody>
+          <a:bodyPr/>
+          <a:lstStyle/>
+          <a:p>
+            <a:r>
+              <a:rPr kumimoji="1" lang="en-US" altLang="ko-KR" sz="1400" dirty="0" err="1"/>
+              <a:t>01. OOAD 개요</a:t>
+            </a:r>
+          </a:p>
+        </p:txBody>
+      </p:sp>
+      <p:sp>
+        <p:nvSpPr>
+          <p:cNvPr id="6" name="텍스트 개체 틀 5">
+            <a:extLst>
+              <a:ext uri="{FF2B5EF4-FFF2-40B4-BE49-F238E27FC236}">
+                <a16:creationId xmlns:a16="http://schemas.microsoft.com/office/drawing/2014/main" id="{A24E58E1-194B-A320-AEEE-24D08685BB67}"/>
+              </a:ext>
+            </a:extLst>
+          </p:cNvPr>
+          <p:cNvSpPr>
+            <a:spLocks noGrp="1"/>
+          </p:cNvSpPr>
+          <p:nvPr>
+            <p:ph type="body" sz="quarter" idx="12"/>
+          </p:nvPr>
+        </p:nvSpPr>
+        <p:spPr/>
+        <p:txBody>
+          <a:bodyPr/>
+          <a:lstStyle/>
+          <a:p>
+            <a:endParaRPr kumimoji="1" lang="ko-KR" altLang="en-US" dirty="0"/>
+          </a:p>
+        </p:txBody>
+      </p:sp>
+      <p:sp>
+        <p:nvSpPr>
+          <p:cNvPr id="7" name="텍스트 개체 틀 6">
+            <a:extLst>
+              <a:ext uri="{FF2B5EF4-FFF2-40B4-BE49-F238E27FC236}">
+                <a16:creationId xmlns:a16="http://schemas.microsoft.com/office/drawing/2014/main" id="{A219F420-613B-6234-45F6-0955A9A4505F}"/>
+              </a:ext>
+            </a:extLst>
+          </p:cNvPr>
+          <p:cNvSpPr>
+            <a:spLocks noGrp="1"/>
+          </p:cNvSpPr>
+          <p:nvPr>
+            <p:ph type="body" sz="quarter" idx="13"/>
+          </p:nvPr>
+        </p:nvSpPr>
+        <p:spPr/>
+        <p:txBody>
+          <a:bodyPr/>
+          <a:lstStyle/>
+          <a:p>
+            <a:endParaRPr kumimoji="1" lang="en-US" altLang="ko-KR" dirty="0"/>
+          </a:p>
+        </p:txBody>
+      </p:sp>
+      <p:sp>
+        <p:nvSpPr>
+          <p:cNvPr id="8" name="내용 개체 틀 7">
+            <a:extLst>
+              <a:ext uri="{FF2B5EF4-FFF2-40B4-BE49-F238E27FC236}">
+                <a16:creationId xmlns:a16="http://schemas.microsoft.com/office/drawing/2014/main" id="{BEBA2C4A-B0BF-F2E4-EA6E-614C99CBA184}"/>
+              </a:ext>
+            </a:extLst>
+          </p:cNvPr>
+          <p:cNvSpPr>
+            <a:spLocks noGrp="1"/>
+          </p:cNvSpPr>
+          <p:nvPr>
+            <p:ph idx="1"/>
+          </p:nvPr>
+        </p:nvSpPr>
+        <p:spPr/>
+        <p:txBody>
+          <a:bodyPr>
+            <a:normAutofit/>
+          </a:bodyPr>
+          <a:lstStyle/>
+          <a:p>
+            <a:pPr marL="0" indent="0">
+              <a:spcBef>
+                <a:spcPts val="600"/>
+              </a:spcBef>
+              <a:spcAft>
+                <a:spcPts val="600"/>
+              </a:spcAft>
+              <a:buNone/>
+            </a:pPr>
+            <a:r>
+              <a:rPr sz="1800" b="0">
+                <a:solidFill>
+                  <a:srgbClr val="000000"/>
+                </a:solidFill>
+                <a:latin typeface="맑은 고딕"/>
+                <a:ea typeface="맑은 고딕"/>
+              </a:rPr>
+              <a:t>24번 실습의 </a:t>
+            </a:r>
+            <a:r>
+              <a:rPr sz="1800" b="1">
+                <a:solidFill>
+                  <a:srgbClr val="000000"/>
+                </a:solidFill>
+                <a:latin typeface="맑은 고딕"/>
+                <a:ea typeface="맑은 고딕"/>
+              </a:rPr>
+              <a:t>하나의 모범 예</a:t>
+            </a:r>
+            <a:r>
+              <a:rPr sz="1800" b="0">
+                <a:solidFill>
+                  <a:srgbClr val="000000"/>
+                </a:solidFill>
+                <a:latin typeface="맑은 고딕"/>
+                <a:ea typeface="맑은 고딕"/>
+              </a:rPr>
+              <a:t>다 —</a:t>
+            </a:r>
+            <a:r>
+              <a:rPr sz="1600" b="0">
+                <a:solidFill>
+                  <a:srgbClr val="000000"/>
+                </a:solidFill>
+                <a:latin typeface="맑은 고딕"/>
+                <a:ea typeface="맑은 고딕"/>
+              </a:rPr>
+              <a:t> 유일한 정답이 아니라, "수준을 구분했는가"를 보여주는 예시다. 아래는 </a:t>
+            </a:r>
+            <a:r>
+              <a:rPr sz="1600" b="1">
+                <a:solidFill>
+                  <a:srgbClr val="000000"/>
+                </a:solidFill>
+                <a:latin typeface="맑은 고딕"/>
+                <a:ea typeface="맑은 고딕"/>
+              </a:rPr>
+              <a:t>고객이 현재 직접 취소할 수 없다는 가정</a:t>
+            </a:r>
+            <a:r>
+              <a:rPr sz="1600" b="0">
+                <a:solidFill>
+                  <a:srgbClr val="000000"/>
+                </a:solidFill>
+                <a:latin typeface="맑은 고딕"/>
+                <a:ea typeface="맑은 고딕"/>
+              </a:rPr>
+              <a:t>에 따른 검토이며, 실제 원인은 요청자에게 확인해야 한다.</a:t>
+            </a:r>
+          </a:p>
+          <a:p>
+            <a:pPr lvl="2" marL="723900" indent="-368300">
+              <a:spcBef>
+                <a:spcPts val="600"/>
+              </a:spcBef>
+              <a:spcAft>
+                <a:spcPts val="600"/>
+              </a:spcAft>
+              <a:buSzPct val="90000"/>
+              <a:buFont typeface="Wingdings" pitchFamily="2" charset="2"/>
+              <a:buChar char=""/>
+            </a:pPr>
+            <a:r>
+              <a:rPr sz="1800" b="1">
+                <a:solidFill>
+                  <a:srgbClr val="000000"/>
+                </a:solidFill>
+                <a:latin typeface="맑은 고딕"/>
+                <a:ea typeface="맑은 고딕"/>
+              </a:rPr>
+              <a:t>문제</a:t>
+            </a:r>
+            <a:r>
+              <a:rPr sz="1800" b="0">
+                <a:solidFill>
+                  <a:srgbClr val="000000"/>
+                </a:solidFill>
+                <a:latin typeface="맑은 고딕"/>
+                <a:ea typeface="맑은 고딕"/>
+              </a:rPr>
+              <a:t> —</a:t>
+            </a:r>
+            <a:r>
+              <a:rPr sz="1600" b="0">
+                <a:solidFill>
+                  <a:srgbClr val="000000"/>
+                </a:solidFill>
+                <a:latin typeface="맑은 고딕"/>
+                <a:ea typeface="맑은 고딕"/>
+              </a:rPr>
+              <a:t> 고객이 취소 가능한 주문을 직접 취소할 수 없음</a:t>
+            </a:r>
+          </a:p>
+          <a:p>
+            <a:pPr lvl="2" marL="723900" indent="-368300">
+              <a:spcBef>
+                <a:spcPts val="600"/>
+              </a:spcBef>
+              <a:spcAft>
+                <a:spcPts val="600"/>
+              </a:spcAft>
+              <a:buSzPct val="90000"/>
+              <a:buFont typeface="Wingdings" pitchFamily="2" charset="2"/>
+              <a:buChar char=""/>
+            </a:pPr>
+            <a:r>
+              <a:rPr sz="1800" b="1">
+                <a:solidFill>
+                  <a:srgbClr val="000000"/>
+                </a:solidFill>
+                <a:latin typeface="맑은 고딕"/>
+                <a:ea typeface="맑은 고딕"/>
+              </a:rPr>
+              <a:t>요구사항</a:t>
+            </a:r>
+            <a:r>
+              <a:rPr sz="1800" b="0">
+                <a:solidFill>
+                  <a:srgbClr val="000000"/>
+                </a:solidFill>
+                <a:latin typeface="맑은 고딕"/>
+                <a:ea typeface="맑은 고딕"/>
+              </a:rPr>
+              <a:t> —</a:t>
+            </a:r>
+            <a:r>
+              <a:rPr sz="1600" b="0">
+                <a:solidFill>
+                  <a:srgbClr val="000000"/>
+                </a:solidFill>
+                <a:latin typeface="맑은 고딕"/>
+                <a:ea typeface="맑은 고딕"/>
+              </a:rPr>
+              <a:t> 배송 시작 전 주문을 고객이 직접 취소하고 결제 금액을 환불받을 수 있어야 함</a:t>
+            </a:r>
+          </a:p>
+          <a:p>
+            <a:pPr lvl="2" marL="723900" indent="-368300">
+              <a:spcBef>
+                <a:spcPts val="600"/>
+              </a:spcBef>
+              <a:spcAft>
+                <a:spcPts val="600"/>
+              </a:spcAft>
+              <a:buSzPct val="90000"/>
+              <a:buFont typeface="Wingdings" pitchFamily="2" charset="2"/>
+              <a:buChar char=""/>
+            </a:pPr>
+            <a:r>
+              <a:rPr sz="1800" b="1">
+                <a:solidFill>
+                  <a:srgbClr val="000000"/>
+                </a:solidFill>
+                <a:latin typeface="맑은 고딕"/>
+                <a:ea typeface="맑은 고딕"/>
+              </a:rPr>
+              <a:t>제약</a:t>
+            </a:r>
+            <a:r>
+              <a:rPr sz="1800" b="0">
+                <a:solidFill>
+                  <a:srgbClr val="000000"/>
+                </a:solidFill>
+                <a:latin typeface="맑은 고딕"/>
+                <a:ea typeface="맑은 고딕"/>
+              </a:rPr>
+              <a:t> —</a:t>
+            </a:r>
+            <a:r>
+              <a:rPr sz="1600" b="0">
+                <a:solidFill>
+                  <a:srgbClr val="000000"/>
+                </a:solidFill>
+                <a:latin typeface="맑은 고딕"/>
+                <a:ea typeface="맑은 고딕"/>
+              </a:rPr>
+              <a:t> 배송 시작 후 일반 취소 불가</a:t>
+            </a:r>
+          </a:p>
+          <a:p>
+            <a:pPr lvl="2" marL="723900" indent="-368300">
+              <a:spcBef>
+                <a:spcPts val="600"/>
+              </a:spcBef>
+              <a:spcAft>
+                <a:spcPts val="600"/>
+              </a:spcAft>
+              <a:buSzPct val="90000"/>
+              <a:buFont typeface="Wingdings" pitchFamily="2" charset="2"/>
+              <a:buChar char=""/>
+            </a:pPr>
+            <a:r>
+              <a:rPr sz="1800" b="1">
+                <a:solidFill>
+                  <a:srgbClr val="000000"/>
+                </a:solidFill>
+                <a:latin typeface="맑은 고딕"/>
+                <a:ea typeface="맑은 고딕"/>
+              </a:rPr>
+              <a:t>해결책</a:t>
+            </a:r>
+            <a:r>
+              <a:rPr sz="1800" b="0">
+                <a:solidFill>
+                  <a:srgbClr val="000000"/>
+                </a:solidFill>
+                <a:latin typeface="맑은 고딕"/>
+                <a:ea typeface="맑은 고딕"/>
+              </a:rPr>
+              <a:t> —</a:t>
+            </a:r>
+            <a:r>
+              <a:rPr sz="1600" b="0">
+                <a:solidFill>
+                  <a:srgbClr val="000000"/>
+                </a:solidFill>
+                <a:latin typeface="맑은 고딕"/>
+                <a:ea typeface="맑은 고딕"/>
+              </a:rPr>
+              <a:t> 취소 버튼</a:t>
+            </a:r>
+            <a:r>
+              <a:rPr sz="1200" b="0">
+                <a:solidFill>
+                  <a:srgbClr val="000000"/>
+                </a:solidFill>
+                <a:latin typeface="맑은 고딕"/>
+                <a:ea typeface="맑은 고딕"/>
+              </a:rPr>
+              <a:t>(다른 해결책도 가능. 예: 고객센터 취소 요청)</a:t>
+            </a:r>
+          </a:p>
+          <a:p>
+            <a:pPr lvl="2" marL="723900" indent="-368300">
+              <a:spcBef>
+                <a:spcPts val="600"/>
+              </a:spcBef>
+              <a:spcAft>
+                <a:spcPts val="600"/>
+              </a:spcAft>
+              <a:buSzPct val="90000"/>
+              <a:buFont typeface="Wingdings" pitchFamily="2" charset="2"/>
+              <a:buChar char=""/>
+            </a:pPr>
+            <a:r>
+              <a:rPr sz="1800" b="1">
+                <a:solidFill>
+                  <a:srgbClr val="000000"/>
+                </a:solidFill>
+                <a:latin typeface="맑은 고딕"/>
+                <a:ea typeface="맑은 고딕"/>
+              </a:rPr>
+              <a:t>확인 질문</a:t>
+            </a:r>
+            <a:r>
+              <a:rPr sz="1800" b="0">
+                <a:solidFill>
+                  <a:srgbClr val="000000"/>
+                </a:solidFill>
+                <a:latin typeface="맑은 고딕"/>
+                <a:ea typeface="맑은 고딕"/>
+              </a:rPr>
+              <a:t> —</a:t>
+            </a:r>
+            <a:r>
+              <a:rPr sz="1600" b="0">
+                <a:solidFill>
+                  <a:srgbClr val="000000"/>
+                </a:solidFill>
+                <a:latin typeface="맑은 고딕"/>
+                <a:ea typeface="맑은 고딕"/>
+              </a:rPr>
+              <a:t> 현재 취소 경로가 없는가, 아니면 찾기 어려운가?</a:t>
+            </a:r>
+          </a:p>
+        </p:txBody>
+      </p:sp>
+    </p:spTree>
+    <p:extLst>
+      <p:ext uri="{BB962C8B-B14F-4D97-AF65-F5344CB8AC3E}">
+        <p14:creationId xmlns:p14="http://schemas.microsoft.com/office/powerpoint/2010/main" val="3555436673"/>
+      </p:ext>
+    </p:extLst>
+  </p:cSld>
+  <p:clrMapOvr>
+    <a:masterClrMapping/>
+  </p:clrMapOvr>
+</p:sld>
+</file>
+
+<file path=ppt/slides/slide27.xml><?xml version="1.0" encoding="utf-8"?>
+<p:sld xmlns:a="http://schemas.openxmlformats.org/drawingml/2006/main" xmlns:r="http://schemas.openxmlformats.org/officeDocument/2006/relationships" xmlns:p="http://schemas.openxmlformats.org/presentationml/2006/main">
+  <p:cSld>
+    <p:spTree>
+      <p:nvGrpSpPr>
+        <p:cNvPr id="1" name="">
+          <a:extLst>
+            <a:ext uri="{FF2B5EF4-FFF2-40B4-BE49-F238E27FC236}">
+              <a16:creationId xmlns:a16="http://schemas.microsoft.com/office/drawing/2014/main" id="{8E4F1F13-426B-086B-7D8C-9A58A0F879DB}"/>
+            </a:ext>
+          </a:extLst>
+        </p:cNvPr>
+        <p:cNvGrpSpPr/>
+        <p:nvPr/>
+      </p:nvGrpSpPr>
+      <p:grpSpPr>
+        <a:xfrm>
+          <a:off x="0" y="0"/>
+          <a:ext cx="0" cy="0"/>
+          <a:chOff x="0" y="0"/>
+          <a:chExt cx="0" cy="0"/>
+        </a:xfrm>
+      </p:grpSpPr>
+      <p:sp>
+        <p:nvSpPr>
+          <p:cNvPr id="2" name="제목 1">
+            <a:extLst>
+              <a:ext uri="{FF2B5EF4-FFF2-40B4-BE49-F238E27FC236}">
+                <a16:creationId xmlns:a16="http://schemas.microsoft.com/office/drawing/2014/main" id="{AA26A92D-924E-0575-9551-F8FD7BFD3FAD}"/>
+              </a:ext>
+            </a:extLst>
+          </p:cNvPr>
+          <p:cNvSpPr>
+            <a:spLocks noGrp="1"/>
+          </p:cNvSpPr>
+          <p:nvPr>
+            <p:ph type="title"/>
+          </p:nvPr>
+        </p:nvSpPr>
+        <p:spPr/>
+        <p:txBody>
+          <a:bodyPr/>
+          <a:lstStyle/>
+          <a:p>
+            <a:r>
+              <a:rPr sz="2400" b="1">
+                <a:solidFill>
+                  <a:srgbClr val="000000"/>
+                </a:solidFill>
+                <a:latin typeface="맑은 고딕"/>
+                <a:ea typeface="맑은 고딕"/>
+              </a:rPr>
+              <a:t>26. 요약</a:t>
+            </a:r>
+          </a:p>
+        </p:txBody>
+      </p:sp>
+      <p:sp>
+        <p:nvSpPr>
+          <p:cNvPr id="3" name="슬라이드 번호 개체 틀 2">
+            <a:extLst>
+              <a:ext uri="{FF2B5EF4-FFF2-40B4-BE49-F238E27FC236}">
+                <a16:creationId xmlns:a16="http://schemas.microsoft.com/office/drawing/2014/main" id="{12CF30EE-4DFD-8063-56B8-B8689E76DFCA}"/>
+              </a:ext>
+            </a:extLst>
+          </p:cNvPr>
+          <p:cNvSpPr>
+            <a:spLocks noGrp="1"/>
+          </p:cNvSpPr>
+          <p:nvPr>
+            <p:ph type="sldNum" sz="quarter" idx="10"/>
+          </p:nvPr>
+        </p:nvSpPr>
+        <p:spPr/>
+        <p:txBody>
+          <a:bodyPr/>
+          <a:lstStyle/>
+          <a:p>
+            <a:pPr>
+              <a:defRPr/>
+            </a:pPr>
+            <a:r>
+              <a:rPr lang="en-US" altLang="ko-KR">
+                <a:solidFill>
+                  <a:prstClr val="black"/>
+                </a:solidFill>
+              </a:rPr>
+              <a:t>- 27 -</a:t>
             </a:r>
           </a:p>
         </p:txBody>
@@ -14427,8 +15754,8 @@
         </p:blipFill>
         <p:spPr>
           <a:xfrm>
-            <a:off x="1149350" y="4489799"/>
-            <a:ext cx="6845300" cy="855662"/>
+            <a:off x="1149350" y="4550918"/>
+            <a:ext cx="6845300" cy="733425"/>
           </a:xfrm>
           <a:prstGeom prst="rect">
             <a:avLst/>
@@ -16268,8 +17595,8 @@
         </p:blipFill>
         <p:spPr>
           <a:xfrm>
-            <a:off x="1149350" y="3993212"/>
-            <a:ext cx="6845300" cy="1519238"/>
+            <a:off x="1149350" y="4084890"/>
+            <a:ext cx="6845300" cy="1335881"/>
           </a:xfrm>
           <a:prstGeom prst="rect">
             <a:avLst/>
@@ -16803,8 +18130,8 @@
         </p:blipFill>
         <p:spPr>
           <a:xfrm>
-            <a:off x="1149350" y="4630199"/>
-            <a:ext cx="6845300" cy="532606"/>
+            <a:off x="1149350" y="4717511"/>
+            <a:ext cx="6845300" cy="357981"/>
           </a:xfrm>
           <a:prstGeom prst="rect">
             <a:avLst/>
@@ -17329,8 +18656,8 @@
         </p:blipFill>
         <p:spPr>
           <a:xfrm>
-            <a:off x="2550716" y="3867274"/>
-            <a:ext cx="4042569" cy="1938338"/>
+            <a:off x="2345531" y="3867274"/>
+            <a:ext cx="4452938" cy="1938337"/>
           </a:xfrm>
           <a:prstGeom prst="rect">
             <a:avLst/>

</xml_diff>

<commit_message>
feat(production): source code layout, diagram-code pairing and layout fixes
- Source code: full-width monospace 10pt with lead text above; tries two
  columns and 9/8pt (tighter spacing) to keep a topic on one slide;
  columns split between members; prefers layouts without wrapped lines.
- A diagram right before code is shown with the code on every slide.
- Side layout (text left, diagram right) for a tall single diagram.
- Communication diagrams: widen viewBox to content clipped by smetana.
- White sequence participant boxes; code aligned with body text inset.
- Text height estimate accounts for 4pt-smaller parentheticals.
- Reference check resolves review decks (sNN-add.md) against sNN.md.
- Re-render OOAD S01-S04 decks with the updated renderer.

Co-Authored-By: Claude Opus 5.5 <noreply@anthropic.com>
</commit_message>
<xml_diff>
--- a/courses/ooad/sessions/s01.pptx
+++ b/courses/ooad/sessions/s01.pptx
@@ -8722,8 +8722,8 @@
         </p:blipFill>
         <p:spPr>
           <a:xfrm>
-            <a:off x="703382" y="3332480"/>
-            <a:ext cx="7737236" cy="2979985"/>
+            <a:off x="625231" y="3148710"/>
+            <a:ext cx="7893538" cy="3040185"/>
           </a:xfrm>
           <a:prstGeom prst="rect">
             <a:avLst/>

</xml_diff>

<commit_message>
docs(ooad): keep citations that anchor a topic and record their sources
- Remove five quotes that did not carry their topic's core message
  (S01 09 Booch OOD, S01 30 Evans, S03 06 state machine, S03 07 Larman
  duplicate, S03 40 Evans); body and notes adjusted.
- Every remaining quote (45) now has its source in the instructor note:
  Brooks, Kay, Gruber, Jeffries, Cucumber, Larman and OMG checked in the
  original; ISO/IEC/IEEE 42010 marked www (NIST glossary); Cucumber
  English restored to the original wording; 29148 clause narrowed to
  §5.2.5-5.2.6 from the official preview.
- session-authoring-guide: quote only when it carries the topic's core
  message.

Co-Authored-By: Claude Opus 5.5 <noreply@anthropic.com>
</commit_message>
<xml_diff>
--- a/courses/ooad/sessions/s01.pptx
+++ b/courses/ooad/sessions/s01.pptx
@@ -642,6 +642,13 @@
             <a:pPr lvl="0"/>
             <a:r>
               <a:rPr lang="ko-KR" sz="1200"/>
+              <a:t>인용 근거: Brooks, "No Silver Bullet — Essence and Accidents of Software Engineering", UNC Technical Report TR86-020(1986), Essential Difficulties의 Complexity 원문 확인.</a:t>
+            </a:r>
+          </a:p>
+          <a:p>
+            <a:pPr lvl="0"/>
+            <a:r>
+              <a:rPr lang="ko-KR" sz="1200"/>
               <a:t>기술은 우연적 어려움을 줄일 수 있지만 본질적 어려움을 제거하지는 못한다.</a:t>
             </a:r>
           </a:p>
@@ -792,7 +799,7 @@
             <a:pPr lvl="0"/>
             <a:r>
               <a:rPr lang="ko-KR" sz="1200"/>
-              <a:t>Booch, *Object-Oriented Analysis and Design with Applications*(2nd ed., 1994) 원서 본문은 미확인이다(www). 재인용처: tutorialspoint, "OOAD — Object Oriented Paradigm". 두 정의의 영어 문구가 이 페이지와 일치함을 확인했다.</a:t>
+              <a:t>Booch, *Object-Oriented Analysis and Design with Applications*(2nd ed., 1994) 원서 본문은 미확인이다(www). 재인용처: tutorialspoint, "OOAD — Object Oriented Paradigm". 정의의 영어 문구가 이 페이지와 일치함을 확인했다.</a:t>
             </a:r>
           </a:p>
           <a:p>
@@ -1064,6 +1071,13 @@
             <a:pPr lvl="0"/>
             <a:r>
               <a:rPr lang="ko-KR" sz="1200"/>
+              <a:t>인용 근거: OMG의 UML 소개 페이지(omg.org/uml) 원문 확인. 영어는 그 페이지 문장의 발췌다.</a:t>
+            </a:r>
+          </a:p>
+          <a:p>
+            <a:pPr lvl="0"/>
+            <a:r>
+              <a:rPr lang="ko-KR" sz="1200"/>
               <a:t>UML의 통합 배경은 OMG [UML 2.5.1](https://www.omg.org/spec/UML/2.5.1/PDF), §1 Scope의 UML 1 설명을 참조한다.</a:t>
             </a:r>
           </a:p>
@@ -1676,6 +1690,13 @@
             <a:pPr lvl="0"/>
             <a:r>
               <a:rPr lang="ko-KR" sz="1200"/>
+              <a:t>인용 근거: Alan Kay가 Stefan Ram에게 보낸 이메일(2003-07-23). Stefan Ram이 공개한 원문 페이지에서 확인했다.</a:t>
+            </a:r>
+          </a:p>
+          <a:p>
+            <a:pPr lvl="0"/>
+            <a:r>
+              <a:rPr lang="ko-KR" sz="1200"/>
               <a:t>객체지향을 클래스와 상속만으로 설명하지 않는다.</a:t>
             </a:r>
           </a:p>
@@ -2316,7 +2337,7 @@
             <a:pPr lvl="0"/>
             <a:r>
               <a:rPr lang="ko-KR" sz="1200"/>
-              <a:t>위 인용문은 Eric Evans, *Domain-Driven Design*(Final Manuscript, 2003-04-15), Part II 서두(p.48)에서 직접 확인했다.</a:t>
+              <a:t>근거: Eric Evans, *Domain-Driven Design*(Final Manuscript, 2003-04-15), Part II 서두(p.48) — 책의 설계 방식이 책임 중심 설계와 계약에 의한 설계, Larman 등 객체지향 설계 모범 사례를 배경으로 한다는 서술을 직접 확인했다.</a:t>
             </a:r>
           </a:p>
         </p:txBody>
@@ -2455,6 +2476,13 @@
         <p:txBody>
           <a:bodyPr/>
           <a:lstStyle/>
+          <a:p>
+            <a:pPr lvl="0"/>
+            <a:r>
+              <a:rPr lang="ko-KR" sz="1200"/>
+              <a:t>인용 근거: Thomas R. Gruber, "A Translation Approach to Portable Ontology Specifications", *Knowledge Acquisition* 5(2):199–220, 1993 원문 확인.</a:t>
+            </a:r>
+          </a:p>
           <a:p>
             <a:pPr lvl="0"/>
             <a:r>
@@ -7407,89 +7435,6 @@
               <a:t>Grady Booch, 1994, www</a:t>
             </a:r>
           </a:p>
-          <a:p>
-            <a:pPr lvl="2" marL="723900" indent="-368300">
-              <a:spcBef>
-                <a:spcPts val="600"/>
-              </a:spcBef>
-              <a:spcAft>
-                <a:spcPts val="600"/>
-              </a:spcAft>
-              <a:buSzPct val="90000"/>
-              <a:buFont typeface="Wingdings" pitchFamily="2" charset="2"/>
-              <a:buChar char=""/>
-            </a:pPr>
-            <a:r>
-              <a:rPr sz="1800" b="0">
-                <a:solidFill>
-                  <a:srgbClr val="000000"/>
-                </a:solidFill>
-                <a:latin typeface="맑은 고딕"/>
-                <a:ea typeface="맑은 고딕"/>
-              </a:rPr>
-              <a:t>"객체지향 설계는 </a:t>
-            </a:r>
-            <a:r>
-              <a:rPr sz="1800" b="1">
-                <a:solidFill>
-                  <a:srgbClr val="000000"/>
-                </a:solidFill>
-                <a:latin typeface="맑은 고딕"/>
-                <a:ea typeface="맑은 고딕"/>
-              </a:rPr>
-              <a:t>객체지향 분해</a:t>
-            </a:r>
-            <a:r>
-              <a:rPr sz="1800" b="0">
-                <a:solidFill>
-                  <a:srgbClr val="000000"/>
-                </a:solidFill>
-                <a:latin typeface="맑은 고딕"/>
-                <a:ea typeface="맑은 고딕"/>
-              </a:rPr>
-              <a:t>와 논리적·물리적, 정적·동적 모델의 표현을 포괄하는 설계 방법이다"</a:t>
-            </a:r>
-            <a:r>
-              <a:rPr sz="1000" b="0">
-                <a:solidFill>
-                  <a:srgbClr val="000000"/>
-                </a:solidFill>
-                <a:latin typeface="맑은 고딕"/>
-                <a:ea typeface="맑은 고딕"/>
-              </a:rPr>
-              <a:t>, </a:t>
-            </a:r>
-            <a:r>
-              <a:rPr sz="1000" b="0">
-                <a:solidFill>
-                  <a:srgbClr val="000000"/>
-                </a:solidFill>
-                <a:latin typeface="맑은 고딕"/>
-                <a:ea typeface="맑은 고딕"/>
-              </a:rPr>
-              <a:t>"A method of design encompassing the process of object-oriented decomposition and a notation for depicting both logical and physical as well as static and dynamic models of the system under design."</a:t>
-            </a:r>
-            <a:r>
-              <a:rPr sz="1000" b="0">
-                <a:solidFill>
-                  <a:srgbClr val="000000"/>
-                </a:solidFill>
-                <a:latin typeface="맑은 고딕"/>
-                <a:ea typeface="맑은 고딕"/>
-              </a:rPr>
-              <a:t>, </a:t>
-            </a:r>
-            <a:r>
-              <a:rPr sz="1000" b="0">
-                <a:solidFill>
-                  <a:srgbClr val="000000"/>
-                </a:solidFill>
-                <a:latin typeface="맑은 고딕"/>
-                <a:ea typeface="맑은 고딕"/>
-              </a:rPr>
-              <a:t>Grady Booch, 1994, www</a:t>
-            </a:r>
-          </a:p>
         </p:txBody>
       </p:sp>
     </p:spTree>
@@ -20796,7 +20741,7 @@
                 <a:latin typeface="맑은 고딕"/>
                 <a:ea typeface="맑은 고딕"/>
               </a:rPr>
-              <a:t>ISO/IEC/IEEE 42010</a:t>
+              <a:t>ISO/IEC/IEEE 42010, www</a:t>
             </a:r>
           </a:p>
           <a:p>
@@ -33698,7 +33643,7 @@
                 <a:latin typeface="맑은 고딕"/>
                 <a:ea typeface="맑은 고딕"/>
               </a:rPr>
-              <a:t>"이 책의 설계 방식은 대체로 </a:t>
+              <a:t>에반스는 도메인 주도 설계를 </a:t>
             </a:r>
             <a:r>
               <a:rPr sz="1800" b="1">
@@ -33711,16 +33656,6 @@
               <a:t>책임 중심 설계</a:t>
             </a:r>
             <a:r>
-              <a:rPr sz="1400" b="0">
-                <a:solidFill>
-                  <a:srgbClr val="000000"/>
-                </a:solidFill>
-                <a:latin typeface="맑은 고딕"/>
-                <a:ea typeface="맑은 고딕"/>
-              </a:rPr>
-              <a:t>(Responsibility-Driven Design)</a:t>
-            </a:r>
-            <a:r>
               <a:rPr sz="1800" b="0">
                 <a:solidFill>
                   <a:srgbClr val="000000"/>
@@ -33728,120 +33663,7 @@
                 <a:latin typeface="맑은 고딕"/>
                 <a:ea typeface="맑은 고딕"/>
               </a:rPr>
-              <a:t> 원칙을 따르며, 10장에서는 특히 </a:t>
-            </a:r>
-            <a:r>
-              <a:rPr sz="1800" b="1">
-                <a:solidFill>
-                  <a:srgbClr val="000000"/>
-                </a:solidFill>
-                <a:latin typeface="맑은 고딕"/>
-                <a:ea typeface="맑은 고딕"/>
-              </a:rPr>
-              <a:t>계약에 의한 설계</a:t>
-            </a:r>
-            <a:r>
-              <a:rPr sz="1400" b="0">
-                <a:solidFill>
-                  <a:srgbClr val="000000"/>
-                </a:solidFill>
-                <a:latin typeface="맑은 고딕"/>
-                <a:ea typeface="맑은 고딕"/>
-              </a:rPr>
-              <a:t>(Design by Contract)</a:t>
-            </a:r>
-            <a:r>
-              <a:rPr sz="1800" b="0">
-                <a:solidFill>
-                  <a:srgbClr val="000000"/>
-                </a:solidFill>
-                <a:latin typeface="맑은 고딕"/>
-                <a:ea typeface="맑은 고딕"/>
-              </a:rPr>
-              <a:t>의 개념에 크게 의존한다. 또한 라만</a:t>
-            </a:r>
-            <a:r>
-              <a:rPr sz="1400" b="0">
-                <a:solidFill>
-                  <a:srgbClr val="000000"/>
-                </a:solidFill>
-                <a:latin typeface="맑은 고딕"/>
-                <a:ea typeface="맑은 고딕"/>
-              </a:rPr>
-              <a:t>(Craig Larman)</a:t>
-            </a:r>
-            <a:r>
-              <a:rPr sz="1800" b="0">
-                <a:solidFill>
-                  <a:srgbClr val="000000"/>
-                </a:solidFill>
-                <a:latin typeface="맑은 고딕"/>
-                <a:ea typeface="맑은 고딕"/>
-              </a:rPr>
-              <a:t>의 책과 같이 널리 받아들여지는 다른 객체지향 설계 모범 사례의 일반적인 배경 위에 있다."</a:t>
-            </a:r>
-            <a:r>
-              <a:rPr sz="1000" b="0">
-                <a:solidFill>
-                  <a:srgbClr val="000000"/>
-                </a:solidFill>
-                <a:latin typeface="맑은 고딕"/>
-                <a:ea typeface="맑은 고딕"/>
-              </a:rPr>
-              <a:t>, </a:t>
-            </a:r>
-            <a:r>
-              <a:rPr sz="1000" b="0">
-                <a:solidFill>
-                  <a:srgbClr val="000000"/>
-                </a:solidFill>
-                <a:latin typeface="맑은 고딕"/>
-                <a:ea typeface="맑은 고딕"/>
-              </a:rPr>
-              <a:t>"The design style largely follows the principle of “responsibility-driven design”... It also relies heavily (especially in Chapter 10) on the ideas of “design by contract”... It draws on the general background of other widely held best practices of object-oriented design, which are described in such books as [Larman 1998]."</a:t>
-            </a:r>
-            <a:r>
-              <a:rPr sz="1000" b="0">
-                <a:solidFill>
-                  <a:srgbClr val="000000"/>
-                </a:solidFill>
-                <a:latin typeface="맑은 고딕"/>
-                <a:ea typeface="맑은 고딕"/>
-              </a:rPr>
-              <a:t>, </a:t>
-            </a:r>
-            <a:r>
-              <a:rPr sz="1000" b="0">
-                <a:solidFill>
-                  <a:srgbClr val="000000"/>
-                </a:solidFill>
-                <a:latin typeface="맑은 고딕"/>
-                <a:ea typeface="맑은 고딕"/>
-              </a:rPr>
-              <a:t>Eric Evans, 2003</a:t>
-            </a:r>
-          </a:p>
-          <a:p>
-            <a:pPr lvl="2" marL="723900" indent="-368300">
-              <a:spcBef>
-                <a:spcPts val="600"/>
-              </a:spcBef>
-              <a:spcAft>
-                <a:spcPts val="600"/>
-              </a:spcAft>
-              <a:buSzPct val="90000"/>
-              <a:buFont typeface="Wingdings" pitchFamily="2" charset="2"/>
-              <a:buChar char=""/>
-            </a:pPr>
-            <a:r>
-              <a:rPr sz="1800" b="0">
-                <a:solidFill>
-                  <a:srgbClr val="000000"/>
-                </a:solidFill>
-                <a:latin typeface="맑은 고딕"/>
-                <a:ea typeface="맑은 고딕"/>
-              </a:rPr>
-              <a:t>에반스는 도메인 주도 설계를 이 배경 위에 세운다. 이 세션은 그 위에서 도메인 주도 설계 고유의 </a:t>
+              <a:t>와 객체지향 설계 모범 사례 위에 세운다. 이 세션은 그 위에서 도메인 주도 설계 고유의 </a:t>
             </a:r>
             <a:r>
               <a:rPr sz="1800" b="1">

</xml_diff>

<commit_message>
feat(ooad): LLM practice scenario across S01-S05, S05 session, answer slides
- Practices rebuilt as one new-development scenario (정기배송): S01 requirements
  spec, S02 use cases + SSD, S03 domain model draft/detail, S04 sequence,
  communication and state machine, S05 package draft/detail. Each answer is an
  "NN. <산출물> (안)" topic, and from practice 2 a closing 보완 (안) slide.
- S05 session (structural boundaries, component principles) with compiled code.
- Renderer: practice and answer slide styles (two-column answers at 14/12/11pt,
  governing message across columns, "(안)" title), nested numbered lists,
  calibrated fit estimate, usecase diagrams, package diagrams show names only.
- Guides, course design and AGENTS.md record the practice rules, the practice
  case and s01-s05 as the authoring baseline.

Co-Authored-By: Claude Opus 5.5 <noreply@anthropic.com>
</commit_message>
<xml_diff>
--- a/courses/ooad/sessions/s01.pptx
+++ b/courses/ooad/sessions/s01.pptx
@@ -2644,21 +2644,21 @@
             <a:pPr lvl="0"/>
             <a:r>
               <a:rPr lang="ko-KR" sz="1200"/>
-              <a:t>개인 판단 → 2~3인 근거 비교 → 전체 검토 순서로 진행한다. 시간은 전체 SA 완성 후 운영 계획에서 정한다.</a:t>
+              <a:t>실습은 모든 세션이 이어 쓰는 정기배송 시스템의 신규 개발 시나리오다. 강의의 주문 사례와 방법은 같지만 모델을 그대로 옮길 수는 없다.</a:t>
             </a:r>
           </a:p>
           <a:p>
             <a:pPr lvl="0"/>
             <a:r>
               <a:rPr lang="ko-KR" sz="1200"/>
-              <a:t>객체 설계나 UML 작성까지 요구하지 않는다.</a:t>
+              <a:t>LLM 사용 — 도구는 제한하지 않는다. LLM의 초안은 검토 전의 가설이며, 초안을 그대로 제출하지 않는다. 평가는 초안이 아니라 고친 곳과 그 이유를 본다.</a:t>
             </a:r>
           </a:p>
           <a:p>
             <a:pPr lvl="0"/>
             <a:r>
               <a:rPr lang="ko-KR" sz="1200"/>
-              <a:t>평가 기준: 네 항목의 수준 구분이 정확한지, 이벤트가 화면·데이터 없이 사건과 결과로 쓰였는지, 조건과 추정을 분리했는지, 취소 버튼 이외의 대안도 검토했는지, 확인 질문이 가설의 참·거짓을 가릴 수 있는지.</a:t>
+              <a:t>LLM이 되묻는 질문에 수강생이 업무 담당자처럼 답해 규칙을 정한다. 답할 수 없는 질문만 미확정으로 남기고 이유를 적는다.</a:t>
             </a:r>
           </a:p>
         </p:txBody>
@@ -2719,14 +2719,21 @@
             <a:pPr lvl="0"/>
             <a:r>
               <a:rPr lang="ko-KR" sz="1200"/>
-              <a:t>특정 문장 하나보다 각 항목의 수준과 사실·가정을 구분했는지가 중요하다.</a:t>
+              <a:t>점검 항목과 규칙의 대응 — 결제는 R5~R7, 주기·기간은 R1~R3, 취소·반품·해지는 R8~R11이다.</a:t>
             </a:r>
           </a:p>
           <a:p>
             <a:pPr lvl="0"/>
             <a:r>
               <a:rPr lang="ko-KR" sz="1200"/>
-              <a:t>같은 요구사항을 만족시키는 해결책은 여러 개일 수 있다.</a:t>
+              <a:t>숫자(28일, 12개월, 7일, 3일, 3,000원)는 교육용 가정이다. 수강생의 답이 달라도 정해져 있으면 맞다.</a:t>
+            </a:r>
+          </a:p>
+          <a:p>
+            <a:pPr lvl="0"/>
+            <a:r>
+              <a:rPr lang="ko-KR" sz="1200"/>
+              <a:t>LLM 초안에서 고칠 곳의 예 — "결제 화면에서 카드 번호를 입력한다" 같은 기술 표현, 개요에 없는 규칙을 묻지 않고 단정한 것.</a:t>
             </a:r>
           </a:p>
         </p:txBody>
@@ -13599,7 +13606,7 @@
                 <a:latin typeface="맑은 고딕"/>
                 <a:ea typeface="맑은 고딕"/>
               </a:rPr>
-              <a:t> 문제·요구사항·해결책</a:t>
+              <a:t> 요구사항 명세서</a:t>
             </a:r>
           </a:p>
           <a:p>
@@ -13620,27 +13627,17 @@
                 <a:latin typeface="맑은 고딕"/>
                 <a:ea typeface="맑은 고딕"/>
               </a:rPr>
-              <a:t>34. 실습 —</a:t>
-            </a:r>
-            <a:r>
-              <a:rPr sz="1400" b="0">
-                <a:solidFill>
-                  <a:srgbClr val="000000"/>
-                </a:solidFill>
-                <a:latin typeface="맑은 고딕"/>
-                <a:ea typeface="맑은 고딕"/>
-              </a:rPr>
-              <a:t> 검토 예시</a:t>
-            </a:r>
-            <a:r>
-              <a:rPr sz="1000" b="0">
-                <a:solidFill>
-                  <a:srgbClr val="000000"/>
-                </a:solidFill>
-                <a:latin typeface="맑은 고딕"/>
-                <a:ea typeface="맑은 고딕"/>
-              </a:rPr>
-              <a:t>(모범답안)</a:t>
+              <a:t>34. 요구사항 명세서 </a:t>
+            </a:r>
+            <a:r>
+              <a:rPr sz="1200" b="0">
+                <a:solidFill>
+                  <a:srgbClr val="000000"/>
+                </a:solidFill>
+                <a:latin typeface="맑은 고딕"/>
+                <a:ea typeface="맑은 고딕"/>
+              </a:rPr>
+              <a:t>(안)</a:t>
             </a:r>
           </a:p>
           <a:p>
@@ -35328,7 +35325,7 @@
                 <a:latin typeface="맑은 고딕"/>
                 <a:ea typeface="맑은 고딕"/>
               </a:rPr>
-              <a:t>33. 실습 — 문제·요구사항·해결책</a:t>
+              <a:t>33. 실습 — 요구사항 명세서</a:t>
             </a:r>
           </a:p>
         </p:txBody>
@@ -35462,7 +35459,12 @@
             <p:ph idx="1"/>
           </p:nvPr>
         </p:nvSpPr>
-        <p:spPr/>
+        <p:spPr>
+          <a:xfrm>
+            <a:off x="365760" y="960120"/>
+            <a:ext cx="8622792" cy="5522976"/>
+          </a:xfrm>
+        </p:spPr>
         <p:txBody>
           <a:bodyPr>
             <a:normAutofit/>
@@ -35471,67 +35473,77 @@
           <a:p>
             <a:pPr marL="0" indent="0">
               <a:spcBef>
-                <a:spcPts val="600"/>
+                <a:spcPts val="300"/>
               </a:spcBef>
               <a:spcAft>
-                <a:spcPts val="600"/>
+                <a:spcPts val="300"/>
               </a:spcAft>
               <a:buNone/>
             </a:pPr>
             <a:r>
-              <a:rPr sz="1800" b="0">
-                <a:solidFill>
-                  <a:srgbClr val="000000"/>
-                </a:solidFill>
-                <a:latin typeface="맑은 고딕"/>
-                <a:ea typeface="맑은 고딕"/>
-              </a:rPr>
-              <a:t>요청에 포함된 해결책과 그 배경의 문제·요구사항·제약을 구분하고, </a:t>
-            </a:r>
-            <a:r>
-              <a:rPr sz="1800" b="1">
-                <a:solidFill>
-                  <a:srgbClr val="000000"/>
-                </a:solidFill>
-                <a:latin typeface="맑은 고딕"/>
-                <a:ea typeface="맑은 고딕"/>
-              </a:rPr>
-              <a:t>확인이 필요한 가정</a:t>
-            </a:r>
-            <a:r>
-              <a:rPr sz="1800" b="0">
-                <a:solidFill>
-                  <a:srgbClr val="000000"/>
-                </a:solidFill>
-                <a:latin typeface="맑은 고딕"/>
-                <a:ea typeface="맑은 고딕"/>
-              </a:rPr>
-              <a:t>을 식별한다.</a:t>
+              <a:rPr sz="1600" b="0">
+                <a:solidFill>
+                  <a:srgbClr val="000000"/>
+                </a:solidFill>
+                <a:latin typeface="맑은 고딕"/>
+                <a:ea typeface="맑은 고딕"/>
+              </a:rPr>
+              <a:t>서비스 개요와 프롬프트를 LLM에 제공하여 </a:t>
+            </a:r>
+            <a:r>
+              <a:rPr sz="1600" b="1">
+                <a:solidFill>
+                  <a:srgbClr val="000000"/>
+                </a:solidFill>
+                <a:latin typeface="맑은 고딕"/>
+                <a:ea typeface="맑은 고딕"/>
+              </a:rPr>
+              <a:t>요구사항 명세서</a:t>
+            </a:r>
+            <a:r>
+              <a:rPr sz="1600" b="0">
+                <a:solidFill>
+                  <a:srgbClr val="000000"/>
+                </a:solidFill>
+                <a:latin typeface="맑은 고딕"/>
+                <a:ea typeface="맑은 고딕"/>
+              </a:rPr>
+              <a:t>를 만들고, 점검 항목을 참고해 </a:t>
+            </a:r>
+            <a:r>
+              <a:rPr sz="1600" b="1">
+                <a:solidFill>
+                  <a:srgbClr val="000000"/>
+                </a:solidFill>
+                <a:latin typeface="맑은 고딕"/>
+                <a:ea typeface="맑은 고딕"/>
+              </a:rPr>
+              <a:t>피드백</a:t>
+            </a:r>
+            <a:r>
+              <a:rPr sz="1600" b="0">
+                <a:solidFill>
+                  <a:srgbClr val="000000"/>
+                </a:solidFill>
+                <a:latin typeface="맑은 고딕"/>
+                <a:ea typeface="맑은 고딕"/>
+              </a:rPr>
+              <a:t>하여 명세서를 완성하십시오.</a:t>
             </a:r>
           </a:p>
           <a:p>
             <a:pPr lvl="2" marL="723900" indent="-368300">
               <a:spcBef>
-                <a:spcPts val="600"/>
+                <a:spcPts val="300"/>
               </a:spcBef>
               <a:spcAft>
-                <a:spcPts val="600"/>
+                <a:spcPts val="300"/>
               </a:spcAft>
               <a:buSzPct val="90000"/>
               <a:buFont typeface="Wingdings" pitchFamily="2" charset="2"/>
               <a:buChar char=""/>
             </a:pPr>
             <a:r>
-              <a:rPr sz="1800" b="0">
-                <a:solidFill>
-                  <a:srgbClr val="000000"/>
-                </a:solidFill>
-                <a:latin typeface="맑은 고딕"/>
-                <a:ea typeface="맑은 고딕"/>
-              </a:rPr>
-              <a:t>온라인 쇼핑몰에 다음 </a:t>
-            </a:r>
-            <a:r>
               <a:rPr sz="1800" b="1">
                 <a:solidFill>
                   <a:srgbClr val="000000"/>
@@ -35539,59 +35551,151 @@
                 <a:latin typeface="맑은 고딕"/>
                 <a:ea typeface="맑은 고딕"/>
               </a:rPr>
-              <a:t>요청</a:t>
-            </a:r>
-            <a:r>
-              <a:rPr sz="1800" b="0">
-                <a:solidFill>
-                  <a:srgbClr val="000000"/>
-                </a:solidFill>
-                <a:latin typeface="맑은 고딕"/>
-                <a:ea typeface="맑은 고딕"/>
-              </a:rPr>
-              <a:t>이 들어왔다.</a:t>
+              <a:t>서비스 개요</a:t>
+            </a:r>
+          </a:p>
+          <a:p>
+            <a:pPr lvl="3" marL="723900" indent="0">
+              <a:spcBef>
+                <a:spcPts val="300"/>
+              </a:spcBef>
+              <a:spcAft>
+                <a:spcPts val="300"/>
+              </a:spcAft>
+              <a:buNone/>
+            </a:pPr>
+            <a:r>
+              <a:rPr sz="1600" b="1">
+                <a:solidFill>
+                  <a:srgbClr val="000000"/>
+                </a:solidFill>
+                <a:latin typeface="맑은 고딕"/>
+                <a:ea typeface="맑은 고딕"/>
+              </a:rPr>
+              <a:t>생필품</a:t>
+            </a:r>
+            <a:r>
+              <a:rPr sz="1600" b="0">
+                <a:solidFill>
+                  <a:srgbClr val="000000"/>
+                </a:solidFill>
+                <a:latin typeface="맑은 고딕"/>
+                <a:ea typeface="맑은 고딕"/>
+              </a:rPr>
+              <a:t>을 일정 주기로 배송하는 정기배송 시스템을 개발한다. 고객은 상품·수량·기간·배송 주기</a:t>
+            </a:r>
+            <a:r>
+              <a:rPr sz="1000" b="0">
+                <a:solidFill>
+                  <a:srgbClr val="000000"/>
+                </a:solidFill>
+                <a:latin typeface="맑은 고딕"/>
+                <a:ea typeface="맑은 고딕"/>
+              </a:rPr>
+              <a:t>(1·2·4주)</a:t>
+            </a:r>
+            <a:r>
+              <a:rPr sz="1600" b="0">
+                <a:solidFill>
+                  <a:srgbClr val="000000"/>
+                </a:solidFill>
+                <a:latin typeface="맑은 고딕"/>
+                <a:ea typeface="맑은 고딕"/>
+              </a:rPr>
+              <a:t>·배송지를 입력하고 결제한다. 고객은 다음 배송을 24시간 전까지 취소할 수 있다</a:t>
+            </a:r>
+            <a:r>
+              <a:rPr sz="1000" b="0">
+                <a:solidFill>
+                  <a:srgbClr val="000000"/>
+                </a:solidFill>
+                <a:latin typeface="맑은 고딕"/>
+                <a:ea typeface="맑은 고딕"/>
+              </a:rPr>
+              <a:t>(연속 2회까지)</a:t>
+            </a:r>
+            <a:r>
+              <a:rPr sz="1600" b="0">
+                <a:solidFill>
+                  <a:srgbClr val="000000"/>
+                </a:solidFill>
+                <a:latin typeface="맑은 고딕"/>
+                <a:ea typeface="맑은 고딕"/>
+              </a:rPr>
+              <a:t>. 상품·결제·배송은 각각 외부 시스템이 맡는다.</a:t>
             </a:r>
           </a:p>
           <a:p>
             <a:pPr lvl="2" marL="723900" indent="-368300">
               <a:spcBef>
-                <a:spcPts val="600"/>
+                <a:spcPts val="300"/>
               </a:spcBef>
               <a:spcAft>
-                <a:spcPts val="600"/>
+                <a:spcPts val="300"/>
               </a:spcAft>
               <a:buSzPct val="90000"/>
               <a:buFont typeface="Wingdings" pitchFamily="2" charset="2"/>
               <a:buChar char=""/>
             </a:pPr>
             <a:r>
-              <a:rPr sz="1800" b="0">
-                <a:solidFill>
-                  <a:srgbClr val="000000"/>
-                </a:solidFill>
-                <a:latin typeface="맑은 고딕"/>
-                <a:ea typeface="맑은 고딕"/>
-              </a:rPr>
-              <a:t>“주문 목록에 취소 버튼을 추가해 주세요.” </a:t>
-            </a:r>
-            <a:r>
-              <a:rPr sz="1400" b="0">
-                <a:solidFill>
-                  <a:srgbClr val="000000"/>
-                </a:solidFill>
-                <a:latin typeface="맑은 고딕"/>
-                <a:ea typeface="맑은 고딕"/>
-              </a:rPr>
-              <a:t>(조건: 배송 시작 전 주문만 취소 가능, 취소 시 결제 금액 환불)</a:t>
+              <a:rPr sz="1800" b="1">
+                <a:solidFill>
+                  <a:srgbClr val="000000"/>
+                </a:solidFill>
+                <a:latin typeface="맑은 고딕"/>
+                <a:ea typeface="맑은 고딕"/>
+              </a:rPr>
+              <a:t>프롬프트</a:t>
+            </a:r>
+          </a:p>
+          <a:p>
+            <a:pPr lvl="3" marL="723900" indent="0">
+              <a:spcBef>
+                <a:spcPts val="300"/>
+              </a:spcBef>
+              <a:spcAft>
+                <a:spcPts val="300"/>
+              </a:spcAft>
+              <a:buNone/>
+            </a:pPr>
+            <a:r>
+              <a:rPr sz="1600" b="0">
+                <a:solidFill>
+                  <a:srgbClr val="000000"/>
+                </a:solidFill>
+                <a:latin typeface="맑은 고딕"/>
+                <a:ea typeface="맑은 고딕"/>
+              </a:rPr>
+              <a:t>"위 서비스 개요로 정기배송 시스템의 요구사항 명세서를 작성해줘. 기능 요구, 업무 규칙, 외부 시스템, 확인할 질문으로 나눠 정리해줘. 개요에 없는 내용은 추측하지 말고 </a:t>
+            </a:r>
+            <a:r>
+              <a:rPr sz="1600" b="1">
+                <a:solidFill>
+                  <a:srgbClr val="000000"/>
+                </a:solidFill>
+                <a:latin typeface="맑은 고딕"/>
+                <a:ea typeface="맑은 고딕"/>
+              </a:rPr>
+              <a:t>반드시 확인</a:t>
+            </a:r>
+            <a:r>
+              <a:rPr sz="1600" b="0">
+                <a:solidFill>
+                  <a:srgbClr val="000000"/>
+                </a:solidFill>
+                <a:latin typeface="맑은 고딕"/>
+                <a:ea typeface="맑은 고딕"/>
+              </a:rPr>
+              <a:t>해라."</a:t>
             </a:r>
           </a:p>
           <a:p>
             <a:pPr lvl="2" marL="723900" indent="-368300">
               <a:spcBef>
-                <a:spcPts val="600"/>
+                <a:spcPts val="300"/>
               </a:spcBef>
               <a:spcAft>
-                <a:spcPts val="600"/>
+                <a:spcPts val="300"/>
               </a:spcAft>
               <a:buSzPct val="90000"/>
               <a:buFont typeface="Wingdings" pitchFamily="2" charset="2"/>
@@ -35605,7 +35709,456 @@
                 <a:latin typeface="맑은 고딕"/>
                 <a:ea typeface="맑은 고딕"/>
               </a:rPr>
-              <a:t>과제</a:t>
+              <a:t>점검 항목</a:t>
+            </a:r>
+          </a:p>
+          <a:p>
+            <a:pPr lvl="3" marL="947420" indent="-223520">
+              <a:spcBef>
+                <a:spcPts val="300"/>
+              </a:spcBef>
+              <a:spcAft>
+                <a:spcPts val="300"/>
+              </a:spcAft>
+              <a:buNone/>
+            </a:pPr>
+            <a:r>
+              <a:rPr sz="1600" b="0">
+                <a:solidFill>
+                  <a:srgbClr val="000000"/>
+                </a:solidFill>
+                <a:latin typeface="맑은 고딕"/>
+                <a:ea typeface="맑은 고딕"/>
+              </a:rPr>
+              <a:t>1. </a:t>
+            </a:r>
+            <a:r>
+              <a:rPr sz="1600" b="1">
+                <a:solidFill>
+                  <a:srgbClr val="000000"/>
+                </a:solidFill>
+                <a:latin typeface="맑은 고딕"/>
+                <a:ea typeface="맑은 고딕"/>
+              </a:rPr>
+              <a:t>개요 반영</a:t>
+            </a:r>
+            <a:r>
+              <a:rPr sz="1600" b="0">
+                <a:solidFill>
+                  <a:srgbClr val="000000"/>
+                </a:solidFill>
+                <a:latin typeface="맑은 고딕"/>
+                <a:ea typeface="맑은 고딕"/>
+              </a:rPr>
+              <a:t> —</a:t>
+            </a:r>
+            <a:r>
+              <a:rPr sz="1050" b="0">
+                <a:solidFill>
+                  <a:srgbClr val="000000"/>
+                </a:solidFill>
+                <a:latin typeface="맑은 고딕"/>
+                <a:ea typeface="맑은 고딕"/>
+              </a:rPr>
+              <a:t> 개요의 모든 내용이 빠짐없이 반영되었는가? 입력 항목, 결제, 취소 규칙, 외부 시스템을 확인한다.</a:t>
+            </a:r>
+          </a:p>
+          <a:p>
+            <a:pPr lvl="3" marL="947420" indent="-223520">
+              <a:spcBef>
+                <a:spcPts val="300"/>
+              </a:spcBef>
+              <a:spcAft>
+                <a:spcPts val="300"/>
+              </a:spcAft>
+              <a:buNone/>
+            </a:pPr>
+            <a:r>
+              <a:rPr sz="1600" b="0">
+                <a:solidFill>
+                  <a:srgbClr val="000000"/>
+                </a:solidFill>
+                <a:latin typeface="맑은 고딕"/>
+                <a:ea typeface="맑은 고딕"/>
+              </a:rPr>
+              <a:t>2. </a:t>
+            </a:r>
+            <a:r>
+              <a:rPr sz="1600" b="1">
+                <a:solidFill>
+                  <a:srgbClr val="000000"/>
+                </a:solidFill>
+                <a:latin typeface="맑은 고딕"/>
+                <a:ea typeface="맑은 고딕"/>
+              </a:rPr>
+              <a:t>결제</a:t>
+            </a:r>
+            <a:r>
+              <a:rPr sz="1600" b="0">
+                <a:solidFill>
+                  <a:srgbClr val="000000"/>
+                </a:solidFill>
+                <a:latin typeface="맑은 고딕"/>
+                <a:ea typeface="맑은 고딕"/>
+              </a:rPr>
+              <a:t> —</a:t>
+            </a:r>
+            <a:r>
+              <a:rPr sz="1050" b="0">
+                <a:solidFill>
+                  <a:srgbClr val="000000"/>
+                </a:solidFill>
+                <a:latin typeface="맑은 고딕"/>
+                <a:ea typeface="맑은 고딕"/>
+              </a:rPr>
+              <a:t> 결제 방법</a:t>
+            </a:r>
+            <a:r>
+              <a:rPr sz="850" b="0">
+                <a:solidFill>
+                  <a:srgbClr val="000000"/>
+                </a:solidFill>
+                <a:latin typeface="맑은 고딕"/>
+                <a:ea typeface="맑은 고딕"/>
+              </a:rPr>
+              <a:t>(카드·계좌이체·간편결제 등)</a:t>
+            </a:r>
+            <a:r>
+              <a:rPr sz="1050" b="0">
+                <a:solidFill>
+                  <a:srgbClr val="000000"/>
+                </a:solidFill>
+                <a:latin typeface="맑은 고딕"/>
+                <a:ea typeface="맑은 고딕"/>
+              </a:rPr>
+              <a:t>, 청구 방식</a:t>
+            </a:r>
+            <a:r>
+              <a:rPr sz="850" b="0">
+                <a:solidFill>
+                  <a:srgbClr val="000000"/>
+                </a:solidFill>
+                <a:latin typeface="맑은 고딕"/>
+                <a:ea typeface="맑은 고딕"/>
+              </a:rPr>
+              <a:t>(일시불·월별 청구)</a:t>
+            </a:r>
+            <a:r>
+              <a:rPr sz="1050" b="0">
+                <a:solidFill>
+                  <a:srgbClr val="000000"/>
+                </a:solidFill>
+                <a:latin typeface="맑은 고딕"/>
+                <a:ea typeface="맑은 고딕"/>
+              </a:rPr>
+              <a:t>, 청구일이 정해졌는가?</a:t>
+            </a:r>
+          </a:p>
+          <a:p>
+            <a:pPr lvl="3" marL="947420" indent="-223520">
+              <a:spcBef>
+                <a:spcPts val="300"/>
+              </a:spcBef>
+              <a:spcAft>
+                <a:spcPts val="300"/>
+              </a:spcAft>
+              <a:buNone/>
+            </a:pPr>
+            <a:r>
+              <a:rPr sz="1600" b="0">
+                <a:solidFill>
+                  <a:srgbClr val="000000"/>
+                </a:solidFill>
+                <a:latin typeface="맑은 고딕"/>
+                <a:ea typeface="맑은 고딕"/>
+              </a:rPr>
+              <a:t>3. </a:t>
+            </a:r>
+            <a:r>
+              <a:rPr sz="1600" b="1">
+                <a:solidFill>
+                  <a:srgbClr val="000000"/>
+                </a:solidFill>
+                <a:latin typeface="맑은 고딕"/>
+                <a:ea typeface="맑은 고딕"/>
+              </a:rPr>
+              <a:t>배송 주기·기간</a:t>
+            </a:r>
+            <a:r>
+              <a:rPr sz="1600" b="0">
+                <a:solidFill>
+                  <a:srgbClr val="000000"/>
+                </a:solidFill>
+                <a:latin typeface="맑은 고딕"/>
+                <a:ea typeface="맑은 고딕"/>
+              </a:rPr>
+              <a:t> —</a:t>
+            </a:r>
+            <a:r>
+              <a:rPr sz="1050" b="0">
+                <a:solidFill>
+                  <a:srgbClr val="000000"/>
+                </a:solidFill>
+                <a:latin typeface="맑은 고딕"/>
+                <a:ea typeface="맑은 고딕"/>
+              </a:rPr>
+              <a:t> 1·2·4주 외에 고객이 원하는 주기</a:t>
+            </a:r>
+            <a:r>
+              <a:rPr sz="850" b="0">
+                <a:solidFill>
+                  <a:srgbClr val="000000"/>
+                </a:solidFill>
+                <a:latin typeface="맑은 고딕"/>
+                <a:ea typeface="맑은 고딕"/>
+              </a:rPr>
+              <a:t>(매일·격일·3일·10일 등)</a:t>
+            </a:r>
+            <a:r>
+              <a:rPr sz="1050" b="0">
+                <a:solidFill>
+                  <a:srgbClr val="000000"/>
+                </a:solidFill>
+                <a:latin typeface="맑은 고딕"/>
+                <a:ea typeface="맑은 고딕"/>
+              </a:rPr>
+              <a:t>를 지원하는가? 기간과 만료일이 정해졌는가?</a:t>
+            </a:r>
+          </a:p>
+          <a:p>
+            <a:pPr lvl="3" marL="947420" indent="-223520">
+              <a:spcBef>
+                <a:spcPts val="300"/>
+              </a:spcBef>
+              <a:spcAft>
+                <a:spcPts val="300"/>
+              </a:spcAft>
+              <a:buNone/>
+            </a:pPr>
+            <a:r>
+              <a:rPr sz="1600" b="0">
+                <a:solidFill>
+                  <a:srgbClr val="000000"/>
+                </a:solidFill>
+                <a:latin typeface="맑은 고딕"/>
+                <a:ea typeface="맑은 고딕"/>
+              </a:rPr>
+              <a:t>4. </a:t>
+            </a:r>
+            <a:r>
+              <a:rPr sz="1600" b="1">
+                <a:solidFill>
+                  <a:srgbClr val="000000"/>
+                </a:solidFill>
+                <a:latin typeface="맑은 고딕"/>
+                <a:ea typeface="맑은 고딕"/>
+              </a:rPr>
+              <a:t>취소·반품·해지</a:t>
+            </a:r>
+            <a:r>
+              <a:rPr sz="1600" b="0">
+                <a:solidFill>
+                  <a:srgbClr val="000000"/>
+                </a:solidFill>
+                <a:latin typeface="맑은 고딕"/>
+                <a:ea typeface="맑은 고딕"/>
+              </a:rPr>
+              <a:t> —</a:t>
+            </a:r>
+            <a:r>
+              <a:rPr sz="1050" b="0">
+                <a:solidFill>
+                  <a:srgbClr val="000000"/>
+                </a:solidFill>
+                <a:latin typeface="맑은 고딕"/>
+                <a:ea typeface="맑은 고딕"/>
+              </a:rPr>
+              <a:t> 취소한 회차의 </a:t>
+            </a:r>
+            <a:r>
+              <a:rPr sz="1050" b="1">
+                <a:solidFill>
+                  <a:srgbClr val="000000"/>
+                </a:solidFill>
+                <a:latin typeface="맑은 고딕"/>
+                <a:ea typeface="맑은 고딕"/>
+              </a:rPr>
+              <a:t>환불 방법</a:t>
+            </a:r>
+            <a:r>
+              <a:rPr sz="1050" b="0">
+                <a:solidFill>
+                  <a:srgbClr val="000000"/>
+                </a:solidFill>
+                <a:latin typeface="맑은 고딕"/>
+                <a:ea typeface="맑은 고딕"/>
+              </a:rPr>
+              <a:t>, 반품할 수 있는 상품과 </a:t>
+            </a:r>
+            <a:r>
+              <a:rPr sz="1050" b="1">
+                <a:solidFill>
+                  <a:srgbClr val="000000"/>
+                </a:solidFill>
+                <a:latin typeface="맑은 고딕"/>
+                <a:ea typeface="맑은 고딕"/>
+              </a:rPr>
+              <a:t>반품 기한·절차</a:t>
+            </a:r>
+            <a:r>
+              <a:rPr sz="1050" b="0">
+                <a:solidFill>
+                  <a:srgbClr val="000000"/>
+                </a:solidFill>
+                <a:latin typeface="맑은 고딕"/>
+                <a:ea typeface="맑은 고딕"/>
+              </a:rPr>
+              <a:t>, 해지할 때 </a:t>
+            </a:r>
+            <a:r>
+              <a:rPr sz="1050" b="1">
+                <a:solidFill>
+                  <a:srgbClr val="000000"/>
+                </a:solidFill>
+                <a:latin typeface="맑은 고딕"/>
+                <a:ea typeface="맑은 고딕"/>
+              </a:rPr>
+              <a:t>남은 금액</a:t>
+            </a:r>
+            <a:r>
+              <a:rPr sz="1050" b="0">
+                <a:solidFill>
+                  <a:srgbClr val="000000"/>
+                </a:solidFill>
+                <a:latin typeface="맑은 고딕"/>
+                <a:ea typeface="맑은 고딕"/>
+              </a:rPr>
+              <a:t>의 처리</a:t>
+            </a:r>
+          </a:p>
+          <a:p>
+            <a:pPr lvl="3" marL="947420" indent="-223520">
+              <a:spcBef>
+                <a:spcPts val="300"/>
+              </a:spcBef>
+              <a:spcAft>
+                <a:spcPts val="300"/>
+              </a:spcAft>
+              <a:buNone/>
+            </a:pPr>
+            <a:r>
+              <a:rPr sz="1600" b="0">
+                <a:solidFill>
+                  <a:srgbClr val="000000"/>
+                </a:solidFill>
+                <a:latin typeface="맑은 고딕"/>
+                <a:ea typeface="맑은 고딕"/>
+              </a:rPr>
+              <a:t>5. </a:t>
+            </a:r>
+            <a:r>
+              <a:rPr sz="1600" b="1">
+                <a:solidFill>
+                  <a:srgbClr val="000000"/>
+                </a:solidFill>
+                <a:latin typeface="맑은 고딕"/>
+                <a:ea typeface="맑은 고딕"/>
+              </a:rPr>
+              <a:t>기술 용어</a:t>
+            </a:r>
+            <a:r>
+              <a:rPr sz="1600" b="0">
+                <a:solidFill>
+                  <a:srgbClr val="000000"/>
+                </a:solidFill>
+                <a:latin typeface="맑은 고딕"/>
+                <a:ea typeface="맑은 고딕"/>
+              </a:rPr>
+              <a:t> —</a:t>
+            </a:r>
+            <a:r>
+              <a:rPr sz="1050" b="0">
+                <a:solidFill>
+                  <a:srgbClr val="000000"/>
+                </a:solidFill>
+                <a:latin typeface="맑은 고딕"/>
+                <a:ea typeface="맑은 고딕"/>
+              </a:rPr>
+              <a:t> 화면·버튼·DB·API 같은 구현 표현이 없는가?</a:t>
+            </a:r>
+          </a:p>
+          <a:p>
+            <a:pPr lvl="3" marL="947420" indent="-223520">
+              <a:spcBef>
+                <a:spcPts val="300"/>
+              </a:spcBef>
+              <a:spcAft>
+                <a:spcPts val="300"/>
+              </a:spcAft>
+              <a:buNone/>
+            </a:pPr>
+            <a:r>
+              <a:rPr sz="1600" b="0">
+                <a:solidFill>
+                  <a:srgbClr val="000000"/>
+                </a:solidFill>
+                <a:latin typeface="맑은 고딕"/>
+                <a:ea typeface="맑은 고딕"/>
+              </a:rPr>
+              <a:t>6. </a:t>
+            </a:r>
+            <a:r>
+              <a:rPr sz="1600" b="1">
+                <a:solidFill>
+                  <a:srgbClr val="000000"/>
+                </a:solidFill>
+                <a:latin typeface="맑은 고딕"/>
+                <a:ea typeface="맑은 고딕"/>
+              </a:rPr>
+              <a:t>미확정 항목</a:t>
+            </a:r>
+            <a:r>
+              <a:rPr sz="1600" b="0">
+                <a:solidFill>
+                  <a:srgbClr val="000000"/>
+                </a:solidFill>
+                <a:latin typeface="맑은 고딕"/>
+                <a:ea typeface="맑은 고딕"/>
+              </a:rPr>
+              <a:t> —</a:t>
+            </a:r>
+            <a:r>
+              <a:rPr sz="1050" b="0">
+                <a:solidFill>
+                  <a:srgbClr val="000000"/>
+                </a:solidFill>
+                <a:latin typeface="맑은 고딕"/>
+                <a:ea typeface="맑은 고딕"/>
+              </a:rPr>
+              <a:t> 질문을 모두 확인해 없앴는가? 남긴 항목이 있다면 그 이유가 분명한가?</a:t>
+            </a:r>
+          </a:p>
+          <a:p>
+            <a:pPr lvl="2" marL="723900" indent="-368300">
+              <a:spcBef>
+                <a:spcPts val="300"/>
+              </a:spcBef>
+              <a:spcAft>
+                <a:spcPts val="300"/>
+              </a:spcAft>
+              <a:buSzPct val="90000"/>
+              <a:buFont typeface="Wingdings" pitchFamily="2" charset="2"/>
+              <a:buChar char=""/>
+            </a:pPr>
+            <a:r>
+              <a:rPr sz="1800" b="1">
+                <a:solidFill>
+                  <a:srgbClr val="000000"/>
+                </a:solidFill>
+                <a:latin typeface="맑은 고딕"/>
+                <a:ea typeface="맑은 고딕"/>
+              </a:rPr>
+              <a:t>결과물</a:t>
             </a:r>
             <a:r>
               <a:rPr sz="1800" b="0">
@@ -35618,144 +36171,14 @@
               <a:t> —</a:t>
             </a:r>
             <a:r>
-              <a:rPr sz="1600" b="0">
-                <a:solidFill>
-                  <a:srgbClr val="000000"/>
-                </a:solidFill>
-                <a:latin typeface="맑은 고딕"/>
-                <a:ea typeface="맑은 고딕"/>
-              </a:rPr>
-              <a:t> 구현 전에 </a:t>
-            </a:r>
-            <a:r>
-              <a:rPr sz="1200" b="0">
-                <a:solidFill>
-                  <a:srgbClr val="000000"/>
-                </a:solidFill>
-                <a:latin typeface="맑은 고딕"/>
-                <a:ea typeface="맑은 고딕"/>
-              </a:rPr>
-              <a:t>(1)</a:t>
-            </a:r>
-            <a:r>
-              <a:rPr sz="1600" b="0">
-                <a:solidFill>
-                  <a:srgbClr val="000000"/>
-                </a:solidFill>
-                <a:latin typeface="맑은 고딕"/>
-                <a:ea typeface="맑은 고딕"/>
-              </a:rPr>
-              <a:t> 문제 </a:t>
-            </a:r>
-            <a:r>
-              <a:rPr sz="1200" b="0">
-                <a:solidFill>
-                  <a:srgbClr val="000000"/>
-                </a:solidFill>
-                <a:latin typeface="맑은 고딕"/>
-                <a:ea typeface="맑은 고딕"/>
-              </a:rPr>
-              <a:t>(2)</a:t>
-            </a:r>
-            <a:r>
-              <a:rPr sz="1600" b="0">
-                <a:solidFill>
-                  <a:srgbClr val="000000"/>
-                </a:solidFill>
-                <a:latin typeface="맑은 고딕"/>
-                <a:ea typeface="맑은 고딕"/>
-              </a:rPr>
-              <a:t> 요구사항 </a:t>
-            </a:r>
-            <a:r>
-              <a:rPr sz="1200" b="0">
-                <a:solidFill>
-                  <a:srgbClr val="000000"/>
-                </a:solidFill>
-                <a:latin typeface="맑은 고딕"/>
-                <a:ea typeface="맑은 고딕"/>
-              </a:rPr>
-              <a:t>(3)</a:t>
-            </a:r>
-            <a:r>
-              <a:rPr sz="1600" b="0">
-                <a:solidFill>
-                  <a:srgbClr val="000000"/>
-                </a:solidFill>
-                <a:latin typeface="맑은 고딕"/>
-                <a:ea typeface="맑은 고딕"/>
-              </a:rPr>
-              <a:t> 제약 </a:t>
-            </a:r>
-            <a:r>
-              <a:rPr sz="1200" b="0">
-                <a:solidFill>
-                  <a:srgbClr val="000000"/>
-                </a:solidFill>
-                <a:latin typeface="맑은 고딕"/>
-                <a:ea typeface="맑은 고딕"/>
-              </a:rPr>
-              <a:t>(4)</a:t>
-            </a:r>
-            <a:r>
-              <a:rPr sz="1600" b="0">
-                <a:solidFill>
-                  <a:srgbClr val="000000"/>
-                </a:solidFill>
-                <a:latin typeface="맑은 고딕"/>
-                <a:ea typeface="맑은 고딕"/>
-              </a:rPr>
-              <a:t> 해결책을 구분하고, </a:t>
-            </a:r>
-            <a:r>
-              <a:rPr sz="1600" b="0">
-                <a:solidFill>
-                  <a:srgbClr val="000000"/>
-                </a:solidFill>
-                <a:latin typeface="맑은 고딕"/>
-                <a:ea typeface="맑은 고딕"/>
-              </a:rPr>
-              <a:t>취소 버튼</a:t>
-            </a:r>
-            <a:r>
-              <a:rPr sz="1600" b="0">
-                <a:solidFill>
-                  <a:srgbClr val="000000"/>
-                </a:solidFill>
-                <a:latin typeface="맑은 고딕"/>
-                <a:ea typeface="맑은 고딕"/>
-              </a:rPr>
-              <a:t>이 어느 항목에 해당하는지 판단한다. 주어진 사실과 추정을 구분해 추정을 확인할 질문을 하나 작성한다. 마지막으로 요청을 </a:t>
-            </a:r>
-            <a:r>
-              <a:rPr sz="1600" b="1">
-                <a:solidFill>
-                  <a:srgbClr val="000000"/>
-                </a:solidFill>
-                <a:latin typeface="맑은 고딕"/>
-                <a:ea typeface="맑은 고딕"/>
-              </a:rPr>
-              <a:t>이벤트 하나</a:t>
-            </a:r>
-            <a:r>
-              <a:rPr sz="1200" b="0">
-                <a:solidFill>
-                  <a:srgbClr val="000000"/>
-                </a:solidFill>
-                <a:latin typeface="맑은 고딕"/>
-                <a:ea typeface="맑은 고딕"/>
-              </a:rPr>
-              <a:t>(무엇이 일어나면 어떤 결과가 필요한가)</a:t>
-            </a:r>
-            <a:r>
-              <a:rPr sz="1600" b="0">
-                <a:solidFill>
-                  <a:srgbClr val="000000"/>
-                </a:solidFill>
-                <a:latin typeface="맑은 고딕"/>
-                <a:ea typeface="맑은 고딕"/>
-              </a:rPr>
-              <a:t>로 다시 쓴다.</a:t>
+              <a:rPr sz="1050" b="0">
+                <a:solidFill>
+                  <a:srgbClr val="000000"/>
+                </a:solidFill>
+                <a:latin typeface="맑은 고딕"/>
+                <a:ea typeface="맑은 고딕"/>
+              </a:rPr>
+              <a:t> 확인할 질문이 남지 않은 요구사항 명세서. 실습 2의 입력이 됩니다.</a:t>
             </a:r>
           </a:p>
         </p:txBody>
@@ -35825,17 +36248,17 @@
                 <a:latin typeface="맑은 고딕"/>
                 <a:ea typeface="맑은 고딕"/>
               </a:rPr>
-              <a:t>34. 실습 — 검토 예시</a:t>
-            </a:r>
-            <a:r>
-              <a:rPr sz="2000" b="1">
-                <a:solidFill>
-                  <a:srgbClr val="000000"/>
-                </a:solidFill>
-                <a:latin typeface="맑은 고딕"/>
-                <a:ea typeface="맑은 고딕"/>
-              </a:rPr>
-              <a:t>(모범답안)</a:t>
+              <a:t>34. 요구사항 명세서 </a:t>
+            </a:r>
+            <a:r>
+              <a:rPr sz="1800" b="1">
+                <a:solidFill>
+                  <a:srgbClr val="000000"/>
+                </a:solidFill>
+                <a:latin typeface="맑은 고딕"/>
+                <a:ea typeface="맑은 고딕"/>
+              </a:rPr>
+              <a:t>(안)</a:t>
             </a:r>
           </a:p>
         </p:txBody>
@@ -35969,289 +36392,1424 @@
             <p:ph idx="1"/>
           </p:nvPr>
         </p:nvSpPr>
-        <p:spPr/>
+        <p:spPr>
+          <a:xfrm>
+            <a:off x="233172" y="1818409"/>
+            <a:ext cx="4338828" cy="4664687"/>
+          </a:xfrm>
+        </p:spPr>
         <p:txBody>
           <a:bodyPr>
             <a:normAutofit/>
           </a:bodyPr>
           <a:lstStyle/>
           <a:p>
-            <a:pPr marL="0" indent="0">
+            <a:pPr lvl="2" marL="228600" indent="-182880">
               <a:spcBef>
-                <a:spcPts val="600"/>
+                <a:spcPts val="300"/>
               </a:spcBef>
               <a:spcAft>
-                <a:spcPts val="600"/>
-              </a:spcAft>
-              <a:buNone/>
-            </a:pPr>
-            <a:r>
-              <a:rPr sz="1800" b="0">
-                <a:solidFill>
-                  <a:srgbClr val="000000"/>
-                </a:solidFill>
-                <a:latin typeface="맑은 고딕"/>
-                <a:ea typeface="맑은 고딕"/>
-              </a:rPr>
-              <a:t>「33. 실습 —</a:t>
-            </a:r>
-            <a:r>
-              <a:rPr sz="1600" b="0">
-                <a:solidFill>
-                  <a:srgbClr val="000000"/>
-                </a:solidFill>
-                <a:latin typeface="맑은 고딕"/>
-                <a:ea typeface="맑은 고딕"/>
-              </a:rPr>
-              <a:t> 문제·요구사항·해결책」의 </a:t>
-            </a:r>
-            <a:r>
-              <a:rPr sz="1600" b="1">
-                <a:solidFill>
-                  <a:srgbClr val="000000"/>
-                </a:solidFill>
-                <a:latin typeface="맑은 고딕"/>
-                <a:ea typeface="맑은 고딕"/>
-              </a:rPr>
-              <a:t>하나의 모범 예</a:t>
-            </a:r>
-            <a:r>
-              <a:rPr sz="1600" b="0">
-                <a:solidFill>
-                  <a:srgbClr val="000000"/>
-                </a:solidFill>
-                <a:latin typeface="맑은 고딕"/>
-                <a:ea typeface="맑은 고딕"/>
-              </a:rPr>
-              <a:t>다 — 유일한 정답이 아니라, "수준을 구분했는가"를 보여주는 예시다. 아래는 </a:t>
-            </a:r>
-            <a:r>
-              <a:rPr sz="1600" b="1">
-                <a:solidFill>
-                  <a:srgbClr val="000000"/>
-                </a:solidFill>
-                <a:latin typeface="맑은 고딕"/>
-                <a:ea typeface="맑은 고딕"/>
-              </a:rPr>
-              <a:t>고객이 현재 직접 취소할 수 없다는 가정</a:t>
-            </a:r>
-            <a:r>
-              <a:rPr sz="1600" b="0">
-                <a:solidFill>
-                  <a:srgbClr val="000000"/>
-                </a:solidFill>
-                <a:latin typeface="맑은 고딕"/>
-                <a:ea typeface="맑은 고딕"/>
-              </a:rPr>
-              <a:t>에 따른 검토이며, 실제 원인은 요청자에게 확인해야 한다.</a:t>
-            </a:r>
-          </a:p>
-          <a:p>
-            <a:pPr lvl="2" marL="723900" indent="-368300">
-              <a:spcBef>
-                <a:spcPts val="600"/>
-              </a:spcBef>
-              <a:spcAft>
-                <a:spcPts val="600"/>
+                <a:spcPts val="300"/>
               </a:spcAft>
               <a:buSzPct val="90000"/>
               <a:buFont typeface="Wingdings" pitchFamily="2" charset="2"/>
               <a:buChar char=""/>
             </a:pPr>
             <a:r>
-              <a:rPr sz="1800" b="1">
-                <a:solidFill>
-                  <a:srgbClr val="000000"/>
-                </a:solidFill>
-                <a:latin typeface="맑은 고딕"/>
-                <a:ea typeface="맑은 고딕"/>
-              </a:rPr>
-              <a:t>문제</a:t>
-            </a:r>
-            <a:r>
-              <a:rPr sz="1800" b="0">
-                <a:solidFill>
-                  <a:srgbClr val="000000"/>
-                </a:solidFill>
-                <a:latin typeface="맑은 고딕"/>
-                <a:ea typeface="맑은 고딕"/>
-              </a:rPr>
-              <a:t> —</a:t>
-            </a:r>
-            <a:r>
-              <a:rPr sz="1600" b="0">
-                <a:solidFill>
-                  <a:srgbClr val="000000"/>
-                </a:solidFill>
-                <a:latin typeface="맑은 고딕"/>
-                <a:ea typeface="맑은 고딕"/>
-              </a:rPr>
-              <a:t> 고객이 취소 가능한 주문을 직접 취소할 수 없음</a:t>
-            </a:r>
-          </a:p>
-          <a:p>
-            <a:pPr lvl="2" marL="723900" indent="-368300">
+              <a:rPr sz="1400" b="1">
+                <a:solidFill>
+                  <a:srgbClr val="000000"/>
+                </a:solidFill>
+                <a:latin typeface="맑은 고딕"/>
+                <a:ea typeface="맑은 고딕"/>
+              </a:rPr>
+              <a:t>기능 요구</a:t>
+            </a:r>
+          </a:p>
+          <a:p>
+            <a:pPr lvl="3" marL="457200" indent="-182880">
               <a:spcBef>
-                <a:spcPts val="600"/>
+                <a:spcPts val="300"/>
               </a:spcBef>
               <a:spcAft>
-                <a:spcPts val="600"/>
+                <a:spcPts val="300"/>
+              </a:spcAft>
+              <a:buSzPct val="90000"/>
+              <a:buFont typeface="Wingdings" pitchFamily="2" charset="2"/>
+              <a:buChar char=""/>
+            </a:pPr>
+            <a:r>
+              <a:rPr sz="1200" b="1">
+                <a:solidFill>
+                  <a:srgbClr val="000000"/>
+                </a:solidFill>
+                <a:latin typeface="맑은 고딕"/>
+                <a:ea typeface="맑은 고딕"/>
+              </a:rPr>
+              <a:t>F1 신청</a:t>
+            </a:r>
+            <a:r>
+              <a:rPr sz="1200" b="0">
+                <a:solidFill>
+                  <a:srgbClr val="000000"/>
+                </a:solidFill>
+                <a:latin typeface="맑은 고딕"/>
+                <a:ea typeface="맑은 고딕"/>
+              </a:rPr>
+              <a:t> —</a:t>
+            </a:r>
+            <a:r>
+              <a:rPr sz="1000" b="0">
+                <a:solidFill>
+                  <a:srgbClr val="000000"/>
+                </a:solidFill>
+                <a:latin typeface="맑은 고딕"/>
+                <a:ea typeface="맑은 고딕"/>
+              </a:rPr>
+              <a:t> 상품·수량·주기·첫 배송일·기간·배송지를 정해 신청</a:t>
+            </a:r>
+          </a:p>
+          <a:p>
+            <a:pPr lvl="3" marL="457200" indent="-182880">
+              <a:spcBef>
+                <a:spcPts val="300"/>
+              </a:spcBef>
+              <a:spcAft>
+                <a:spcPts val="300"/>
+              </a:spcAft>
+              <a:buSzPct val="90000"/>
+              <a:buFont typeface="Wingdings" pitchFamily="2" charset="2"/>
+              <a:buChar char=""/>
+            </a:pPr>
+            <a:r>
+              <a:rPr sz="1200" b="1">
+                <a:solidFill>
+                  <a:srgbClr val="000000"/>
+                </a:solidFill>
+                <a:latin typeface="맑은 고딕"/>
+                <a:ea typeface="맑은 고딕"/>
+              </a:rPr>
+              <a:t>F2 결제</a:t>
+            </a:r>
+            <a:r>
+              <a:rPr sz="1200" b="0">
+                <a:solidFill>
+                  <a:srgbClr val="000000"/>
+                </a:solidFill>
+                <a:latin typeface="맑은 고딕"/>
+                <a:ea typeface="맑은 고딕"/>
+              </a:rPr>
+              <a:t> —</a:t>
+            </a:r>
+            <a:r>
+              <a:rPr sz="1000" b="0">
+                <a:solidFill>
+                  <a:srgbClr val="000000"/>
+                </a:solidFill>
+                <a:latin typeface="맑은 고딕"/>
+                <a:ea typeface="맑은 고딕"/>
+              </a:rPr>
+              <a:t> 결제 방법과 청구 방식을 골라 결제</a:t>
+            </a:r>
+          </a:p>
+          <a:p>
+            <a:pPr lvl="3" marL="457200" indent="-182880">
+              <a:spcBef>
+                <a:spcPts val="300"/>
+              </a:spcBef>
+              <a:spcAft>
+                <a:spcPts val="300"/>
+              </a:spcAft>
+              <a:buSzPct val="90000"/>
+              <a:buFont typeface="Wingdings" pitchFamily="2" charset="2"/>
+              <a:buChar char=""/>
+            </a:pPr>
+            <a:r>
+              <a:rPr sz="1200" b="1">
+                <a:solidFill>
+                  <a:srgbClr val="000000"/>
+                </a:solidFill>
+                <a:latin typeface="맑은 고딕"/>
+                <a:ea typeface="맑은 고딕"/>
+              </a:rPr>
+              <a:t>F3 배송 요청</a:t>
+            </a:r>
+            <a:r>
+              <a:rPr sz="1200" b="0">
+                <a:solidFill>
+                  <a:srgbClr val="000000"/>
+                </a:solidFill>
+                <a:latin typeface="맑은 고딕"/>
+                <a:ea typeface="맑은 고딕"/>
+              </a:rPr>
+              <a:t> —</a:t>
+            </a:r>
+            <a:r>
+              <a:rPr sz="1000" b="0">
+                <a:solidFill>
+                  <a:srgbClr val="000000"/>
+                </a:solidFill>
+                <a:latin typeface="맑은 고딕"/>
+                <a:ea typeface="맑은 고딕"/>
+              </a:rPr>
+              <a:t> 배송일마다 배송 시스템에 요청</a:t>
+            </a:r>
+          </a:p>
+          <a:p>
+            <a:pPr lvl="3" marL="457200" indent="-182880">
+              <a:spcBef>
+                <a:spcPts val="300"/>
+              </a:spcBef>
+              <a:spcAft>
+                <a:spcPts val="300"/>
+              </a:spcAft>
+              <a:buSzPct val="90000"/>
+              <a:buFont typeface="Wingdings" pitchFamily="2" charset="2"/>
+              <a:buChar char=""/>
+            </a:pPr>
+            <a:r>
+              <a:rPr sz="1200" b="1">
+                <a:solidFill>
+                  <a:srgbClr val="000000"/>
+                </a:solidFill>
+                <a:latin typeface="맑은 고딕"/>
+                <a:ea typeface="맑은 고딕"/>
+              </a:rPr>
+              <a:t>F4 취소</a:t>
+            </a:r>
+            <a:r>
+              <a:rPr sz="1200" b="0">
+                <a:solidFill>
+                  <a:srgbClr val="000000"/>
+                </a:solidFill>
+                <a:latin typeface="맑은 고딕"/>
+                <a:ea typeface="맑은 고딕"/>
+              </a:rPr>
+              <a:t> —</a:t>
+            </a:r>
+            <a:r>
+              <a:rPr sz="1000" b="0">
+                <a:solidFill>
+                  <a:srgbClr val="000000"/>
+                </a:solidFill>
+                <a:latin typeface="맑은 고딕"/>
+                <a:ea typeface="맑은 고딕"/>
+              </a:rPr>
+              <a:t> 다음 배송을 취소하고 그 회차 금액을 환불</a:t>
+            </a:r>
+          </a:p>
+          <a:p>
+            <a:pPr lvl="3" marL="457200" indent="-182880">
+              <a:spcBef>
+                <a:spcPts val="300"/>
+              </a:spcBef>
+              <a:spcAft>
+                <a:spcPts val="300"/>
+              </a:spcAft>
+              <a:buSzPct val="90000"/>
+              <a:buFont typeface="Wingdings" pitchFamily="2" charset="2"/>
+              <a:buChar char=""/>
+            </a:pPr>
+            <a:r>
+              <a:rPr sz="1200" b="1">
+                <a:solidFill>
+                  <a:srgbClr val="000000"/>
+                </a:solidFill>
+                <a:latin typeface="맑은 고딕"/>
+                <a:ea typeface="맑은 고딕"/>
+              </a:rPr>
+              <a:t>F5 반품</a:t>
+            </a:r>
+            <a:r>
+              <a:rPr sz="1200" b="0">
+                <a:solidFill>
+                  <a:srgbClr val="000000"/>
+                </a:solidFill>
+                <a:latin typeface="맑은 고딕"/>
+                <a:ea typeface="맑은 고딕"/>
+              </a:rPr>
+              <a:t> —</a:t>
+            </a:r>
+            <a:r>
+              <a:rPr sz="1000" b="0">
+                <a:solidFill>
+                  <a:srgbClr val="000000"/>
+                </a:solidFill>
+                <a:latin typeface="맑은 고딕"/>
+                <a:ea typeface="맑은 고딕"/>
+              </a:rPr>
+              <a:t> 반품을 신청하고, 회수가 확인되면 환불</a:t>
+            </a:r>
+          </a:p>
+          <a:p>
+            <a:pPr lvl="3" marL="457200" indent="-182880">
+              <a:spcBef>
+                <a:spcPts val="300"/>
+              </a:spcBef>
+              <a:spcAft>
+                <a:spcPts val="300"/>
+              </a:spcAft>
+              <a:buSzPct val="90000"/>
+              <a:buFont typeface="Wingdings" pitchFamily="2" charset="2"/>
+              <a:buChar char=""/>
+            </a:pPr>
+            <a:r>
+              <a:rPr sz="1200" b="1">
+                <a:solidFill>
+                  <a:srgbClr val="000000"/>
+                </a:solidFill>
+                <a:latin typeface="맑은 고딕"/>
+                <a:ea typeface="맑은 고딕"/>
+              </a:rPr>
+              <a:t>F6 해지</a:t>
+            </a:r>
+            <a:r>
+              <a:rPr sz="1200" b="0">
+                <a:solidFill>
+                  <a:srgbClr val="000000"/>
+                </a:solidFill>
+                <a:latin typeface="맑은 고딕"/>
+                <a:ea typeface="맑은 고딕"/>
+              </a:rPr>
+              <a:t> —</a:t>
+            </a:r>
+            <a:r>
+              <a:rPr sz="1000" b="0">
+                <a:solidFill>
+                  <a:srgbClr val="000000"/>
+                </a:solidFill>
+                <a:latin typeface="맑은 고딕"/>
+                <a:ea typeface="맑은 고딕"/>
+              </a:rPr>
+              <a:t> 해지하고, 배송되지 않은 회차 금액을 환불</a:t>
+            </a:r>
+          </a:p>
+          <a:p>
+            <a:pPr lvl="2" marL="228600" indent="-182880">
+              <a:spcBef>
+                <a:spcPts val="300"/>
+              </a:spcBef>
+              <a:spcAft>
+                <a:spcPts val="300"/>
               </a:spcAft>
               <a:buSzPct val="90000"/>
               <a:buFont typeface="Wingdings" pitchFamily="2" charset="2"/>
               <a:buChar char=""/>
             </a:pPr>
             <a:r>
-              <a:rPr sz="1800" b="1">
-                <a:solidFill>
-                  <a:srgbClr val="000000"/>
-                </a:solidFill>
-                <a:latin typeface="맑은 고딕"/>
-                <a:ea typeface="맑은 고딕"/>
-              </a:rPr>
-              <a:t>요구사항</a:t>
-            </a:r>
-            <a:r>
-              <a:rPr sz="1800" b="0">
-                <a:solidFill>
-                  <a:srgbClr val="000000"/>
-                </a:solidFill>
-                <a:latin typeface="맑은 고딕"/>
-                <a:ea typeface="맑은 고딕"/>
-              </a:rPr>
-              <a:t> —</a:t>
-            </a:r>
-            <a:r>
-              <a:rPr sz="1600" b="0">
-                <a:solidFill>
-                  <a:srgbClr val="000000"/>
-                </a:solidFill>
-                <a:latin typeface="맑은 고딕"/>
-                <a:ea typeface="맑은 고딕"/>
-              </a:rPr>
-              <a:t> 배송 시작 전 주문을 고객이 직접 취소하고 결제 금액을 환불받을 수 있어야 함</a:t>
-            </a:r>
-          </a:p>
-          <a:p>
-            <a:pPr lvl="2" marL="723900" indent="-368300">
+              <a:rPr sz="1400" b="1">
+                <a:solidFill>
+                  <a:srgbClr val="000000"/>
+                </a:solidFill>
+                <a:latin typeface="맑은 고딕"/>
+                <a:ea typeface="맑은 고딕"/>
+              </a:rPr>
+              <a:t>업무 규칙: 신청·금액·결제</a:t>
+            </a:r>
+          </a:p>
+          <a:p>
+            <a:pPr lvl="3" marL="457200" indent="-182880">
               <a:spcBef>
-                <a:spcPts val="600"/>
+                <a:spcPts val="300"/>
               </a:spcBef>
               <a:spcAft>
-                <a:spcPts val="600"/>
+                <a:spcPts val="300"/>
+              </a:spcAft>
+              <a:buSzPct val="90000"/>
+              <a:buFont typeface="Wingdings" pitchFamily="2" charset="2"/>
+              <a:buChar char=""/>
+            </a:pPr>
+            <a:r>
+              <a:rPr sz="1200" b="1">
+                <a:solidFill>
+                  <a:srgbClr val="000000"/>
+                </a:solidFill>
+                <a:latin typeface="맑은 고딕"/>
+                <a:ea typeface="맑은 고딕"/>
+              </a:rPr>
+              <a:t>R1 배송 주기</a:t>
+            </a:r>
+            <a:r>
+              <a:rPr sz="1200" b="0">
+                <a:solidFill>
+                  <a:srgbClr val="000000"/>
+                </a:solidFill>
+                <a:latin typeface="맑은 고딕"/>
+                <a:ea typeface="맑은 고딕"/>
+              </a:rPr>
+              <a:t> —</a:t>
+            </a:r>
+            <a:r>
+              <a:rPr sz="1000" b="0">
+                <a:solidFill>
+                  <a:srgbClr val="000000"/>
+                </a:solidFill>
+                <a:latin typeface="맑은 고딕"/>
+                <a:ea typeface="맑은 고딕"/>
+              </a:rPr>
+              <a:t> 1~28일, 일 단위</a:t>
+            </a:r>
+            <a:r>
+              <a:rPr sz="800" b="0">
+                <a:solidFill>
+                  <a:srgbClr val="000000"/>
+                </a:solidFill>
+                <a:latin typeface="맑은 고딕"/>
+                <a:ea typeface="맑은 고딕"/>
+              </a:rPr>
+              <a:t>(매일·격일·3일·1주·10일·2주·4주 등)</a:t>
+            </a:r>
+          </a:p>
+          <a:p>
+            <a:pPr lvl="3" marL="457200" indent="-182880">
+              <a:spcBef>
+                <a:spcPts val="300"/>
+              </a:spcBef>
+              <a:spcAft>
+                <a:spcPts val="300"/>
+              </a:spcAft>
+              <a:buSzPct val="90000"/>
+              <a:buFont typeface="Wingdings" pitchFamily="2" charset="2"/>
+              <a:buChar char=""/>
+            </a:pPr>
+            <a:r>
+              <a:rPr sz="1200" b="1">
+                <a:solidFill>
+                  <a:srgbClr val="000000"/>
+                </a:solidFill>
+                <a:latin typeface="맑은 고딕"/>
+                <a:ea typeface="맑은 고딕"/>
+              </a:rPr>
+              <a:t>R2 배송일</a:t>
+            </a:r>
+            <a:r>
+              <a:rPr sz="1200" b="0">
+                <a:solidFill>
+                  <a:srgbClr val="000000"/>
+                </a:solidFill>
+                <a:latin typeface="맑은 고딕"/>
+                <a:ea typeface="맑은 고딕"/>
+              </a:rPr>
+              <a:t> —</a:t>
+            </a:r>
+            <a:r>
+              <a:rPr sz="1000" b="0">
+                <a:solidFill>
+                  <a:srgbClr val="000000"/>
+                </a:solidFill>
+                <a:latin typeface="맑은 고딕"/>
+                <a:ea typeface="맑은 고딕"/>
+              </a:rPr>
+              <a:t> 첫 배송일은 신청 다음 날부터 7일 안에서 고르고, 이후는 주기마다 정해진다.</a:t>
+            </a:r>
+          </a:p>
+          <a:p>
+            <a:pPr lvl="3" marL="457200" indent="-182880">
+              <a:spcBef>
+                <a:spcPts val="300"/>
+              </a:spcBef>
+              <a:spcAft>
+                <a:spcPts val="300"/>
+              </a:spcAft>
+              <a:buSzPct val="90000"/>
+              <a:buFont typeface="Wingdings" pitchFamily="2" charset="2"/>
+              <a:buChar char=""/>
+            </a:pPr>
+            <a:r>
+              <a:rPr sz="1200" b="1">
+                <a:solidFill>
+                  <a:srgbClr val="000000"/>
+                </a:solidFill>
+                <a:latin typeface="맑은 고딕"/>
+                <a:ea typeface="맑은 고딕"/>
+              </a:rPr>
+              <a:t>R3 기간</a:t>
+            </a:r>
+            <a:r>
+              <a:rPr sz="1200" b="0">
+                <a:solidFill>
+                  <a:srgbClr val="000000"/>
+                </a:solidFill>
+                <a:latin typeface="맑은 고딕"/>
+                <a:ea typeface="맑은 고딕"/>
+              </a:rPr>
+              <a:t> —</a:t>
+            </a:r>
+            <a:r>
+              <a:rPr sz="1000" b="0">
+                <a:solidFill>
+                  <a:srgbClr val="000000"/>
+                </a:solidFill>
+                <a:latin typeface="맑은 고딕"/>
+                <a:ea typeface="맑은 고딕"/>
+              </a:rPr>
+              <a:t> 1~12개월. 만료일은 첫 배송일 + 기간의 </a:t>
+            </a:r>
+            <a:r>
+              <a:rPr sz="1000" b="1">
+                <a:solidFill>
+                  <a:srgbClr val="000000"/>
+                </a:solidFill>
+                <a:latin typeface="맑은 고딕"/>
+                <a:ea typeface="맑은 고딕"/>
+              </a:rPr>
+              <a:t>전날</a:t>
+            </a:r>
+            <a:r>
+              <a:rPr sz="1000" b="0">
+                <a:solidFill>
+                  <a:srgbClr val="000000"/>
+                </a:solidFill>
+                <a:latin typeface="맑은 고딕"/>
+                <a:ea typeface="맑은 고딕"/>
+              </a:rPr>
+              <a:t>이며, 자동 연장하지 않는다.</a:t>
+            </a:r>
+          </a:p>
+          <a:p>
+            <a:pPr lvl="3" marL="457200" indent="-182880">
+              <a:spcBef>
+                <a:spcPts val="300"/>
+              </a:spcBef>
+              <a:spcAft>
+                <a:spcPts val="300"/>
+              </a:spcAft>
+              <a:buSzPct val="90000"/>
+              <a:buFont typeface="Wingdings" pitchFamily="2" charset="2"/>
+              <a:buChar char=""/>
+            </a:pPr>
+            <a:r>
+              <a:rPr sz="1200" b="1">
+                <a:solidFill>
+                  <a:srgbClr val="000000"/>
+                </a:solidFill>
+                <a:latin typeface="맑은 고딕"/>
+                <a:ea typeface="맑은 고딕"/>
+              </a:rPr>
+              <a:t>R4 회차 금액</a:t>
+            </a:r>
+            <a:r>
+              <a:rPr sz="1200" b="0">
+                <a:solidFill>
+                  <a:srgbClr val="000000"/>
+                </a:solidFill>
+                <a:latin typeface="맑은 고딕"/>
+                <a:ea typeface="맑은 고딕"/>
+              </a:rPr>
+              <a:t> —</a:t>
+            </a:r>
+            <a:r>
+              <a:rPr sz="1000" b="0">
+                <a:solidFill>
+                  <a:srgbClr val="000000"/>
+                </a:solidFill>
+                <a:latin typeface="맑은 고딕"/>
+                <a:ea typeface="맑은 고딕"/>
+              </a:rPr>
+              <a:t> 상품 가격 × 수량. </a:t>
+            </a:r>
+            <a:r>
+              <a:rPr sz="1000" b="1">
+                <a:solidFill>
+                  <a:srgbClr val="000000"/>
+                </a:solidFill>
+                <a:latin typeface="맑은 고딕"/>
+                <a:ea typeface="맑은 고딕"/>
+              </a:rPr>
+              <a:t>신청 때의 가격</a:t>
+            </a:r>
+            <a:r>
+              <a:rPr sz="1000" b="0">
+                <a:solidFill>
+                  <a:srgbClr val="000000"/>
+                </a:solidFill>
+                <a:latin typeface="맑은 고딕"/>
+                <a:ea typeface="맑은 고딕"/>
+              </a:rPr>
+              <a:t>을 기간 끝까지 적용한다.</a:t>
+            </a:r>
+          </a:p>
+          <a:p>
+            <a:pPr lvl="3" marL="457200" indent="-182880">
+              <a:spcBef>
+                <a:spcPts val="300"/>
+              </a:spcBef>
+              <a:spcAft>
+                <a:spcPts val="300"/>
+              </a:spcAft>
+              <a:buSzPct val="90000"/>
+              <a:buFont typeface="Wingdings" pitchFamily="2" charset="2"/>
+              <a:buChar char=""/>
+            </a:pPr>
+            <a:r>
+              <a:rPr sz="1200" b="1">
+                <a:solidFill>
+                  <a:srgbClr val="000000"/>
+                </a:solidFill>
+                <a:latin typeface="맑은 고딕"/>
+                <a:ea typeface="맑은 고딕"/>
+              </a:rPr>
+              <a:t>R5 결제 방법</a:t>
+            </a:r>
+            <a:r>
+              <a:rPr sz="1200" b="0">
+                <a:solidFill>
+                  <a:srgbClr val="000000"/>
+                </a:solidFill>
+                <a:latin typeface="맑은 고딕"/>
+                <a:ea typeface="맑은 고딕"/>
+              </a:rPr>
+              <a:t> —</a:t>
+            </a:r>
+            <a:r>
+              <a:rPr sz="1000" b="0">
+                <a:solidFill>
+                  <a:srgbClr val="000000"/>
+                </a:solidFill>
+                <a:latin typeface="맑은 고딕"/>
+                <a:ea typeface="맑은 고딕"/>
+              </a:rPr>
+              <a:t> 카드, 계좌이체, 간편결제 중 하나</a:t>
+            </a:r>
+          </a:p>
+          <a:p>
+            <a:pPr lvl="3" marL="457200" indent="-182880">
+              <a:spcBef>
+                <a:spcPts val="300"/>
+              </a:spcBef>
+              <a:spcAft>
+                <a:spcPts val="300"/>
+              </a:spcAft>
+              <a:buSzPct val="90000"/>
+              <a:buFont typeface="Wingdings" pitchFamily="2" charset="2"/>
+              <a:buChar char=""/>
+            </a:pPr>
+            <a:r>
+              <a:rPr sz="1200" b="1">
+                <a:solidFill>
+                  <a:srgbClr val="000000"/>
+                </a:solidFill>
+                <a:latin typeface="맑은 고딕"/>
+                <a:ea typeface="맑은 고딕"/>
+              </a:rPr>
+              <a:t>R6 청구 방식</a:t>
+            </a:r>
+          </a:p>
+          <a:p>
+            <a:pPr lvl="4" marL="685800" indent="-182880">
+              <a:spcBef>
+                <a:spcPts val="300"/>
+              </a:spcBef>
+              <a:spcAft>
+                <a:spcPts val="300"/>
+              </a:spcAft>
+              <a:buFont typeface="Wingdings" pitchFamily="2" charset="2"/>
+              <a:buChar char="l"/>
+            </a:pPr>
+            <a:r>
+              <a:rPr sz="1100" b="1">
+                <a:solidFill>
+                  <a:srgbClr val="000000"/>
+                </a:solidFill>
+                <a:latin typeface="맑은 고딕"/>
+                <a:ea typeface="맑은 고딕"/>
+              </a:rPr>
+              <a:t>일시불</a:t>
+            </a:r>
+            <a:r>
+              <a:rPr sz="1100" b="0">
+                <a:solidFill>
+                  <a:srgbClr val="000000"/>
+                </a:solidFill>
+                <a:latin typeface="맑은 고딕"/>
+                <a:ea typeface="맑은 고딕"/>
+              </a:rPr>
+              <a:t> —</a:t>
+            </a:r>
+            <a:r>
+              <a:rPr sz="900" b="0">
+                <a:solidFill>
+                  <a:srgbClr val="000000"/>
+                </a:solidFill>
+                <a:latin typeface="맑은 고딕"/>
+                <a:ea typeface="맑은 고딕"/>
+              </a:rPr>
+              <a:t> 신청할 때 전체 회차 금액을 청구한다.</a:t>
+            </a:r>
+          </a:p>
+          <a:p>
+            <a:pPr lvl="4" marL="685800" indent="-182880">
+              <a:spcBef>
+                <a:spcPts val="300"/>
+              </a:spcBef>
+              <a:spcAft>
+                <a:spcPts val="300"/>
+              </a:spcAft>
+              <a:buFont typeface="Wingdings" pitchFamily="2" charset="2"/>
+              <a:buChar char="l"/>
+            </a:pPr>
+            <a:r>
+              <a:rPr sz="1100" b="1">
+                <a:solidFill>
+                  <a:srgbClr val="000000"/>
+                </a:solidFill>
+                <a:latin typeface="맑은 고딕"/>
+                <a:ea typeface="맑은 고딕"/>
+              </a:rPr>
+              <a:t>월별 청구</a:t>
+            </a:r>
+            <a:r>
+              <a:rPr sz="1100" b="0">
+                <a:solidFill>
+                  <a:srgbClr val="000000"/>
+                </a:solidFill>
+                <a:latin typeface="맑은 고딕"/>
+                <a:ea typeface="맑은 고딕"/>
+              </a:rPr>
+              <a:t> —</a:t>
+            </a:r>
+            <a:r>
+              <a:rPr sz="900" b="0">
+                <a:solidFill>
+                  <a:srgbClr val="000000"/>
+                </a:solidFill>
+                <a:latin typeface="맑은 고딕"/>
+                <a:ea typeface="맑은 고딕"/>
+              </a:rPr>
+              <a:t> 매월 첫 배송일과 같은 날</a:t>
+            </a:r>
+            <a:r>
+              <a:rPr sz="800" b="0">
+                <a:solidFill>
+                  <a:srgbClr val="000000"/>
+                </a:solidFill>
+                <a:latin typeface="맑은 고딕"/>
+                <a:ea typeface="맑은 고딕"/>
+              </a:rPr>
+              <a:t>(없으면 말일)</a:t>
+            </a:r>
+            <a:r>
+              <a:rPr sz="900" b="0">
+                <a:solidFill>
+                  <a:srgbClr val="000000"/>
+                </a:solidFill>
+                <a:latin typeface="맑은 고딕"/>
+                <a:ea typeface="맑은 고딕"/>
+              </a:rPr>
+              <a:t>에 그달 회차 금액을 청구한다.</a:t>
+            </a:r>
+          </a:p>
+        </p:txBody>
+      </p:sp>
+      <p:sp>
+        <p:nvSpPr>
+          <p:cNvPr id="9" name="내용 개체 틀 7">
+            <a:extLst>
+              <a:ext uri="{FF2B5EF4-FFF2-40B4-BE49-F238E27FC236}">
+                <a16:creationId xmlns:a16="http://schemas.microsoft.com/office/drawing/2014/main" id="{BEBA2C4A-B0BF-F2E4-EA6E-614C99CBA184}"/>
+              </a:ext>
+            </a:extLst>
+          </p:cNvPr>
+          <p:cNvSpPr>
+            <a:spLocks noGrp="1"/>
+          </p:cNvSpPr>
+          <p:nvPr>
+            <p:ph idx="1"/>
+          </p:nvPr>
+        </p:nvSpPr>
+        <p:spPr>
+          <a:xfrm>
+            <a:off x="233172" y="960120"/>
+            <a:ext cx="8778240" cy="858289"/>
+          </a:xfrm>
+        </p:spPr>
+        <p:txBody>
+          <a:bodyPr>
+            <a:normAutofit/>
+          </a:bodyPr>
+          <a:lstStyle/>
+          <a:p>
+            <a:pPr marL="0" indent="0">
+              <a:spcBef>
+                <a:spcPts val="300"/>
+              </a:spcBef>
+              <a:spcAft>
+                <a:spcPts val="300"/>
+              </a:spcAft>
+              <a:buNone/>
+            </a:pPr>
+            <a:r>
+              <a:rPr sz="1400" b="0">
+                <a:solidFill>
+                  <a:srgbClr val="000000"/>
+                </a:solidFill>
+                <a:latin typeface="맑은 고딕"/>
+                <a:ea typeface="맑은 고딕"/>
+              </a:rPr>
+              <a:t>생필품을 고객이 정한 주기로 배송하는 </a:t>
+            </a:r>
+            <a:r>
+              <a:rPr sz="1400" b="1">
+                <a:solidFill>
+                  <a:srgbClr val="000000"/>
+                </a:solidFill>
+                <a:latin typeface="맑은 고딕"/>
+                <a:ea typeface="맑은 고딕"/>
+              </a:rPr>
+              <a:t>정기배송 서비스</a:t>
+            </a:r>
+            <a:r>
+              <a:rPr sz="1400" b="0">
+                <a:solidFill>
+                  <a:srgbClr val="000000"/>
+                </a:solidFill>
+                <a:latin typeface="맑은 고딕"/>
+                <a:ea typeface="맑은 고딕"/>
+              </a:rPr>
+              <a:t>다. 고객은 상품·수량·배송 주기·첫 배송일·기간·배송지를 정해 신청하고, 일시불 또는 월별로 결제한다. 고객은 다음 배송을 취소하거나, 받은 상품을 반품하거나, 정기배송을 해지할 수 있다. 상품·결제·배송은 각각 외부 시스템이 맡는다.</a:t>
+            </a:r>
+          </a:p>
+        </p:txBody>
+      </p:sp>
+      <p:sp>
+        <p:nvSpPr>
+          <p:cNvPr id="10" name="내용 개체 틀 7">
+            <a:extLst>
+              <a:ext uri="{FF2B5EF4-FFF2-40B4-BE49-F238E27FC236}">
+                <a16:creationId xmlns:a16="http://schemas.microsoft.com/office/drawing/2014/main" id="{BEBA2C4A-B0BF-F2E4-EA6E-614C99CBA184}"/>
+              </a:ext>
+            </a:extLst>
+          </p:cNvPr>
+          <p:cNvSpPr>
+            <a:spLocks noGrp="1"/>
+          </p:cNvSpPr>
+          <p:nvPr>
+            <p:ph idx="1"/>
+          </p:nvPr>
+        </p:nvSpPr>
+        <p:spPr>
+          <a:xfrm>
+            <a:off x="4572000" y="1818409"/>
+            <a:ext cx="4439412" cy="4664687"/>
+          </a:xfrm>
+        </p:spPr>
+        <p:txBody>
+          <a:bodyPr>
+            <a:normAutofit/>
+          </a:bodyPr>
+          <a:lstStyle/>
+          <a:p>
+            <a:pPr lvl="2" marL="228600" indent="-182880">
+              <a:spcBef>
+                <a:spcPts val="300"/>
+              </a:spcBef>
+              <a:spcAft>
+                <a:spcPts val="300"/>
               </a:spcAft>
               <a:buSzPct val="90000"/>
               <a:buFont typeface="Wingdings" pitchFamily="2" charset="2"/>
               <a:buChar char=""/>
             </a:pPr>
             <a:r>
-              <a:rPr sz="1800" b="1">
-                <a:solidFill>
-                  <a:srgbClr val="000000"/>
-                </a:solidFill>
-                <a:latin typeface="맑은 고딕"/>
-                <a:ea typeface="맑은 고딕"/>
-              </a:rPr>
-              <a:t>제약</a:t>
-            </a:r>
-            <a:r>
-              <a:rPr sz="1800" b="0">
-                <a:solidFill>
-                  <a:srgbClr val="000000"/>
-                </a:solidFill>
-                <a:latin typeface="맑은 고딕"/>
-                <a:ea typeface="맑은 고딕"/>
-              </a:rPr>
-              <a:t> —</a:t>
-            </a:r>
-            <a:r>
-              <a:rPr sz="1600" b="0">
-                <a:solidFill>
-                  <a:srgbClr val="000000"/>
-                </a:solidFill>
-                <a:latin typeface="맑은 고딕"/>
-                <a:ea typeface="맑은 고딕"/>
-              </a:rPr>
-              <a:t> 배송 시작 후 일반 취소 불가</a:t>
-            </a:r>
-          </a:p>
-          <a:p>
-            <a:pPr lvl="2" marL="723900" indent="-368300">
+              <a:rPr sz="1400" b="1">
+                <a:solidFill>
+                  <a:srgbClr val="000000"/>
+                </a:solidFill>
+                <a:latin typeface="맑은 고딕"/>
+                <a:ea typeface="맑은 고딕"/>
+              </a:rPr>
+              <a:t>업무 규칙: 청구 실패·취소·반품·해지</a:t>
+            </a:r>
+          </a:p>
+          <a:p>
+            <a:pPr lvl="3" marL="457200" indent="-182880">
               <a:spcBef>
-                <a:spcPts val="600"/>
+                <a:spcPts val="300"/>
               </a:spcBef>
               <a:spcAft>
-                <a:spcPts val="600"/>
+                <a:spcPts val="300"/>
+              </a:spcAft>
+              <a:buSzPct val="90000"/>
+              <a:buFont typeface="Wingdings" pitchFamily="2" charset="2"/>
+              <a:buChar char=""/>
+            </a:pPr>
+            <a:r>
+              <a:rPr sz="1200" b="1">
+                <a:solidFill>
+                  <a:srgbClr val="000000"/>
+                </a:solidFill>
+                <a:latin typeface="맑은 고딕"/>
+                <a:ea typeface="맑은 고딕"/>
+              </a:rPr>
+              <a:t>R7 청구 실패</a:t>
+            </a:r>
+            <a:r>
+              <a:rPr sz="1200" b="0">
+                <a:solidFill>
+                  <a:srgbClr val="000000"/>
+                </a:solidFill>
+                <a:latin typeface="맑은 고딕"/>
+                <a:ea typeface="맑은 고딕"/>
+              </a:rPr>
+              <a:t> —</a:t>
+            </a:r>
+            <a:r>
+              <a:rPr sz="1000" b="0">
+                <a:solidFill>
+                  <a:srgbClr val="000000"/>
+                </a:solidFill>
+                <a:latin typeface="맑은 고딕"/>
+                <a:ea typeface="맑은 고딕"/>
+              </a:rPr>
+              <a:t> 3일 동안 매일 다시 청구하고, 그래도 실패하면 정지하고 고객에게 알린다.</a:t>
+            </a:r>
+          </a:p>
+          <a:p>
+            <a:pPr lvl="3" marL="457200" indent="-182880">
+              <a:spcBef>
+                <a:spcPts val="300"/>
+              </a:spcBef>
+              <a:spcAft>
+                <a:spcPts val="300"/>
+              </a:spcAft>
+              <a:buSzPct val="90000"/>
+              <a:buFont typeface="Wingdings" pitchFamily="2" charset="2"/>
+              <a:buChar char=""/>
+            </a:pPr>
+            <a:r>
+              <a:rPr sz="1200" b="1">
+                <a:solidFill>
+                  <a:srgbClr val="000000"/>
+                </a:solidFill>
+                <a:latin typeface="맑은 고딕"/>
+                <a:ea typeface="맑은 고딕"/>
+              </a:rPr>
+              <a:t>R8 취소</a:t>
+            </a:r>
+            <a:r>
+              <a:rPr sz="1200" b="0">
+                <a:solidFill>
+                  <a:srgbClr val="000000"/>
+                </a:solidFill>
+                <a:latin typeface="맑은 고딕"/>
+                <a:ea typeface="맑은 고딕"/>
+              </a:rPr>
+              <a:t> —</a:t>
+            </a:r>
+            <a:r>
+              <a:rPr sz="1000" b="0">
+                <a:solidFill>
+                  <a:srgbClr val="000000"/>
+                </a:solidFill>
+                <a:latin typeface="맑은 고딕"/>
+                <a:ea typeface="맑은 고딕"/>
+              </a:rPr>
+              <a:t> 배송 24시간 전까지, 연속 2회까지</a:t>
+            </a:r>
+          </a:p>
+          <a:p>
+            <a:pPr lvl="4" marL="685800" indent="-182880">
+              <a:spcBef>
+                <a:spcPts val="300"/>
+              </a:spcBef>
+              <a:spcAft>
+                <a:spcPts val="300"/>
+              </a:spcAft>
+              <a:buFont typeface="Wingdings" pitchFamily="2" charset="2"/>
+              <a:buChar char="l"/>
+            </a:pPr>
+            <a:r>
+              <a:rPr sz="1100" b="0">
+                <a:solidFill>
+                  <a:srgbClr val="000000"/>
+                </a:solidFill>
+                <a:latin typeface="맑은 고딕"/>
+                <a:ea typeface="맑은 고딕"/>
+              </a:rPr>
+              <a:t>청구한 회차는 </a:t>
+            </a:r>
+            <a:r>
+              <a:rPr sz="1100" b="1">
+                <a:solidFill>
+                  <a:srgbClr val="000000"/>
+                </a:solidFill>
+                <a:latin typeface="맑은 고딕"/>
+                <a:ea typeface="맑은 고딕"/>
+              </a:rPr>
+              <a:t>결제 수단으로 환불</a:t>
+            </a:r>
+            <a:r>
+              <a:rPr sz="1100" b="0">
+                <a:solidFill>
+                  <a:srgbClr val="000000"/>
+                </a:solidFill>
+                <a:latin typeface="맑은 고딕"/>
+                <a:ea typeface="맑은 고딕"/>
+              </a:rPr>
+              <a:t>하고, 청구 전이면 </a:t>
+            </a:r>
+            <a:r>
+              <a:rPr sz="1100" b="1">
+                <a:solidFill>
+                  <a:srgbClr val="000000"/>
+                </a:solidFill>
+                <a:latin typeface="맑은 고딕"/>
+                <a:ea typeface="맑은 고딕"/>
+              </a:rPr>
+              <a:t>청구에서 뺀다</a:t>
+            </a:r>
+            <a:r>
+              <a:rPr sz="1100" b="0">
+                <a:solidFill>
+                  <a:srgbClr val="000000"/>
+                </a:solidFill>
+                <a:latin typeface="맑은 고딕"/>
+                <a:ea typeface="맑은 고딕"/>
+              </a:rPr>
+              <a:t>.</a:t>
+            </a:r>
+          </a:p>
+          <a:p>
+            <a:pPr lvl="3" marL="457200" indent="-182880">
+              <a:spcBef>
+                <a:spcPts val="300"/>
+              </a:spcBef>
+              <a:spcAft>
+                <a:spcPts val="300"/>
+              </a:spcAft>
+              <a:buSzPct val="90000"/>
+              <a:buFont typeface="Wingdings" pitchFamily="2" charset="2"/>
+              <a:buChar char=""/>
+            </a:pPr>
+            <a:r>
+              <a:rPr sz="1200" b="1">
+                <a:solidFill>
+                  <a:srgbClr val="000000"/>
+                </a:solidFill>
+                <a:latin typeface="맑은 고딕"/>
+                <a:ea typeface="맑은 고딕"/>
+              </a:rPr>
+              <a:t>R9 반품 대상</a:t>
+            </a:r>
+            <a:r>
+              <a:rPr sz="1200" b="0">
+                <a:solidFill>
+                  <a:srgbClr val="000000"/>
+                </a:solidFill>
+                <a:latin typeface="맑은 고딕"/>
+                <a:ea typeface="맑은 고딕"/>
+              </a:rPr>
+              <a:t> —</a:t>
+            </a:r>
+            <a:r>
+              <a:rPr sz="1000" b="0">
+                <a:solidFill>
+                  <a:srgbClr val="000000"/>
+                </a:solidFill>
+                <a:latin typeface="맑은 고딕"/>
+                <a:ea typeface="맑은 고딕"/>
+              </a:rPr>
+              <a:t> 개봉하지 않은 공산품, 받은 날부터 7일 이내</a:t>
+            </a:r>
+          </a:p>
+          <a:p>
+            <a:pPr lvl="4" marL="685800" indent="-182880">
+              <a:spcBef>
+                <a:spcPts val="300"/>
+              </a:spcBef>
+              <a:spcAft>
+                <a:spcPts val="300"/>
+              </a:spcAft>
+              <a:buFont typeface="Wingdings" pitchFamily="2" charset="2"/>
+              <a:buChar char="l"/>
+            </a:pPr>
+            <a:r>
+              <a:rPr sz="1100" b="1">
+                <a:solidFill>
+                  <a:srgbClr val="000000"/>
+                </a:solidFill>
+                <a:latin typeface="맑은 고딕"/>
+                <a:ea typeface="맑은 고딕"/>
+              </a:rPr>
+              <a:t>식품은 불가</a:t>
+            </a:r>
+            <a:r>
+              <a:rPr sz="1100" b="0">
+                <a:solidFill>
+                  <a:srgbClr val="000000"/>
+                </a:solidFill>
+                <a:latin typeface="맑은 고딕"/>
+                <a:ea typeface="맑은 고딕"/>
+              </a:rPr>
+              <a:t>. 불량·오배송은 종류·개봉과 관계없이 가능하다.</a:t>
+            </a:r>
+          </a:p>
+          <a:p>
+            <a:pPr lvl="3" marL="457200" indent="-182880">
+              <a:spcBef>
+                <a:spcPts val="300"/>
+              </a:spcBef>
+              <a:spcAft>
+                <a:spcPts val="300"/>
+              </a:spcAft>
+              <a:buSzPct val="90000"/>
+              <a:buFont typeface="Wingdings" pitchFamily="2" charset="2"/>
+              <a:buChar char=""/>
+            </a:pPr>
+            <a:r>
+              <a:rPr sz="1200" b="1">
+                <a:solidFill>
+                  <a:srgbClr val="000000"/>
+                </a:solidFill>
+                <a:latin typeface="맑은 고딕"/>
+                <a:ea typeface="맑은 고딕"/>
+              </a:rPr>
+              <a:t>R10 반품 절차</a:t>
+            </a:r>
+            <a:r>
+              <a:rPr sz="1200" b="0">
+                <a:solidFill>
+                  <a:srgbClr val="000000"/>
+                </a:solidFill>
+                <a:latin typeface="맑은 고딕"/>
+                <a:ea typeface="맑은 고딕"/>
+              </a:rPr>
+              <a:t> —</a:t>
+            </a:r>
+            <a:r>
+              <a:rPr sz="1000" b="0">
+                <a:solidFill>
+                  <a:srgbClr val="000000"/>
+                </a:solidFill>
+                <a:latin typeface="맑은 고딕"/>
+                <a:ea typeface="맑은 고딕"/>
+              </a:rPr>
+              <a:t> 배송 시스템이 회수하고, 확인 후 3영업일 안에 결제 수단으로 환불한다.</a:t>
+            </a:r>
+          </a:p>
+          <a:p>
+            <a:pPr lvl="4" marL="685800" indent="-182880">
+              <a:spcBef>
+                <a:spcPts val="300"/>
+              </a:spcBef>
+              <a:spcAft>
+                <a:spcPts val="300"/>
+              </a:spcAft>
+              <a:buFont typeface="Wingdings" pitchFamily="2" charset="2"/>
+              <a:buChar char="l"/>
+            </a:pPr>
+            <a:r>
+              <a:rPr sz="1100" b="1">
+                <a:solidFill>
+                  <a:srgbClr val="000000"/>
+                </a:solidFill>
+                <a:latin typeface="맑은 고딕"/>
+                <a:ea typeface="맑은 고딕"/>
+              </a:rPr>
+              <a:t>단순 변심</a:t>
+            </a:r>
+            <a:r>
+              <a:rPr sz="1100" b="0">
+                <a:solidFill>
+                  <a:srgbClr val="000000"/>
+                </a:solidFill>
+                <a:latin typeface="맑은 고딕"/>
+                <a:ea typeface="맑은 고딕"/>
+              </a:rPr>
+              <a:t>은 반품 배송비 3,000원을 빼고 환불한다.</a:t>
+            </a:r>
+          </a:p>
+          <a:p>
+            <a:pPr lvl="3" marL="457200" indent="-182880">
+              <a:spcBef>
+                <a:spcPts val="300"/>
+              </a:spcBef>
+              <a:spcAft>
+                <a:spcPts val="300"/>
+              </a:spcAft>
+              <a:buSzPct val="90000"/>
+              <a:buFont typeface="Wingdings" pitchFamily="2" charset="2"/>
+              <a:buChar char=""/>
+            </a:pPr>
+            <a:r>
+              <a:rPr sz="1200" b="1">
+                <a:solidFill>
+                  <a:srgbClr val="000000"/>
+                </a:solidFill>
+                <a:latin typeface="맑은 고딕"/>
+                <a:ea typeface="맑은 고딕"/>
+              </a:rPr>
+              <a:t>R11 해지</a:t>
+            </a:r>
+            <a:r>
+              <a:rPr sz="1200" b="0">
+                <a:solidFill>
+                  <a:srgbClr val="000000"/>
+                </a:solidFill>
+                <a:latin typeface="맑은 고딕"/>
+                <a:ea typeface="맑은 고딕"/>
+              </a:rPr>
+              <a:t> —</a:t>
+            </a:r>
+            <a:r>
+              <a:rPr sz="1000" b="0">
+                <a:solidFill>
+                  <a:srgbClr val="000000"/>
+                </a:solidFill>
+                <a:latin typeface="맑은 고딕"/>
+                <a:ea typeface="맑은 고딕"/>
+              </a:rPr>
+              <a:t> 언제든, 위약금 없음</a:t>
+            </a:r>
+          </a:p>
+          <a:p>
+            <a:pPr lvl="4" marL="685800" indent="-182880">
+              <a:spcBef>
+                <a:spcPts val="300"/>
+              </a:spcBef>
+              <a:spcAft>
+                <a:spcPts val="300"/>
+              </a:spcAft>
+              <a:buFont typeface="Wingdings" pitchFamily="2" charset="2"/>
+              <a:buChar char="l"/>
+            </a:pPr>
+            <a:r>
+              <a:rPr sz="1100" b="0">
+                <a:solidFill>
+                  <a:srgbClr val="000000"/>
+                </a:solidFill>
+                <a:latin typeface="맑은 고딕"/>
+                <a:ea typeface="맑은 고딕"/>
+              </a:rPr>
+              <a:t>24시간 전이 지난 회차는 </a:t>
+            </a:r>
+            <a:r>
+              <a:rPr sz="1100" b="1">
+                <a:solidFill>
+                  <a:srgbClr val="000000"/>
+                </a:solidFill>
+                <a:latin typeface="맑은 고딕"/>
+                <a:ea typeface="맑은 고딕"/>
+              </a:rPr>
+              <a:t>배송</a:t>
+            </a:r>
+            <a:r>
+              <a:rPr sz="1100" b="0">
+                <a:solidFill>
+                  <a:srgbClr val="000000"/>
+                </a:solidFill>
+                <a:latin typeface="맑은 고딕"/>
+                <a:ea typeface="맑은 고딕"/>
+              </a:rPr>
+              <a:t>하고, 청구했지만 배송되지 않은 회차는 </a:t>
+            </a:r>
+            <a:r>
+              <a:rPr sz="1100" b="1">
+                <a:solidFill>
+                  <a:srgbClr val="000000"/>
+                </a:solidFill>
+                <a:latin typeface="맑은 고딕"/>
+                <a:ea typeface="맑은 고딕"/>
+              </a:rPr>
+              <a:t>환불</a:t>
+            </a:r>
+            <a:r>
+              <a:rPr sz="1100" b="0">
+                <a:solidFill>
+                  <a:srgbClr val="000000"/>
+                </a:solidFill>
+                <a:latin typeface="맑은 고딕"/>
+                <a:ea typeface="맑은 고딕"/>
+              </a:rPr>
+              <a:t>한다. 이후 청구는 멈춘다.</a:t>
+            </a:r>
+          </a:p>
+          <a:p>
+            <a:pPr lvl="2" marL="228600" indent="-182880">
+              <a:spcBef>
+                <a:spcPts val="300"/>
+              </a:spcBef>
+              <a:spcAft>
+                <a:spcPts val="300"/>
               </a:spcAft>
               <a:buSzPct val="90000"/>
               <a:buFont typeface="Wingdings" pitchFamily="2" charset="2"/>
               <a:buChar char=""/>
             </a:pPr>
             <a:r>
-              <a:rPr sz="1800" b="1">
-                <a:solidFill>
-                  <a:srgbClr val="000000"/>
-                </a:solidFill>
-                <a:latin typeface="맑은 고딕"/>
-                <a:ea typeface="맑은 고딕"/>
-              </a:rPr>
-              <a:t>해결책</a:t>
-            </a:r>
-            <a:r>
-              <a:rPr sz="1800" b="0">
-                <a:solidFill>
-                  <a:srgbClr val="000000"/>
-                </a:solidFill>
-                <a:latin typeface="맑은 고딕"/>
-                <a:ea typeface="맑은 고딕"/>
-              </a:rPr>
-              <a:t> —</a:t>
-            </a:r>
-            <a:r>
-              <a:rPr sz="1600" b="0">
-                <a:solidFill>
-                  <a:srgbClr val="000000"/>
-                </a:solidFill>
-                <a:latin typeface="맑은 고딕"/>
-                <a:ea typeface="맑은 고딕"/>
-              </a:rPr>
-              <a:t> 취소 버튼</a:t>
-            </a:r>
-            <a:r>
-              <a:rPr sz="1200" b="0">
-                <a:solidFill>
-                  <a:srgbClr val="000000"/>
-                </a:solidFill>
-                <a:latin typeface="맑은 고딕"/>
-                <a:ea typeface="맑은 고딕"/>
-              </a:rPr>
-              <a:t>(다른 해결책도 가능. 예: 고객센터 취소 요청)</a:t>
-            </a:r>
-          </a:p>
-          <a:p>
-            <a:pPr lvl="2" marL="723900" indent="-368300">
+              <a:rPr sz="1400" b="1">
+                <a:solidFill>
+                  <a:srgbClr val="000000"/>
+                </a:solidFill>
+                <a:latin typeface="맑은 고딕"/>
+                <a:ea typeface="맑은 고딕"/>
+              </a:rPr>
+              <a:t>외부 시스템</a:t>
+            </a:r>
+          </a:p>
+          <a:p>
+            <a:pPr lvl="3" marL="457200" indent="-182880">
               <a:spcBef>
-                <a:spcPts val="600"/>
+                <a:spcPts val="300"/>
               </a:spcBef>
               <a:spcAft>
-                <a:spcPts val="600"/>
+                <a:spcPts val="300"/>
+              </a:spcAft>
+              <a:buSzPct val="90000"/>
+              <a:buFont typeface="Wingdings" pitchFamily="2" charset="2"/>
+              <a:buChar char=""/>
+            </a:pPr>
+            <a:r>
+              <a:rPr sz="1200" b="1">
+                <a:solidFill>
+                  <a:srgbClr val="000000"/>
+                </a:solidFill>
+                <a:latin typeface="맑은 고딕"/>
+                <a:ea typeface="맑은 고딕"/>
+              </a:rPr>
+              <a:t>상품</a:t>
+            </a:r>
+            <a:r>
+              <a:rPr sz="1200" b="0">
+                <a:solidFill>
+                  <a:srgbClr val="000000"/>
+                </a:solidFill>
+                <a:latin typeface="맑은 고딕"/>
+                <a:ea typeface="맑은 고딕"/>
+              </a:rPr>
+              <a:t> —</a:t>
+            </a:r>
+            <a:r>
+              <a:rPr sz="1000" b="0">
+                <a:solidFill>
+                  <a:srgbClr val="000000"/>
+                </a:solidFill>
+                <a:latin typeface="맑은 고딕"/>
+                <a:ea typeface="맑은 고딕"/>
+              </a:rPr>
+              <a:t> 상품 정보·가격, 상품 종류</a:t>
+            </a:r>
+            <a:r>
+              <a:rPr sz="800" b="0">
+                <a:solidFill>
+                  <a:srgbClr val="000000"/>
+                </a:solidFill>
+                <a:latin typeface="맑은 고딕"/>
+                <a:ea typeface="맑은 고딕"/>
+              </a:rPr>
+              <a:t>(식품·공산품)</a:t>
+            </a:r>
+          </a:p>
+          <a:p>
+            <a:pPr lvl="3" marL="457200" indent="-182880">
+              <a:spcBef>
+                <a:spcPts val="300"/>
+              </a:spcBef>
+              <a:spcAft>
+                <a:spcPts val="300"/>
+              </a:spcAft>
+              <a:buSzPct val="90000"/>
+              <a:buFont typeface="Wingdings" pitchFamily="2" charset="2"/>
+              <a:buChar char=""/>
+            </a:pPr>
+            <a:r>
+              <a:rPr sz="1200" b="1">
+                <a:solidFill>
+                  <a:srgbClr val="000000"/>
+                </a:solidFill>
+                <a:latin typeface="맑은 고딕"/>
+                <a:ea typeface="맑은 고딕"/>
+              </a:rPr>
+              <a:t>결제</a:t>
+            </a:r>
+            <a:r>
+              <a:rPr sz="1200" b="0">
+                <a:solidFill>
+                  <a:srgbClr val="000000"/>
+                </a:solidFill>
+                <a:latin typeface="맑은 고딕"/>
+                <a:ea typeface="맑은 고딕"/>
+              </a:rPr>
+              <a:t> —</a:t>
+            </a:r>
+            <a:r>
+              <a:rPr sz="1000" b="0">
+                <a:solidFill>
+                  <a:srgbClr val="000000"/>
+                </a:solidFill>
+                <a:latin typeface="맑은 고딕"/>
+                <a:ea typeface="맑은 고딕"/>
+              </a:rPr>
+              <a:t> 결제·청구·환불</a:t>
+            </a:r>
+          </a:p>
+          <a:p>
+            <a:pPr lvl="3" marL="457200" indent="-182880">
+              <a:spcBef>
+                <a:spcPts val="300"/>
+              </a:spcBef>
+              <a:spcAft>
+                <a:spcPts val="300"/>
+              </a:spcAft>
+              <a:buSzPct val="90000"/>
+              <a:buFont typeface="Wingdings" pitchFamily="2" charset="2"/>
+              <a:buChar char=""/>
+            </a:pPr>
+            <a:r>
+              <a:rPr sz="1200" b="1">
+                <a:solidFill>
+                  <a:srgbClr val="000000"/>
+                </a:solidFill>
+                <a:latin typeface="맑은 고딕"/>
+                <a:ea typeface="맑은 고딕"/>
+              </a:rPr>
+              <a:t>배송</a:t>
+            </a:r>
+            <a:r>
+              <a:rPr sz="1200" b="0">
+                <a:solidFill>
+                  <a:srgbClr val="000000"/>
+                </a:solidFill>
+                <a:latin typeface="맑은 고딕"/>
+                <a:ea typeface="맑은 고딕"/>
+              </a:rPr>
+              <a:t> —</a:t>
+            </a:r>
+            <a:r>
+              <a:rPr sz="1000" b="0">
+                <a:solidFill>
+                  <a:srgbClr val="000000"/>
+                </a:solidFill>
+                <a:latin typeface="맑은 고딕"/>
+                <a:ea typeface="맑은 고딕"/>
+              </a:rPr>
+              <a:t> 배송, 반품 회수</a:t>
+            </a:r>
+          </a:p>
+          <a:p>
+            <a:pPr lvl="2" marL="228600" indent="-182880">
+              <a:spcBef>
+                <a:spcPts val="300"/>
+              </a:spcBef>
+              <a:spcAft>
+                <a:spcPts val="300"/>
               </a:spcAft>
               <a:buSzPct val="90000"/>
               <a:buFont typeface="Wingdings" pitchFamily="2" charset="2"/>
               <a:buChar char=""/>
             </a:pPr>
             <a:r>
-              <a:rPr sz="1800" b="1">
-                <a:solidFill>
-                  <a:srgbClr val="000000"/>
-                </a:solidFill>
-                <a:latin typeface="맑은 고딕"/>
-                <a:ea typeface="맑은 고딕"/>
-              </a:rPr>
-              <a:t>이벤트</a:t>
-            </a:r>
-            <a:r>
-              <a:rPr sz="1800" b="0">
+              <a:rPr sz="1400" b="1">
+                <a:solidFill>
+                  <a:srgbClr val="000000"/>
+                </a:solidFill>
+                <a:latin typeface="맑은 고딕"/>
+                <a:ea typeface="맑은 고딕"/>
+              </a:rPr>
+              <a:t>미확정 항목</a:t>
+            </a:r>
+            <a:r>
+              <a:rPr sz="1400" b="0">
                 <a:solidFill>
                   <a:srgbClr val="000000"/>
                 </a:solidFill>
@@ -36261,57 +37819,14 @@
               <a:t> —</a:t>
             </a:r>
             <a:r>
-              <a:rPr sz="1600" b="0">
-                <a:solidFill>
-                  <a:srgbClr val="000000"/>
-                </a:solidFill>
-                <a:latin typeface="맑은 고딕"/>
-                <a:ea typeface="맑은 고딕"/>
-              </a:rPr>
-              <a:t> 고객이 배송 시작 전 주문을 취소한다 → 주문이 취소되고 결제 금액이 환불된다</a:t>
-            </a:r>
-          </a:p>
-          <a:p>
-            <a:pPr lvl="2" marL="723900" indent="-368300">
-              <a:spcBef>
-                <a:spcPts val="600"/>
-              </a:spcBef>
-              <a:spcAft>
-                <a:spcPts val="600"/>
-              </a:spcAft>
-              <a:buSzPct val="90000"/>
-              <a:buFont typeface="Wingdings" pitchFamily="2" charset="2"/>
-              <a:buChar char=""/>
-            </a:pPr>
-            <a:r>
-              <a:rPr sz="1800" b="1">
-                <a:solidFill>
-                  <a:srgbClr val="000000"/>
-                </a:solidFill>
-                <a:latin typeface="맑은 고딕"/>
-                <a:ea typeface="맑은 고딕"/>
-              </a:rPr>
-              <a:t>확인 질문</a:t>
-            </a:r>
-            <a:r>
-              <a:rPr sz="1800" b="0">
-                <a:solidFill>
-                  <a:srgbClr val="000000"/>
-                </a:solidFill>
-                <a:latin typeface="맑은 고딕"/>
-                <a:ea typeface="맑은 고딕"/>
-              </a:rPr>
-              <a:t> —</a:t>
-            </a:r>
-            <a:r>
-              <a:rPr sz="1600" b="0">
-                <a:solidFill>
-                  <a:srgbClr val="000000"/>
-                </a:solidFill>
-                <a:latin typeface="맑은 고딕"/>
-                <a:ea typeface="맑은 고딕"/>
-              </a:rPr>
-              <a:t> 현재 취소 경로가 없는가, 아니면 찾기 어려운가?</a:t>
+              <a:rPr sz="1200" b="0">
+                <a:solidFill>
+                  <a:srgbClr val="000000"/>
+                </a:solidFill>
+                <a:latin typeface="맑은 고딕"/>
+                <a:ea typeface="맑은 고딕"/>
+              </a:rPr>
+              <a:t> 없음</a:t>
             </a:r>
           </a:p>
         </p:txBody>

</xml_diff>

<commit_message>
feat(ooad): S06 session, glossary as the naming source, English design names
- S06 "분석 모델에서 설계 모델로": 38 topics, verified citations (Larman, Evans),
  initial design of order cancellation, code/s06 with meaning-preservation tests,
  practice 6 (mapping table, DCD, design sequence, supplement)
- Glossary defined in S02 (term, definition, term-level business rules, English
  name; relation to DD, XP metaphor, UL, naming rules) and recalled in S03-S06
- Analysis stays Korean; design diagrams and code from S05 use the glossary's
  English names and naming rules (code/s05, code/s06 rewritten)
- course-design: S06 anchor message, 영한 용어집과 명명 규칙, design identifiers
- Guides: glossary/naming rules; production enum check maps Korean and English
  enums through the course glossary (with test)
- Instructor-note citation evidence completed in S01-S03

Co-Authored-By: Claude Opus 5.5 <noreply@anthropic.com>
</commit_message>
<xml_diff>
--- a/courses/ooad/sessions/s01.pptx
+++ b/courses/ooad/sessions/s01.pptx
@@ -581,7 +581,7 @@
             <a:pPr lvl="0"/>
             <a:r>
               <a:rPr lang="ko-KR" sz="1200"/>
-              <a:t>화면·기술 요소를 요구에 섞는 잘못된 관행은 "02. 요구 분석과 유스케이스"의 「36. 잘못된 관행 — 화면·기술 요소」에서 다룬다.</a:t>
+              <a:t>화면·기술 요소를 요구에 섞는 잘못된 관행은 "02. 요구 분석과 유스케이스"의 「37. 잘못된 관행 — 화면·기술 요소」에서 다룬다.</a:t>
             </a:r>
           </a:p>
         </p:txBody>
@@ -1228,7 +1228,7 @@
             <a:pPr lvl="0"/>
             <a:r>
               <a:rPr lang="ko-KR" sz="1200"/>
-              <a:t>SSD와 시스템 오퍼레이션은 "02. 요구 분석과 유스케이스"의 「40. 시스템 시퀀스 다이어그램」·「43. 정제된 SSD」에서 다룬다.</a:t>
+              <a:t>SSD와 시스템 오퍼레이션은 "02. 요구 분석과 유스케이스"의 「41. 시스템 시퀀스 다이어그램」·「44. 정제된 SSD」에서 다룬다.</a:t>
             </a:r>
           </a:p>
         </p:txBody>
@@ -1507,7 +1507,7 @@
             <a:pPr lvl="0"/>
             <a:r>
               <a:rPr lang="ko-KR" sz="1200"/>
-              <a:t>요구 예시와 행위 주도 개발은 "02. 요구 분석과 유스케이스"의 「50. 행위 주도 개발」에서 다룬다.</a:t>
+              <a:t>요구 예시와 행위 주도 개발은 "02. 요구 분석과 유스케이스"의 「51. 행위 주도 개발」에서 다룬다.</a:t>
             </a:r>
           </a:p>
         </p:txBody>
@@ -1568,7 +1568,7 @@
             <a:pPr lvl="0"/>
             <a:r>
               <a:rPr lang="ko-KR" sz="1200"/>
-              <a:t>아키텍처를 문서나 다이어그램 자체와 동일시하지 않는다. 위 정의는 ISO/IEC/IEEE 42010 정의를 그대로 재수록한 NIST 공식 용어집에서 확인했다. ISO 표준 본문 자체를 직접 확인한 것은 아니다.</a:t>
+              <a:t>아키텍처를 문서나 다이어그램 자체와 동일시하지 않는다. 위 정의의 ISO/IEC/IEEE 42010 표준 본문은 미확인이다(www). 재인용처: 42010 정의를 그대로 재수록한 NIST 공식 용어집(CSRC Glossary, "architecture")에서 영어 문구를 확인했다.</a:t>
             </a:r>
           </a:p>
         </p:txBody>
@@ -2398,7 +2398,14 @@
             <a:pPr lvl="0"/>
             <a:r>
               <a:rPr lang="ko-KR" sz="1200"/>
-              <a:t>인용 근거: Karl Wiegers, "When Bad Requirements Happen to Nice People", Jama Software 블로그(2013). 이 글은 수치의 출처를 밝히지 않는다.</a:t>
+              <a:t>재작업 인용 근거: Barry Boehm·Victor R. Basili, ["Software Defect Reduction Top 10 List"](https://www.cs.umd.edu/users/basili/publications/journals/J81.pdf), *IEEE Computer* 34(1):135–137, 2001, 항목 TWO 원문 확인. 같은 항목은 재작업을 "더 일찍 발견해 더 싸게 고칠 수 있었던 문제에 쓴 노력"으로 정의한다.</a:t>
+            </a:r>
+          </a:p>
+          <a:p>
+            <a:pPr lvl="0"/>
+            <a:r>
+              <a:rPr lang="ko-KR" sz="1200"/>
+              <a:t>요구사항 오류 인용 근거: Karl Wiegers, "When Bad Requirements Happen to Nice People", Jama Software 블로그(2013). 이 글은 수치의 출처를 밝히지 않는다.</a:t>
             </a:r>
           </a:p>
           <a:p>

</xml_diff>

<commit_message>
Align OOAD sessions 1-4 and authoring guidance
</commit_message>
<xml_diff>
--- a/courses/ooad/sessions/s01.pptx
+++ b/courses/ooad/sessions/s01.pptx
@@ -14209,7 +14209,7 @@
                 <a:latin typeface="맑은 고딕"/>
                 <a:ea typeface="맑은 고딕"/>
               </a:rPr>
-              <a:t>이 세션은 </a:t>
+              <a:t>객체지향 분석·설계는 </a:t>
             </a:r>
             <a:r>
               <a:rPr sz="1800" b="1">
@@ -14229,7 +14229,7 @@
                 <a:latin typeface="맑은 고딕"/>
                 <a:ea typeface="맑은 고딕"/>
               </a:rPr>
-              <a:t>하고, 요구가 </a:t>
+              <a:t>하고, 요구를 </a:t>
             </a:r>
             <a:r>
               <a:rPr sz="1800" b="1">
@@ -14249,7 +14249,7 @@
                 <a:latin typeface="맑은 고딕"/>
                 <a:ea typeface="맑은 고딕"/>
               </a:rPr>
-              <a:t>로 이어지는 객체지향 분석·설계의 판단 흐름을 살펴본다.</a:t>
+              <a:t>로 이어 가는 판단의 흐름이다.</a:t>
             </a:r>
           </a:p>
           <a:p>
@@ -34041,7 +34041,7 @@
                 <a:latin typeface="맑은 고딕"/>
                 <a:ea typeface="맑은 고딕"/>
               </a:rPr>
-              <a:t>이 세션은 문제를 이해하고 해결책의 책임과 경계를 결정하는 </a:t>
+              <a:t>객체지향 분석·설계는 문제를 이해하고 해결책의 책임과 경계를 결정하는 </a:t>
             </a:r>
             <a:r>
               <a:rPr sz="1800" b="1">
@@ -34061,7 +34061,7 @@
                 <a:latin typeface="맑은 고딕"/>
                 <a:ea typeface="맑은 고딕"/>
               </a:rPr>
-              <a:t>을 코드·테스트까지 이어서 다뤘다.</a:t>
+              <a:t>을 코드·테스트까지 잇는다.</a:t>
             </a:r>
           </a:p>
           <a:p>

</xml_diff>

<commit_message>
feat(ooad): user stories, BDD and SDD overview in S02; answers to appendix
- S02: user story (3C, template, INVEST, slicing, bad stories), BDD
  (practices, Given-When-Then, Example Mapping), SDD overview and limits.
- 요구사항 명세서 -> 요구사항 정의서, 사용자 스토리 -> 유저 스토리.
- S06-S13: practice answers moved to the appendix; quotes fixed to match
  originals; question table cells end with "?"; S14 coordinated with the
  AI-native course.
- Legacy course designs (agile, ddd, devops, ...) marked as old drafts.

Co-Authored-By: Claude Opus 5.5 <noreply@anthropic.com>
</commit_message>
<xml_diff>
--- a/courses/ooad/sessions/s01.pptx
+++ b/courses/ooad/sessions/s01.pptx
@@ -1366,7 +1366,7 @@
             <a:pPr lvl="0"/>
             <a:r>
               <a:rPr lang="ko-KR" sz="1200"/>
-              <a:t>수용·거절 예시의 기대값으로 미확정 정책을 결정하지 않는다. 요구 예시의 상세는 "02. 요구 분석과 유스케이스"의 「51. 행위 주도 개발」에서 다룬다.</a:t>
+              <a:t>수용·거절 예시의 기대값으로 미확정 정책을 결정하지 않는다. 요구 예시의 상세는 "02. 요구 분석과 유스케이스"의 「56. Given-When-Then」에서 다룬다.</a:t>
             </a:r>
           </a:p>
         </p:txBody>
@@ -3075,7 +3075,7 @@
             <a:pPr lvl="0"/>
             <a:r>
               <a:rPr lang="ko-KR" sz="1200"/>
-              <a:t>이벤트 반응 목록, 유스케이스, 사용자 이야기, 도메인 이벤트가 모두 이벤트를 출발점으로 삼는다는 근거는 "02. 요구 분석과 유스케이스"의 「07. 이벤트 중심 요구」·「08. 이벤트 중심 기법」에서 다룬다.</a:t>
+              <a:t>이벤트 반응 목록, 유스케이스, 유저 스토리, 도메인 이벤트가 모두 이벤트를 출발점으로 삼는다는 근거는 "02. 요구 분석과 유스케이스"의 「07. 이벤트 중심 요구」·「08. 이벤트 중심 기법」에서 다룬다.</a:t>
             </a:r>
           </a:p>
           <a:p>
@@ -4765,7 +4765,7 @@
                 <a:latin typeface="맑은 고딕"/>
                 <a:ea typeface="맑은 고딕"/>
               </a:rPr>
-              <a:t> 요구사항 명세서</a:t>
+              <a:t> 요구사항 정의서</a:t>
             </a:r>
           </a:p>
           <a:p>
@@ -14457,7 +14457,7 @@
                 <a:latin typeface="맑은 고딕"/>
                 <a:ea typeface="맑은 고딕"/>
               </a:rPr>
-              <a:t>으로 이어질 질문을 알고 요구사항 명세서 초안을 검토한다.</a:t>
+              <a:t>으로 이어질 질문을 알고 요구사항 정의서 초안을 검토한다.</a:t>
             </a:r>
           </a:p>
         </p:txBody>
@@ -31225,7 +31225,7 @@
                 <a:latin typeface="맑은 고딕"/>
                 <a:ea typeface="맑은 고딕"/>
               </a:rPr>
-              <a:t>14. 실습 — 요구사항 명세서</a:t>
+              <a:t>14. 실습 — 요구사항 정의서</a:t>
             </a:r>
           </a:p>
         </p:txBody>
@@ -31398,7 +31398,7 @@
                 <a:latin typeface="맑은 고딕"/>
                 <a:ea typeface="맑은 고딕"/>
               </a:rPr>
-              <a:t>요구사항 명세서</a:t>
+              <a:t>요구사항 정의서</a:t>
             </a:r>
             <a:r>
               <a:rPr sz="1400" b="0">
@@ -31660,7 +31660,7 @@
                 <a:latin typeface="맑은 고딕"/>
                 <a:ea typeface="맑은 고딕"/>
               </a:rPr>
-              <a:t>"위 서비스 개요로 정기배송 시스템의 요구사항 명세서를 작성해줘. 기능 요구, 업무 규칙, 외부 시스템, 확인할 질문으로 나눠 정리해줘. 개요에 없는 내용은 추측하지 말고 </a:t>
+              <a:t>"위 서비스 개요로 정기배송 시스템의 요구사항 정의서를 작성해줘. 기능 요구, 업무 규칙, 외부 시스템, 확인할 질문으로 나눠 정리해줘. 개요에 없는 내용은 추측하지 말고 </a:t>
             </a:r>
             <a:r>
               <a:rPr sz="1200" b="1">
@@ -32112,7 +32112,7 @@
                 <a:latin typeface="맑은 고딕"/>
                 <a:ea typeface="맑은 고딕"/>
               </a:rPr>
-              <a:t> 확인할 질문이 남지 않은 요구사항 명세서. 실습 2의 입력이 됩니다.</a:t>
+              <a:t> 확인할 질문이 남지 않은 요구사항 정의서. 실습 2의 입력이 됩니다.</a:t>
             </a:r>
           </a:p>
         </p:txBody>
@@ -32740,7 +32740,7 @@
                 <a:latin typeface="맑은 고딕"/>
                 <a:ea typeface="맑은 고딕"/>
               </a:rPr>
-              <a:t>요구사항 명세서 </a:t>
+              <a:t>요구사항 정의서 </a:t>
             </a:r>
             <a:r>
               <a:rPr sz="1800" b="1">

</xml_diff>